<commit_message>
ok pour saisie des poids
</commit_message>
<xml_diff>
--- a/outillage.pptx
+++ b/outillage.pptx
@@ -5,11 +5,10 @@
     <p:sldMasterId id="2147483648" r:id="rId1"/>
   </p:sldMasterIdLst>
   <p:sldIdLst>
-    <p:sldId id="256" r:id="rId2"/>
+    <p:sldId id="257" r:id="rId2"/>
     <p:sldId id="259" r:id="rId3"/>
-    <p:sldId id="257" r:id="rId4"/>
-    <p:sldId id="258" r:id="rId5"/>
-    <p:sldId id="260" r:id="rId6"/>
+    <p:sldId id="258" r:id="rId4"/>
+    <p:sldId id="260" r:id="rId5"/>
   </p:sldIdLst>
   <p:sldSz cx="12192000" cy="6858000"/>
   <p:notesSz cx="6858000" cy="9144000"/>
@@ -263,7 +262,7 @@
           <a:p>
             <a:fld id="{D7B9B2F6-DB6D-6549-8947-FBFB6C213823}" type="datetimeFigureOut">
               <a:rPr lang="fr-FR" smtClean="0"/>
-              <a:t>20/10/2026</a:t>
+              <a:t>22/10/2026</a:t>
             </a:fld>
             <a:endParaRPr lang="fr-FR"/>
           </a:p>
@@ -461,7 +460,7 @@
           <a:p>
             <a:fld id="{D7B9B2F6-DB6D-6549-8947-FBFB6C213823}" type="datetimeFigureOut">
               <a:rPr lang="fr-FR" smtClean="0"/>
-              <a:t>20/10/2026</a:t>
+              <a:t>22/10/2026</a:t>
             </a:fld>
             <a:endParaRPr lang="fr-FR"/>
           </a:p>
@@ -669,7 +668,7 @@
           <a:p>
             <a:fld id="{D7B9B2F6-DB6D-6549-8947-FBFB6C213823}" type="datetimeFigureOut">
               <a:rPr lang="fr-FR" smtClean="0"/>
-              <a:t>20/10/2026</a:t>
+              <a:t>22/10/2026</a:t>
             </a:fld>
             <a:endParaRPr lang="fr-FR"/>
           </a:p>
@@ -867,7 +866,7 @@
           <a:p>
             <a:fld id="{D7B9B2F6-DB6D-6549-8947-FBFB6C213823}" type="datetimeFigureOut">
               <a:rPr lang="fr-FR" smtClean="0"/>
-              <a:t>20/10/2026</a:t>
+              <a:t>22/10/2026</a:t>
             </a:fld>
             <a:endParaRPr lang="fr-FR"/>
           </a:p>
@@ -1142,7 +1141,7 @@
           <a:p>
             <a:fld id="{D7B9B2F6-DB6D-6549-8947-FBFB6C213823}" type="datetimeFigureOut">
               <a:rPr lang="fr-FR" smtClean="0"/>
-              <a:t>20/10/2026</a:t>
+              <a:t>22/10/2026</a:t>
             </a:fld>
             <a:endParaRPr lang="fr-FR"/>
           </a:p>
@@ -1407,7 +1406,7 @@
           <a:p>
             <a:fld id="{D7B9B2F6-DB6D-6549-8947-FBFB6C213823}" type="datetimeFigureOut">
               <a:rPr lang="fr-FR" smtClean="0"/>
-              <a:t>20/10/2026</a:t>
+              <a:t>22/10/2026</a:t>
             </a:fld>
             <a:endParaRPr lang="fr-FR"/>
           </a:p>
@@ -1819,7 +1818,7 @@
           <a:p>
             <a:fld id="{D7B9B2F6-DB6D-6549-8947-FBFB6C213823}" type="datetimeFigureOut">
               <a:rPr lang="fr-FR" smtClean="0"/>
-              <a:t>20/10/2026</a:t>
+              <a:t>22/10/2026</a:t>
             </a:fld>
             <a:endParaRPr lang="fr-FR"/>
           </a:p>
@@ -1960,7 +1959,7 @@
           <a:p>
             <a:fld id="{D7B9B2F6-DB6D-6549-8947-FBFB6C213823}" type="datetimeFigureOut">
               <a:rPr lang="fr-FR" smtClean="0"/>
-              <a:t>20/10/2026</a:t>
+              <a:t>22/10/2026</a:t>
             </a:fld>
             <a:endParaRPr lang="fr-FR"/>
           </a:p>
@@ -2073,7 +2072,7 @@
           <a:p>
             <a:fld id="{D7B9B2F6-DB6D-6549-8947-FBFB6C213823}" type="datetimeFigureOut">
               <a:rPr lang="fr-FR" smtClean="0"/>
-              <a:t>20/10/2026</a:t>
+              <a:t>22/10/2026</a:t>
             </a:fld>
             <a:endParaRPr lang="fr-FR"/>
           </a:p>
@@ -2384,7 +2383,7 @@
           <a:p>
             <a:fld id="{D7B9B2F6-DB6D-6549-8947-FBFB6C213823}" type="datetimeFigureOut">
               <a:rPr lang="fr-FR" smtClean="0"/>
-              <a:t>20/10/2026</a:t>
+              <a:t>22/10/2026</a:t>
             </a:fld>
             <a:endParaRPr lang="fr-FR"/>
           </a:p>
@@ -2672,7 +2671,7 @@
           <a:p>
             <a:fld id="{D7B9B2F6-DB6D-6549-8947-FBFB6C213823}" type="datetimeFigureOut">
               <a:rPr lang="fr-FR" smtClean="0"/>
-              <a:t>20/10/2026</a:t>
+              <a:t>22/10/2026</a:t>
             </a:fld>
             <a:endParaRPr lang="fr-FR"/>
           </a:p>
@@ -2913,7 +2912,7 @@
           <a:p>
             <a:fld id="{D7B9B2F6-DB6D-6549-8947-FBFB6C213823}" type="datetimeFigureOut">
               <a:rPr lang="fr-FR" smtClean="0"/>
-              <a:t>20/10/2026</a:t>
+              <a:t>22/10/2026</a:t>
             </a:fld>
             <a:endParaRPr lang="fr-FR"/>
           </a:p>
@@ -3318,7 +3317,13 @@
   <p:cSld>
     <p:spTree>
       <p:nvGrpSpPr>
-        <p:cNvPr id="1" name=""/>
+        <p:cNvPr id="1" name="">
+          <a:extLst>
+            <a:ext uri="{FF2B5EF4-FFF2-40B4-BE49-F238E27FC236}">
+              <a16:creationId xmlns:a16="http://schemas.microsoft.com/office/drawing/2014/main" id="{14373272-B996-5683-3B1B-13E87A59F2FA}"/>
+            </a:ext>
+          </a:extLst>
+        </p:cNvPr>
         <p:cNvGrpSpPr/>
         <p:nvPr/>
       </p:nvGrpSpPr>
@@ -3335,7 +3340,7 @@
           <p:cNvPr id="4" name="Ellipse 3">
             <a:extLst>
               <a:ext uri="{FF2B5EF4-FFF2-40B4-BE49-F238E27FC236}">
-                <a16:creationId xmlns:a16="http://schemas.microsoft.com/office/drawing/2014/main" id="{90251D55-DCA6-C305-E518-EE4C4C4A0E82}"/>
+                <a16:creationId xmlns:a16="http://schemas.microsoft.com/office/drawing/2014/main" id="{F48B0356-D8AF-91BC-4776-6CFD486E57EE}"/>
               </a:ext>
             </a:extLst>
           </p:cNvPr>
@@ -3382,13 +3387,13 @@
           </a:fontRef>
         </p:style>
         <p:txBody>
-          <a:bodyPr rtlCol="0" anchor="ctr"/>
+          <a:bodyPr lIns="0" tIns="0" rIns="0" bIns="0" rtlCol="0" anchor="ctr"/>
           <a:lstStyle/>
           <a:p>
             <a:pPr algn="ctr"/>
             <a:r>
-              <a:rPr lang="fr-FR" sz="1000" dirty="0"/>
-              <a:t>b1</a:t>
+              <a:rPr lang="fr-FR" sz="1600" dirty="0"/>
+              <a:t>E1</a:t>
             </a:r>
           </a:p>
         </p:txBody>
@@ -3398,7 +3403,7 @@
           <p:cNvPr id="5" name="Ellipse 4">
             <a:extLst>
               <a:ext uri="{FF2B5EF4-FFF2-40B4-BE49-F238E27FC236}">
-                <a16:creationId xmlns:a16="http://schemas.microsoft.com/office/drawing/2014/main" id="{C7FA57C0-FFD8-7E2E-370D-C38D846520E9}"/>
+                <a16:creationId xmlns:a16="http://schemas.microsoft.com/office/drawing/2014/main" id="{50C6A811-A76E-702D-DA4D-1F855DE5A503}"/>
               </a:ext>
             </a:extLst>
           </p:cNvPr>
@@ -3407,7 +3412,7 @@
         </p:nvSpPr>
         <p:spPr>
           <a:xfrm>
-            <a:off x="1064002" y="2700259"/>
+            <a:off x="1068410" y="3152165"/>
             <a:ext cx="467833" cy="467833"/>
           </a:xfrm>
           <a:prstGeom prst="ellipse">
@@ -3445,13 +3450,13 @@
           </a:fontRef>
         </p:style>
         <p:txBody>
-          <a:bodyPr rtlCol="0" anchor="ctr"/>
+          <a:bodyPr lIns="0" tIns="0" rIns="0" bIns="0" rtlCol="0" anchor="ctr"/>
           <a:lstStyle/>
           <a:p>
             <a:pPr algn="ctr"/>
             <a:r>
-              <a:rPr lang="fr-FR" sz="1000" dirty="0"/>
-              <a:t>b0</a:t>
+              <a:rPr lang="fr-FR" sz="1600" dirty="0"/>
+              <a:t>E2</a:t>
             </a:r>
           </a:p>
         </p:txBody>
@@ -3461,7 +3466,7 @@
           <p:cNvPr id="10" name="Connecteur en angle 9">
             <a:extLst>
               <a:ext uri="{FF2B5EF4-FFF2-40B4-BE49-F238E27FC236}">
-                <a16:creationId xmlns:a16="http://schemas.microsoft.com/office/drawing/2014/main" id="{E9ACC0E2-A4D6-AB82-8739-23496289C5B1}"/>
+                <a16:creationId xmlns:a16="http://schemas.microsoft.com/office/drawing/2014/main" id="{9CA6DD80-A5D6-7836-356E-CBA39C4FA07C}"/>
               </a:ext>
             </a:extLst>
           </p:cNvPr>
@@ -3475,7 +3480,7 @@
         <p:spPr>
           <a:xfrm>
             <a:off x="1502664" y="1722507"/>
-            <a:ext cx="2641049" cy="1654710"/>
+            <a:ext cx="2641049" cy="1909902"/>
           </a:xfrm>
           <a:prstGeom prst="straightConnector1">
             <a:avLst/>
@@ -3501,7 +3506,7 @@
           <p:cNvPr id="11" name="Connecteur en angle 10">
             <a:extLst>
               <a:ext uri="{FF2B5EF4-FFF2-40B4-BE49-F238E27FC236}">
-                <a16:creationId xmlns:a16="http://schemas.microsoft.com/office/drawing/2014/main" id="{645472C6-DED2-61B5-387B-452AE96489B6}"/>
+                <a16:creationId xmlns:a16="http://schemas.microsoft.com/office/drawing/2014/main" id="{88F20B6E-FF17-0C26-B5E8-CB2436E66CD8}"/>
               </a:ext>
             </a:extLst>
           </p:cNvPr>
@@ -3541,7 +3546,7 @@
           <p:cNvPr id="12" name="Connecteur en angle 11">
             <a:extLst>
               <a:ext uri="{FF2B5EF4-FFF2-40B4-BE49-F238E27FC236}">
-                <a16:creationId xmlns:a16="http://schemas.microsoft.com/office/drawing/2014/main" id="{A60CBD3A-06AE-506B-8875-C54F53CE546E}"/>
+                <a16:creationId xmlns:a16="http://schemas.microsoft.com/office/drawing/2014/main" id="{C7138474-8EE5-7DB9-510B-3160319059CA}"/>
               </a:ext>
             </a:extLst>
           </p:cNvPr>
@@ -3555,7 +3560,7 @@
         <p:spPr>
           <a:xfrm>
             <a:off x="1502664" y="1722507"/>
-            <a:ext cx="2625629" cy="654716"/>
+            <a:ext cx="2625629" cy="782312"/>
           </a:xfrm>
           <a:prstGeom prst="straightConnector1">
             <a:avLst/>
@@ -3581,7 +3586,7 @@
           <p:cNvPr id="19" name="Connecteur en angle 18">
             <a:extLst>
               <a:ext uri="{FF2B5EF4-FFF2-40B4-BE49-F238E27FC236}">
-                <a16:creationId xmlns:a16="http://schemas.microsoft.com/office/drawing/2014/main" id="{03813804-60D7-38C8-5AB0-746C65B2ACAC}"/>
+                <a16:creationId xmlns:a16="http://schemas.microsoft.com/office/drawing/2014/main" id="{88C35BFB-A176-D46B-5690-006DC753287F}"/>
               </a:ext>
             </a:extLst>
           </p:cNvPr>
@@ -3594,8 +3599,8 @@
         </p:nvCxnSpPr>
         <p:spPr>
           <a:xfrm>
-            <a:off x="1531835" y="2934176"/>
-            <a:ext cx="2611878" cy="443041"/>
+            <a:off x="1536243" y="3386082"/>
+            <a:ext cx="2607470" cy="246327"/>
           </a:xfrm>
           <a:prstGeom prst="straightConnector1">
             <a:avLst/>
@@ -3621,7 +3626,7 @@
           <p:cNvPr id="22" name="Connecteur en angle 21">
             <a:extLst>
               <a:ext uri="{FF2B5EF4-FFF2-40B4-BE49-F238E27FC236}">
-                <a16:creationId xmlns:a16="http://schemas.microsoft.com/office/drawing/2014/main" id="{6B2DE060-48D6-D91E-D479-ECA4607601AE}"/>
+                <a16:creationId xmlns:a16="http://schemas.microsoft.com/office/drawing/2014/main" id="{A2C1C670-A064-71E4-07A8-34582C08D868}"/>
               </a:ext>
             </a:extLst>
           </p:cNvPr>
@@ -3634,8 +3639,8 @@
         </p:nvCxnSpPr>
         <p:spPr>
           <a:xfrm flipV="1">
-            <a:off x="1531835" y="2377223"/>
-            <a:ext cx="2596458" cy="556953"/>
+            <a:off x="1536243" y="2504819"/>
+            <a:ext cx="2592050" cy="881263"/>
           </a:xfrm>
           <a:prstGeom prst="straightConnector1">
             <a:avLst/>
@@ -3661,7 +3666,7 @@
           <p:cNvPr id="25" name="Connecteur en angle 24">
             <a:extLst>
               <a:ext uri="{FF2B5EF4-FFF2-40B4-BE49-F238E27FC236}">
-                <a16:creationId xmlns:a16="http://schemas.microsoft.com/office/drawing/2014/main" id="{76382799-BE5D-FDBF-2A72-31B5E5437EFB}"/>
+                <a16:creationId xmlns:a16="http://schemas.microsoft.com/office/drawing/2014/main" id="{1336422C-FB4A-FF57-E487-13769C12418F}"/>
               </a:ext>
             </a:extLst>
           </p:cNvPr>
@@ -3674,8 +3679,8 @@
         </p:nvCxnSpPr>
         <p:spPr>
           <a:xfrm flipV="1">
-            <a:off x="1531835" y="1478019"/>
-            <a:ext cx="2569491" cy="1456157"/>
+            <a:off x="1536243" y="1478019"/>
+            <a:ext cx="2565083" cy="1908063"/>
           </a:xfrm>
           <a:prstGeom prst="straightConnector1">
             <a:avLst/>
@@ -3701,7 +3706,7 @@
           <p:cNvPr id="77" name="ZoneTexte 76">
             <a:extLst>
               <a:ext uri="{FF2B5EF4-FFF2-40B4-BE49-F238E27FC236}">
-                <a16:creationId xmlns:a16="http://schemas.microsoft.com/office/drawing/2014/main" id="{4F2601DC-C409-0183-1639-EC66016C9867}"/>
+                <a16:creationId xmlns:a16="http://schemas.microsoft.com/office/drawing/2014/main" id="{458876C5-7412-36D5-0398-EBB52369E711}"/>
               </a:ext>
             </a:extLst>
           </p:cNvPr>
@@ -3710,7 +3715,7 @@
         </p:nvSpPr>
         <p:spPr>
           <a:xfrm>
-            <a:off x="3047864" y="3118842"/>
+            <a:off x="3047864" y="3457164"/>
             <a:ext cx="585417" cy="369332"/>
           </a:xfrm>
           <a:prstGeom prst="rect">
@@ -3746,7 +3751,7 @@
           <p:cNvPr id="78" name="ZoneTexte 77">
             <a:extLst>
               <a:ext uri="{FF2B5EF4-FFF2-40B4-BE49-F238E27FC236}">
-                <a16:creationId xmlns:a16="http://schemas.microsoft.com/office/drawing/2014/main" id="{74C485E5-D63B-04F3-32BA-081D68F68F7D}"/>
+                <a16:creationId xmlns:a16="http://schemas.microsoft.com/office/drawing/2014/main" id="{ABAAD53A-8937-7125-4F09-9B4F9C6B98AD}"/>
               </a:ext>
             </a:extLst>
           </p:cNvPr>
@@ -3791,7 +3796,7 @@
           <p:cNvPr id="79" name="ZoneTexte 78">
             <a:extLst>
               <a:ext uri="{FF2B5EF4-FFF2-40B4-BE49-F238E27FC236}">
-                <a16:creationId xmlns:a16="http://schemas.microsoft.com/office/drawing/2014/main" id="{9AFC3031-0186-0FB5-29AB-7626D4346683}"/>
+                <a16:creationId xmlns:a16="http://schemas.microsoft.com/office/drawing/2014/main" id="{E07C2E40-8F59-5494-8461-F2E775B6E17B}"/>
               </a:ext>
             </a:extLst>
           </p:cNvPr>
@@ -3800,7 +3805,7 @@
         </p:nvSpPr>
         <p:spPr>
           <a:xfrm>
-            <a:off x="3031834" y="2288853"/>
+            <a:off x="3031834" y="2416449"/>
             <a:ext cx="617477" cy="369332"/>
           </a:xfrm>
           <a:prstGeom prst="rect">
@@ -3836,7 +3841,7 @@
           <p:cNvPr id="80" name="ZoneTexte 79">
             <a:extLst>
               <a:ext uri="{FF2B5EF4-FFF2-40B4-BE49-F238E27FC236}">
-                <a16:creationId xmlns:a16="http://schemas.microsoft.com/office/drawing/2014/main" id="{D0D582CF-A4AE-9EB9-E2AD-73A994A45879}"/>
+                <a16:creationId xmlns:a16="http://schemas.microsoft.com/office/drawing/2014/main" id="{EF11B74F-17F1-7D95-E815-AF6652F1DB30}"/>
               </a:ext>
             </a:extLst>
           </p:cNvPr>
@@ -3881,7 +3886,7 @@
           <p:cNvPr id="81" name="ZoneTexte 80">
             <a:extLst>
               <a:ext uri="{FF2B5EF4-FFF2-40B4-BE49-F238E27FC236}">
-                <a16:creationId xmlns:a16="http://schemas.microsoft.com/office/drawing/2014/main" id="{DCD7AE03-5553-3BAE-5009-F6463159EAE6}"/>
+                <a16:creationId xmlns:a16="http://schemas.microsoft.com/office/drawing/2014/main" id="{9FF5E186-1428-1DAC-7A5D-3103C7311391}"/>
               </a:ext>
             </a:extLst>
           </p:cNvPr>
@@ -3926,7 +3931,7 @@
           <p:cNvPr id="76" name="ZoneTexte 75">
             <a:extLst>
               <a:ext uri="{FF2B5EF4-FFF2-40B4-BE49-F238E27FC236}">
-                <a16:creationId xmlns:a16="http://schemas.microsoft.com/office/drawing/2014/main" id="{66157849-3683-78B4-5A10-A3E8C22A602C}"/>
+                <a16:creationId xmlns:a16="http://schemas.microsoft.com/office/drawing/2014/main" id="{A95F3F2D-688F-3082-9585-C96BA1C33EFA}"/>
               </a:ext>
             </a:extLst>
           </p:cNvPr>
@@ -3935,7 +3940,7 @@
         </p:nvSpPr>
         <p:spPr>
           <a:xfrm>
-            <a:off x="3035537" y="2712307"/>
+            <a:off x="3035537" y="3022919"/>
             <a:ext cx="610070" cy="369332"/>
           </a:xfrm>
           <a:prstGeom prst="rect">
@@ -3967,10 +3972,10 @@
       </p:sp>
       <p:sp>
         <p:nvSpPr>
-          <p:cNvPr id="2" name="Forme libre 1">
-            <a:extLst>
-              <a:ext uri="{FF2B5EF4-FFF2-40B4-BE49-F238E27FC236}">
-                <a16:creationId xmlns:a16="http://schemas.microsoft.com/office/drawing/2014/main" id="{E95E750B-F460-90CD-8B7A-A01F1C3152B9}"/>
+          <p:cNvPr id="3" name="Ellipse 2">
+            <a:extLst>
+              <a:ext uri="{FF2B5EF4-FFF2-40B4-BE49-F238E27FC236}">
+                <a16:creationId xmlns:a16="http://schemas.microsoft.com/office/drawing/2014/main" id="{91CC4009-725A-77A3-EEE4-667E529096F9}"/>
               </a:ext>
             </a:extLst>
           </p:cNvPr>
@@ -3978,9 +3983,760 @@
           <p:nvPr/>
         </p:nvSpPr>
         <p:spPr>
-          <a:xfrm rot="16557881">
-            <a:off x="5014861" y="2316504"/>
-            <a:ext cx="574334" cy="370546"/>
+          <a:xfrm>
+            <a:off x="7558785" y="4037217"/>
+            <a:ext cx="467833" cy="467833"/>
+          </a:xfrm>
+          <a:prstGeom prst="ellipse">
+            <a:avLst/>
+          </a:prstGeom>
+          <a:solidFill>
+            <a:schemeClr val="tx2">
+              <a:lumMod val="50000"/>
+              <a:lumOff val="50000"/>
+            </a:schemeClr>
+          </a:solidFill>
+          <a:ln>
+            <a:solidFill>
+              <a:schemeClr val="tx2">
+                <a:lumMod val="50000"/>
+                <a:lumOff val="50000"/>
+              </a:schemeClr>
+            </a:solidFill>
+          </a:ln>
+        </p:spPr>
+        <p:style>
+          <a:lnRef idx="2">
+            <a:schemeClr val="accent1">
+              <a:shade val="15000"/>
+            </a:schemeClr>
+          </a:lnRef>
+          <a:fillRef idx="1">
+            <a:schemeClr val="accent1"/>
+          </a:fillRef>
+          <a:effectRef idx="0">
+            <a:schemeClr val="accent1"/>
+          </a:effectRef>
+          <a:fontRef idx="minor">
+            <a:schemeClr val="lt1"/>
+          </a:fontRef>
+        </p:style>
+        <p:txBody>
+          <a:bodyPr lIns="0" tIns="0" rIns="0" bIns="0" rtlCol="0" anchor="ctr"/>
+          <a:lstStyle/>
+          <a:p>
+            <a:pPr algn="ctr"/>
+            <a:r>
+              <a:rPr lang="fr-FR" sz="1600" dirty="0"/>
+              <a:t>s3</a:t>
+            </a:r>
+          </a:p>
+        </p:txBody>
+      </p:sp>
+      <p:sp>
+        <p:nvSpPr>
+          <p:cNvPr id="9" name="Rectangle 8">
+            <a:extLst>
+              <a:ext uri="{FF2B5EF4-FFF2-40B4-BE49-F238E27FC236}">
+                <a16:creationId xmlns:a16="http://schemas.microsoft.com/office/drawing/2014/main" id="{9E3FF7E1-D7CE-A97E-0830-B4FB1F034C41}"/>
+              </a:ext>
+            </a:extLst>
+          </p:cNvPr>
+          <p:cNvSpPr/>
+          <p:nvPr/>
+        </p:nvSpPr>
+        <p:spPr>
+          <a:xfrm>
+            <a:off x="4101326" y="1222837"/>
+            <a:ext cx="587269" cy="510363"/>
+          </a:xfrm>
+          <a:prstGeom prst="rect">
+            <a:avLst/>
+          </a:prstGeom>
+          <a:noFill/>
+          <a:ln>
+            <a:solidFill>
+              <a:schemeClr val="bg1">
+                <a:lumMod val="75000"/>
+              </a:schemeClr>
+            </a:solidFill>
+          </a:ln>
+        </p:spPr>
+        <p:style>
+          <a:lnRef idx="2">
+            <a:schemeClr val="accent1">
+              <a:shade val="15000"/>
+            </a:schemeClr>
+          </a:lnRef>
+          <a:fillRef idx="1">
+            <a:schemeClr val="accent1"/>
+          </a:fillRef>
+          <a:effectRef idx="0">
+            <a:schemeClr val="accent1"/>
+          </a:effectRef>
+          <a:fontRef idx="minor">
+            <a:schemeClr val="lt1"/>
+          </a:fontRef>
+        </p:style>
+        <p:txBody>
+          <a:bodyPr rtlCol="0" anchor="ctr"/>
+          <a:lstStyle/>
+          <a:p>
+            <a:pPr algn="ctr"/>
+            <a:endParaRPr lang="fr-FR"/>
+          </a:p>
+        </p:txBody>
+      </p:sp>
+      <p:sp>
+        <p:nvSpPr>
+          <p:cNvPr id="13" name="Ellipse 12">
+            <a:extLst>
+              <a:ext uri="{FF2B5EF4-FFF2-40B4-BE49-F238E27FC236}">
+                <a16:creationId xmlns:a16="http://schemas.microsoft.com/office/drawing/2014/main" id="{57A60CF6-8702-1CEA-3E4C-4A1CD55A69CA}"/>
+              </a:ext>
+            </a:extLst>
+          </p:cNvPr>
+          <p:cNvSpPr/>
+          <p:nvPr/>
+        </p:nvSpPr>
+        <p:spPr>
+          <a:xfrm>
+            <a:off x="6581114" y="4064926"/>
+            <a:ext cx="467833" cy="467833"/>
+          </a:xfrm>
+          <a:prstGeom prst="ellipse">
+            <a:avLst/>
+          </a:prstGeom>
+          <a:solidFill>
+            <a:schemeClr val="tx2">
+              <a:lumMod val="50000"/>
+              <a:lumOff val="50000"/>
+            </a:schemeClr>
+          </a:solidFill>
+          <a:ln>
+            <a:solidFill>
+              <a:schemeClr val="tx2">
+                <a:lumMod val="50000"/>
+                <a:lumOff val="50000"/>
+              </a:schemeClr>
+            </a:solidFill>
+          </a:ln>
+        </p:spPr>
+        <p:style>
+          <a:lnRef idx="2">
+            <a:schemeClr val="accent1">
+              <a:shade val="15000"/>
+            </a:schemeClr>
+          </a:lnRef>
+          <a:fillRef idx="1">
+            <a:schemeClr val="accent1"/>
+          </a:fillRef>
+          <a:effectRef idx="0">
+            <a:schemeClr val="accent1"/>
+          </a:effectRef>
+          <a:fontRef idx="minor">
+            <a:schemeClr val="lt1"/>
+          </a:fontRef>
+        </p:style>
+        <p:txBody>
+          <a:bodyPr lIns="0" tIns="0" rIns="0" bIns="0" rtlCol="0" anchor="ctr"/>
+          <a:lstStyle/>
+          <a:p>
+            <a:pPr algn="ctr"/>
+            <a:r>
+              <a:rPr lang="fr-FR" sz="1600" dirty="0"/>
+              <a:t>s2</a:t>
+            </a:r>
+          </a:p>
+        </p:txBody>
+      </p:sp>
+      <p:sp>
+        <p:nvSpPr>
+          <p:cNvPr id="14" name="Ellipse 13">
+            <a:extLst>
+              <a:ext uri="{FF2B5EF4-FFF2-40B4-BE49-F238E27FC236}">
+                <a16:creationId xmlns:a16="http://schemas.microsoft.com/office/drawing/2014/main" id="{5438B2DD-65A7-D5A6-4E30-D8BF01E57D34}"/>
+              </a:ext>
+            </a:extLst>
+          </p:cNvPr>
+          <p:cNvSpPr/>
+          <p:nvPr/>
+        </p:nvSpPr>
+        <p:spPr>
+          <a:xfrm>
+            <a:off x="5656048" y="4048363"/>
+            <a:ext cx="467833" cy="467833"/>
+          </a:xfrm>
+          <a:prstGeom prst="ellipse">
+            <a:avLst/>
+          </a:prstGeom>
+          <a:solidFill>
+            <a:schemeClr val="tx2">
+              <a:lumMod val="50000"/>
+              <a:lumOff val="50000"/>
+            </a:schemeClr>
+          </a:solidFill>
+          <a:ln>
+            <a:solidFill>
+              <a:schemeClr val="tx2">
+                <a:lumMod val="50000"/>
+                <a:lumOff val="50000"/>
+              </a:schemeClr>
+            </a:solidFill>
+          </a:ln>
+        </p:spPr>
+        <p:style>
+          <a:lnRef idx="2">
+            <a:schemeClr val="accent1">
+              <a:shade val="15000"/>
+            </a:schemeClr>
+          </a:lnRef>
+          <a:fillRef idx="1">
+            <a:schemeClr val="accent1"/>
+          </a:fillRef>
+          <a:effectRef idx="0">
+            <a:schemeClr val="accent1"/>
+          </a:effectRef>
+          <a:fontRef idx="minor">
+            <a:schemeClr val="lt1"/>
+          </a:fontRef>
+        </p:style>
+        <p:txBody>
+          <a:bodyPr lIns="0" tIns="0" rIns="0" bIns="0" rtlCol="0" anchor="ctr"/>
+          <a:lstStyle/>
+          <a:p>
+            <a:pPr algn="ctr"/>
+            <a:r>
+              <a:rPr lang="fr-FR" sz="1600" dirty="0"/>
+              <a:t>S1</a:t>
+            </a:r>
+          </a:p>
+        </p:txBody>
+      </p:sp>
+      <p:sp>
+        <p:nvSpPr>
+          <p:cNvPr id="17" name="Rectangle 16">
+            <a:extLst>
+              <a:ext uri="{FF2B5EF4-FFF2-40B4-BE49-F238E27FC236}">
+                <a16:creationId xmlns:a16="http://schemas.microsoft.com/office/drawing/2014/main" id="{33FF0AFC-0FE4-07C5-BA85-34110FA42229}"/>
+              </a:ext>
+            </a:extLst>
+          </p:cNvPr>
+          <p:cNvSpPr/>
+          <p:nvPr/>
+        </p:nvSpPr>
+        <p:spPr>
+          <a:xfrm>
+            <a:off x="4128293" y="2249637"/>
+            <a:ext cx="587269" cy="510363"/>
+          </a:xfrm>
+          <a:prstGeom prst="rect">
+            <a:avLst/>
+          </a:prstGeom>
+          <a:noFill/>
+          <a:ln>
+            <a:solidFill>
+              <a:schemeClr val="bg1">
+                <a:lumMod val="75000"/>
+              </a:schemeClr>
+            </a:solidFill>
+          </a:ln>
+        </p:spPr>
+        <p:style>
+          <a:lnRef idx="2">
+            <a:schemeClr val="accent1">
+              <a:shade val="15000"/>
+            </a:schemeClr>
+          </a:lnRef>
+          <a:fillRef idx="1">
+            <a:schemeClr val="accent1"/>
+          </a:fillRef>
+          <a:effectRef idx="0">
+            <a:schemeClr val="accent1"/>
+          </a:effectRef>
+          <a:fontRef idx="minor">
+            <a:schemeClr val="lt1"/>
+          </a:fontRef>
+        </p:style>
+        <p:txBody>
+          <a:bodyPr rtlCol="0" anchor="ctr"/>
+          <a:lstStyle/>
+          <a:p>
+            <a:pPr algn="ctr"/>
+            <a:endParaRPr lang="fr-FR"/>
+          </a:p>
+        </p:txBody>
+      </p:sp>
+      <p:sp>
+        <p:nvSpPr>
+          <p:cNvPr id="27" name="Rectangle 26">
+            <a:extLst>
+              <a:ext uri="{FF2B5EF4-FFF2-40B4-BE49-F238E27FC236}">
+                <a16:creationId xmlns:a16="http://schemas.microsoft.com/office/drawing/2014/main" id="{984137C5-2372-EA5B-9502-A7B497B20766}"/>
+              </a:ext>
+            </a:extLst>
+          </p:cNvPr>
+          <p:cNvSpPr/>
+          <p:nvPr/>
+        </p:nvSpPr>
+        <p:spPr>
+          <a:xfrm>
+            <a:off x="4143713" y="3377227"/>
+            <a:ext cx="587269" cy="510363"/>
+          </a:xfrm>
+          <a:prstGeom prst="rect">
+            <a:avLst/>
+          </a:prstGeom>
+          <a:noFill/>
+          <a:ln>
+            <a:solidFill>
+              <a:schemeClr val="bg1">
+                <a:lumMod val="75000"/>
+              </a:schemeClr>
+            </a:solidFill>
+          </a:ln>
+        </p:spPr>
+        <p:style>
+          <a:lnRef idx="2">
+            <a:schemeClr val="accent1">
+              <a:shade val="15000"/>
+            </a:schemeClr>
+          </a:lnRef>
+          <a:fillRef idx="1">
+            <a:schemeClr val="accent1"/>
+          </a:fillRef>
+          <a:effectRef idx="0">
+            <a:schemeClr val="accent1"/>
+          </a:effectRef>
+          <a:fontRef idx="minor">
+            <a:schemeClr val="lt1"/>
+          </a:fontRef>
+        </p:style>
+        <p:txBody>
+          <a:bodyPr rtlCol="0" anchor="ctr"/>
+          <a:lstStyle/>
+          <a:p>
+            <a:pPr algn="ctr"/>
+            <a:endParaRPr lang="fr-FR"/>
+          </a:p>
+        </p:txBody>
+      </p:sp>
+      <p:cxnSp>
+        <p:nvCxnSpPr>
+          <p:cNvPr id="39" name="Connecteur en angle 10">
+            <a:extLst>
+              <a:ext uri="{FF2B5EF4-FFF2-40B4-BE49-F238E27FC236}">
+                <a16:creationId xmlns:a16="http://schemas.microsoft.com/office/drawing/2014/main" id="{0E345B31-338E-2280-5794-ECBD8E70B250}"/>
+              </a:ext>
+            </a:extLst>
+          </p:cNvPr>
+          <p:cNvCxnSpPr>
+            <a:cxnSpLocks/>
+            <a:stCxn id="17" idx="3"/>
+            <a:endCxn id="13" idx="0"/>
+          </p:cNvCxnSpPr>
+          <p:nvPr/>
+        </p:nvCxnSpPr>
+        <p:spPr>
+          <a:xfrm>
+            <a:off x="4715562" y="2504819"/>
+            <a:ext cx="2099469" cy="1560107"/>
+          </a:xfrm>
+          <a:prstGeom prst="bentConnector2">
+            <a:avLst/>
+          </a:prstGeom>
+        </p:spPr>
+        <p:style>
+          <a:lnRef idx="2">
+            <a:schemeClr val="accent1"/>
+          </a:lnRef>
+          <a:fillRef idx="0">
+            <a:schemeClr val="accent1"/>
+          </a:fillRef>
+          <a:effectRef idx="1">
+            <a:schemeClr val="accent1"/>
+          </a:effectRef>
+          <a:fontRef idx="minor">
+            <a:schemeClr val="tx1"/>
+          </a:fontRef>
+        </p:style>
+      </p:cxnSp>
+      <p:cxnSp>
+        <p:nvCxnSpPr>
+          <p:cNvPr id="42" name="Connecteur en angle 10">
+            <a:extLst>
+              <a:ext uri="{FF2B5EF4-FFF2-40B4-BE49-F238E27FC236}">
+                <a16:creationId xmlns:a16="http://schemas.microsoft.com/office/drawing/2014/main" id="{7A465D79-E8F2-CCE3-29B0-F0249C0C88A5}"/>
+              </a:ext>
+            </a:extLst>
+          </p:cNvPr>
+          <p:cNvCxnSpPr>
+            <a:cxnSpLocks/>
+            <a:stCxn id="27" idx="3"/>
+            <a:endCxn id="14" idx="0"/>
+          </p:cNvCxnSpPr>
+          <p:nvPr/>
+        </p:nvCxnSpPr>
+        <p:spPr>
+          <a:xfrm>
+            <a:off x="4730982" y="3632409"/>
+            <a:ext cx="1158983" cy="415954"/>
+          </a:xfrm>
+          <a:prstGeom prst="bentConnector2">
+            <a:avLst/>
+          </a:prstGeom>
+        </p:spPr>
+        <p:style>
+          <a:lnRef idx="2">
+            <a:schemeClr val="accent1"/>
+          </a:lnRef>
+          <a:fillRef idx="0">
+            <a:schemeClr val="accent1"/>
+          </a:fillRef>
+          <a:effectRef idx="1">
+            <a:schemeClr val="accent1"/>
+          </a:effectRef>
+          <a:fontRef idx="minor">
+            <a:schemeClr val="tx1"/>
+          </a:fontRef>
+        </p:style>
+      </p:cxnSp>
+      <p:sp>
+        <p:nvSpPr>
+          <p:cNvPr id="47" name="ZoneTexte 46">
+            <a:extLst>
+              <a:ext uri="{FF2B5EF4-FFF2-40B4-BE49-F238E27FC236}">
+                <a16:creationId xmlns:a16="http://schemas.microsoft.com/office/drawing/2014/main" id="{4EAF8AB6-30F9-4276-4471-3F8562D672BB}"/>
+              </a:ext>
+            </a:extLst>
+          </p:cNvPr>
+          <p:cNvSpPr txBox="1"/>
+          <p:nvPr/>
+        </p:nvSpPr>
+        <p:spPr>
+          <a:xfrm>
+            <a:off x="4226055" y="1218489"/>
+            <a:ext cx="346570" cy="461665"/>
+          </a:xfrm>
+          <a:prstGeom prst="rect">
+            <a:avLst/>
+          </a:prstGeom>
+          <a:noFill/>
+        </p:spPr>
+        <p:txBody>
+          <a:bodyPr wrap="none" rtlCol="0">
+            <a:spAutoFit/>
+          </a:bodyPr>
+          <a:lstStyle/>
+          <a:p>
+            <a:r>
+              <a:rPr lang="fr-FR" sz="2400" dirty="0"/>
+              <a:t>∑</a:t>
+            </a:r>
+          </a:p>
+        </p:txBody>
+      </p:sp>
+      <p:sp>
+        <p:nvSpPr>
+          <p:cNvPr id="48" name="ZoneTexte 47">
+            <a:extLst>
+              <a:ext uri="{FF2B5EF4-FFF2-40B4-BE49-F238E27FC236}">
+                <a16:creationId xmlns:a16="http://schemas.microsoft.com/office/drawing/2014/main" id="{4CE9383F-BFC5-4EE8-0FAB-840E07171D96}"/>
+              </a:ext>
+            </a:extLst>
+          </p:cNvPr>
+          <p:cNvSpPr txBox="1"/>
+          <p:nvPr/>
+        </p:nvSpPr>
+        <p:spPr>
+          <a:xfrm>
+            <a:off x="4269244" y="3370141"/>
+            <a:ext cx="346570" cy="461665"/>
+          </a:xfrm>
+          <a:prstGeom prst="rect">
+            <a:avLst/>
+          </a:prstGeom>
+          <a:noFill/>
+        </p:spPr>
+        <p:txBody>
+          <a:bodyPr wrap="none" rtlCol="0">
+            <a:spAutoFit/>
+          </a:bodyPr>
+          <a:lstStyle/>
+          <a:p>
+            <a:r>
+              <a:rPr lang="fr-FR" sz="2400" dirty="0"/>
+              <a:t>∑</a:t>
+            </a:r>
+          </a:p>
+        </p:txBody>
+      </p:sp>
+      <p:sp>
+        <p:nvSpPr>
+          <p:cNvPr id="49" name="ZoneTexte 48">
+            <a:extLst>
+              <a:ext uri="{FF2B5EF4-FFF2-40B4-BE49-F238E27FC236}">
+                <a16:creationId xmlns:a16="http://schemas.microsoft.com/office/drawing/2014/main" id="{E4318403-FF95-8191-B277-7E9DAE34F2E8}"/>
+              </a:ext>
+            </a:extLst>
+          </p:cNvPr>
+          <p:cNvSpPr txBox="1"/>
+          <p:nvPr/>
+        </p:nvSpPr>
+        <p:spPr>
+          <a:xfrm>
+            <a:off x="4270690" y="2305002"/>
+            <a:ext cx="346570" cy="461665"/>
+          </a:xfrm>
+          <a:prstGeom prst="rect">
+            <a:avLst/>
+          </a:prstGeom>
+          <a:noFill/>
+        </p:spPr>
+        <p:txBody>
+          <a:bodyPr wrap="none" rtlCol="0">
+            <a:spAutoFit/>
+          </a:bodyPr>
+          <a:lstStyle/>
+          <a:p>
+            <a:r>
+              <a:rPr lang="fr-FR" sz="2400" dirty="0"/>
+              <a:t>∑</a:t>
+            </a:r>
+          </a:p>
+        </p:txBody>
+      </p:sp>
+      <p:sp>
+        <p:nvSpPr>
+          <p:cNvPr id="51" name="ZoneTexte 50">
+            <a:extLst>
+              <a:ext uri="{FF2B5EF4-FFF2-40B4-BE49-F238E27FC236}">
+                <a16:creationId xmlns:a16="http://schemas.microsoft.com/office/drawing/2014/main" id="{0E5F238F-367E-A687-CC60-D25429F8E6F0}"/>
+              </a:ext>
+            </a:extLst>
+          </p:cNvPr>
+          <p:cNvSpPr txBox="1"/>
+          <p:nvPr/>
+        </p:nvSpPr>
+        <p:spPr>
+          <a:xfrm>
+            <a:off x="6123881" y="740373"/>
+            <a:ext cx="1523174" cy="369332"/>
+          </a:xfrm>
+          <a:prstGeom prst="rect">
+            <a:avLst/>
+          </a:prstGeom>
+          <a:noFill/>
+        </p:spPr>
+        <p:txBody>
+          <a:bodyPr wrap="none" rtlCol="0">
+            <a:spAutoFit/>
+          </a:bodyPr>
+          <a:lstStyle/>
+          <a:p>
+            <a:r>
+              <a:rPr lang="fr-FR" dirty="0"/>
+              <a:t>Sorties 0 ou 1</a:t>
+            </a:r>
+          </a:p>
+        </p:txBody>
+      </p:sp>
+      <p:sp>
+        <p:nvSpPr>
+          <p:cNvPr id="52" name="ZoneTexte 51">
+            <a:extLst>
+              <a:ext uri="{FF2B5EF4-FFF2-40B4-BE49-F238E27FC236}">
+                <a16:creationId xmlns:a16="http://schemas.microsoft.com/office/drawing/2014/main" id="{D90273BB-A92E-A48F-0A16-321EC6DB8F54}"/>
+              </a:ext>
+            </a:extLst>
+          </p:cNvPr>
+          <p:cNvSpPr txBox="1"/>
+          <p:nvPr/>
+        </p:nvSpPr>
+        <p:spPr>
+          <a:xfrm>
+            <a:off x="957193" y="740373"/>
+            <a:ext cx="1632242" cy="369332"/>
+          </a:xfrm>
+          <a:prstGeom prst="rect">
+            <a:avLst/>
+          </a:prstGeom>
+          <a:noFill/>
+        </p:spPr>
+        <p:txBody>
+          <a:bodyPr wrap="none" rtlCol="0">
+            <a:spAutoFit/>
+          </a:bodyPr>
+          <a:lstStyle/>
+          <a:p>
+            <a:r>
+              <a:rPr lang="fr-FR" dirty="0"/>
+              <a:t>Entrées 0  ou 1</a:t>
+            </a:r>
+          </a:p>
+        </p:txBody>
+      </p:sp>
+      <p:sp>
+        <p:nvSpPr>
+          <p:cNvPr id="53" name="ZoneTexte 52">
+            <a:extLst>
+              <a:ext uri="{FF2B5EF4-FFF2-40B4-BE49-F238E27FC236}">
+                <a16:creationId xmlns:a16="http://schemas.microsoft.com/office/drawing/2014/main" id="{BAAB3AA3-0B71-52A9-4264-8CE864C562DF}"/>
+              </a:ext>
+            </a:extLst>
+          </p:cNvPr>
+          <p:cNvSpPr txBox="1"/>
+          <p:nvPr/>
+        </p:nvSpPr>
+        <p:spPr>
+          <a:xfrm>
+            <a:off x="3858775" y="741391"/>
+            <a:ext cx="939681" cy="369332"/>
+          </a:xfrm>
+          <a:prstGeom prst="rect">
+            <a:avLst/>
+          </a:prstGeom>
+          <a:noFill/>
+        </p:spPr>
+        <p:txBody>
+          <a:bodyPr wrap="none" rtlCol="0">
+            <a:spAutoFit/>
+          </a:bodyPr>
+          <a:lstStyle/>
+          <a:p>
+            <a:r>
+              <a:rPr lang="fr-FR" dirty="0"/>
+              <a:t>somme</a:t>
+            </a:r>
+          </a:p>
+        </p:txBody>
+      </p:sp>
+      <p:sp>
+        <p:nvSpPr>
+          <p:cNvPr id="54" name="ZoneTexte 53">
+            <a:extLst>
+              <a:ext uri="{FF2B5EF4-FFF2-40B4-BE49-F238E27FC236}">
+                <a16:creationId xmlns:a16="http://schemas.microsoft.com/office/drawing/2014/main" id="{86AA09F2-9C5B-8DA4-9746-A9635449D524}"/>
+              </a:ext>
+            </a:extLst>
+          </p:cNvPr>
+          <p:cNvSpPr txBox="1"/>
+          <p:nvPr/>
+        </p:nvSpPr>
+        <p:spPr>
+          <a:xfrm>
+            <a:off x="4853251" y="741391"/>
+            <a:ext cx="660758" cy="369332"/>
+          </a:xfrm>
+          <a:prstGeom prst="rect">
+            <a:avLst/>
+          </a:prstGeom>
+          <a:noFill/>
+        </p:spPr>
+        <p:txBody>
+          <a:bodyPr wrap="none" rtlCol="0">
+            <a:spAutoFit/>
+          </a:bodyPr>
+          <a:lstStyle/>
+          <a:p>
+            <a:r>
+              <a:rPr lang="fr-FR" dirty="0"/>
+              <a:t>seuil</a:t>
+            </a:r>
+          </a:p>
+        </p:txBody>
+      </p:sp>
+      <p:sp>
+        <p:nvSpPr>
+          <p:cNvPr id="55" name="ZoneTexte 54">
+            <a:extLst>
+              <a:ext uri="{FF2B5EF4-FFF2-40B4-BE49-F238E27FC236}">
+                <a16:creationId xmlns:a16="http://schemas.microsoft.com/office/drawing/2014/main" id="{81F13F09-9D55-5B45-D6C6-4B09C54E0D1E}"/>
+              </a:ext>
+            </a:extLst>
+          </p:cNvPr>
+          <p:cNvSpPr txBox="1"/>
+          <p:nvPr/>
+        </p:nvSpPr>
+        <p:spPr>
+          <a:xfrm>
+            <a:off x="2883637" y="741391"/>
+            <a:ext cx="737702" cy="369332"/>
+          </a:xfrm>
+          <a:prstGeom prst="rect">
+            <a:avLst/>
+          </a:prstGeom>
+          <a:noFill/>
+        </p:spPr>
+        <p:txBody>
+          <a:bodyPr wrap="none" rtlCol="0">
+            <a:spAutoFit/>
+          </a:bodyPr>
+          <a:lstStyle/>
+          <a:p>
+            <a:r>
+              <a:rPr lang="fr-FR" dirty="0"/>
+              <a:t>poids</a:t>
+            </a:r>
+          </a:p>
+        </p:txBody>
+      </p:sp>
+      <p:cxnSp>
+        <p:nvCxnSpPr>
+          <p:cNvPr id="16" name="Connecteur en angle 10">
+            <a:extLst>
+              <a:ext uri="{FF2B5EF4-FFF2-40B4-BE49-F238E27FC236}">
+                <a16:creationId xmlns:a16="http://schemas.microsoft.com/office/drawing/2014/main" id="{2D510080-C5B9-DDD2-E5C6-E759877C3EFB}"/>
+              </a:ext>
+            </a:extLst>
+          </p:cNvPr>
+          <p:cNvCxnSpPr>
+            <a:cxnSpLocks/>
+            <a:stCxn id="9" idx="3"/>
+            <a:endCxn id="3" idx="0"/>
+          </p:cNvCxnSpPr>
+          <p:nvPr/>
+        </p:nvCxnSpPr>
+        <p:spPr>
+          <a:xfrm>
+            <a:off x="4688595" y="1478019"/>
+            <a:ext cx="3104107" cy="2559198"/>
+          </a:xfrm>
+          <a:prstGeom prst="bentConnector2">
+            <a:avLst/>
+          </a:prstGeom>
+        </p:spPr>
+        <p:style>
+          <a:lnRef idx="2">
+            <a:schemeClr val="accent1"/>
+          </a:lnRef>
+          <a:fillRef idx="0">
+            <a:schemeClr val="accent1"/>
+          </a:fillRef>
+          <a:effectRef idx="1">
+            <a:schemeClr val="accent1"/>
+          </a:effectRef>
+          <a:fontRef idx="minor">
+            <a:schemeClr val="tx1"/>
+          </a:fontRef>
+        </p:style>
+      </p:cxnSp>
+      <p:sp>
+        <p:nvSpPr>
+          <p:cNvPr id="34" name="Forme libre 33">
+            <a:extLst>
+              <a:ext uri="{FF2B5EF4-FFF2-40B4-BE49-F238E27FC236}">
+                <a16:creationId xmlns:a16="http://schemas.microsoft.com/office/drawing/2014/main" id="{AAB92076-EC75-4767-F557-6B1ADE3E1352}"/>
+              </a:ext>
+            </a:extLst>
+          </p:cNvPr>
+          <p:cNvSpPr/>
+          <p:nvPr/>
+        </p:nvSpPr>
+        <p:spPr>
+          <a:xfrm rot="16557881" flipV="1">
+            <a:off x="5002989" y="1431699"/>
+            <a:ext cx="574334" cy="289722"/>
           </a:xfrm>
           <a:custGeom>
             <a:avLst/>
@@ -4033,7 +4789,11 @@
               </a:path>
             </a:pathLst>
           </a:custGeom>
-          <a:noFill/>
+          <a:solidFill>
+            <a:schemeClr val="bg2">
+              <a:lumMod val="90000"/>
+            </a:schemeClr>
+          </a:solidFill>
         </p:spPr>
         <p:style>
           <a:lnRef idx="2">
@@ -4056,16 +4816,16 @@
           <a:lstStyle/>
           <a:p>
             <a:pPr algn="ctr"/>
-            <a:endParaRPr lang="fr-FR"/>
-          </a:p>
-        </p:txBody>
-      </p:sp>
-      <p:sp>
-        <p:nvSpPr>
-          <p:cNvPr id="3" name="Ellipse 2">
-            <a:extLst>
-              <a:ext uri="{FF2B5EF4-FFF2-40B4-BE49-F238E27FC236}">
-                <a16:creationId xmlns:a16="http://schemas.microsoft.com/office/drawing/2014/main" id="{7EA1BD77-DB03-37BC-509E-443FE1526940}"/>
+            <a:endParaRPr lang="fr-FR" dirty="0"/>
+          </a:p>
+        </p:txBody>
+      </p:sp>
+      <p:sp>
+        <p:nvSpPr>
+          <p:cNvPr id="30" name="Forme libre 29">
+            <a:extLst>
+              <a:ext uri="{FF2B5EF4-FFF2-40B4-BE49-F238E27FC236}">
+                <a16:creationId xmlns:a16="http://schemas.microsoft.com/office/drawing/2014/main" id="{2B0D1B1D-F9AB-C627-D258-9B1D3C6FC82A}"/>
               </a:ext>
             </a:extLst>
           </p:cNvPr>
@@ -4073,189 +4833,9 @@
           <p:nvPr/>
         </p:nvSpPr>
         <p:spPr>
-          <a:xfrm>
-            <a:off x="5691797" y="1244103"/>
-            <a:ext cx="467833" cy="467833"/>
-          </a:xfrm>
-          <a:prstGeom prst="ellipse">
-            <a:avLst/>
-          </a:prstGeom>
-          <a:solidFill>
-            <a:srgbClr val="FF0000"/>
-          </a:solidFill>
-          <a:ln>
-            <a:solidFill>
-              <a:schemeClr val="tx2">
-                <a:lumMod val="50000"/>
-                <a:lumOff val="50000"/>
-              </a:schemeClr>
-            </a:solidFill>
-          </a:ln>
-        </p:spPr>
-        <p:style>
-          <a:lnRef idx="2">
-            <a:schemeClr val="accent1">
-              <a:shade val="15000"/>
-            </a:schemeClr>
-          </a:lnRef>
-          <a:fillRef idx="1">
-            <a:schemeClr val="accent1"/>
-          </a:fillRef>
-          <a:effectRef idx="0">
-            <a:schemeClr val="accent1"/>
-          </a:effectRef>
-          <a:fontRef idx="minor">
-            <a:schemeClr val="lt1"/>
-          </a:fontRef>
-        </p:style>
-        <p:txBody>
-          <a:bodyPr rtlCol="0" anchor="ctr"/>
-          <a:lstStyle/>
-          <a:p>
-            <a:pPr algn="ctr"/>
-            <a:r>
-              <a:rPr lang="fr-FR" dirty="0"/>
-              <a:t>3</a:t>
-            </a:r>
-          </a:p>
-        </p:txBody>
-      </p:sp>
-      <p:sp>
-        <p:nvSpPr>
-          <p:cNvPr id="13" name="Ellipse 12">
-            <a:extLst>
-              <a:ext uri="{FF2B5EF4-FFF2-40B4-BE49-F238E27FC236}">
-                <a16:creationId xmlns:a16="http://schemas.microsoft.com/office/drawing/2014/main" id="{944E16C9-23E4-7002-4C3D-D86686CF48B8}"/>
-              </a:ext>
-            </a:extLst>
-          </p:cNvPr>
-          <p:cNvSpPr/>
-          <p:nvPr/>
-        </p:nvSpPr>
-        <p:spPr>
-          <a:xfrm>
-            <a:off x="5702924" y="2106805"/>
-            <a:ext cx="467833" cy="467833"/>
-          </a:xfrm>
-          <a:prstGeom prst="ellipse">
-            <a:avLst/>
-          </a:prstGeom>
-          <a:solidFill>
-            <a:srgbClr val="FFC000"/>
-          </a:solidFill>
-          <a:ln>
-            <a:solidFill>
-              <a:schemeClr val="tx2">
-                <a:lumMod val="50000"/>
-                <a:lumOff val="50000"/>
-              </a:schemeClr>
-            </a:solidFill>
-          </a:ln>
-        </p:spPr>
-        <p:style>
-          <a:lnRef idx="2">
-            <a:schemeClr val="accent1">
-              <a:shade val="15000"/>
-            </a:schemeClr>
-          </a:lnRef>
-          <a:fillRef idx="1">
-            <a:schemeClr val="accent1"/>
-          </a:fillRef>
-          <a:effectRef idx="0">
-            <a:schemeClr val="accent1"/>
-          </a:effectRef>
-          <a:fontRef idx="minor">
-            <a:schemeClr val="lt1"/>
-          </a:fontRef>
-        </p:style>
-        <p:txBody>
-          <a:bodyPr rtlCol="0" anchor="ctr"/>
-          <a:lstStyle/>
-          <a:p>
-            <a:pPr algn="ctr"/>
-            <a:r>
-              <a:rPr lang="fr-FR" dirty="0"/>
-              <a:t>2</a:t>
-            </a:r>
-          </a:p>
-        </p:txBody>
-      </p:sp>
-      <p:sp>
-        <p:nvSpPr>
-          <p:cNvPr id="14" name="Ellipse 13">
-            <a:extLst>
-              <a:ext uri="{FF2B5EF4-FFF2-40B4-BE49-F238E27FC236}">
-                <a16:creationId xmlns:a16="http://schemas.microsoft.com/office/drawing/2014/main" id="{49699683-EF29-D857-E931-B602B915CEB0}"/>
-              </a:ext>
-            </a:extLst>
-          </p:cNvPr>
-          <p:cNvSpPr/>
-          <p:nvPr/>
-        </p:nvSpPr>
-        <p:spPr>
-          <a:xfrm>
-            <a:off x="5723657" y="3143299"/>
-            <a:ext cx="467833" cy="467833"/>
-          </a:xfrm>
-          <a:prstGeom prst="ellipse">
-            <a:avLst/>
-          </a:prstGeom>
-          <a:solidFill>
-            <a:srgbClr val="92D050"/>
-          </a:solidFill>
-          <a:ln>
-            <a:solidFill>
-              <a:schemeClr val="tx2">
-                <a:lumMod val="50000"/>
-                <a:lumOff val="50000"/>
-              </a:schemeClr>
-            </a:solidFill>
-          </a:ln>
-        </p:spPr>
-        <p:style>
-          <a:lnRef idx="2">
-            <a:schemeClr val="accent1">
-              <a:shade val="15000"/>
-            </a:schemeClr>
-          </a:lnRef>
-          <a:fillRef idx="1">
-            <a:schemeClr val="accent1"/>
-          </a:fillRef>
-          <a:effectRef idx="0">
-            <a:schemeClr val="accent1"/>
-          </a:effectRef>
-          <a:fontRef idx="minor">
-            <a:schemeClr val="lt1"/>
-          </a:fontRef>
-        </p:style>
-        <p:txBody>
-          <a:bodyPr rtlCol="0" anchor="ctr"/>
-          <a:lstStyle/>
-          <a:p>
-            <a:pPr algn="ctr"/>
-            <a:r>
-              <a:rPr lang="fr-FR" dirty="0"/>
-              <a:t>1</a:t>
-            </a:r>
-          </a:p>
-        </p:txBody>
-      </p:sp>
-      <p:sp>
-        <p:nvSpPr>
-          <p:cNvPr id="33" name="Forme libre 32">
-            <a:extLst>
-              <a:ext uri="{FF2B5EF4-FFF2-40B4-BE49-F238E27FC236}">
-                <a16:creationId xmlns:a16="http://schemas.microsoft.com/office/drawing/2014/main" id="{B4336C7A-5FFD-2B25-996D-3F65AB24E108}"/>
-              </a:ext>
-            </a:extLst>
-          </p:cNvPr>
-          <p:cNvSpPr/>
-          <p:nvPr/>
-        </p:nvSpPr>
-        <p:spPr>
-          <a:xfrm rot="16557881">
-            <a:off x="5014861" y="1379465"/>
-            <a:ext cx="574334" cy="370546"/>
+          <a:xfrm rot="16557881" flipV="1">
+            <a:off x="5002989" y="3493599"/>
+            <a:ext cx="574334" cy="289722"/>
           </a:xfrm>
           <a:custGeom>
             <a:avLst/>
@@ -4308,7 +4888,11 @@
               </a:path>
             </a:pathLst>
           </a:custGeom>
-          <a:noFill/>
+          <a:solidFill>
+            <a:schemeClr val="bg2">
+              <a:lumMod val="90000"/>
+            </a:schemeClr>
+          </a:solidFill>
         </p:spPr>
         <p:style>
           <a:lnRef idx="2">
@@ -4331,16 +4915,16 @@
           <a:lstStyle/>
           <a:p>
             <a:pPr algn="ctr"/>
-            <a:endParaRPr lang="fr-FR"/>
-          </a:p>
-        </p:txBody>
-      </p:sp>
-      <p:sp>
-        <p:nvSpPr>
-          <p:cNvPr id="34" name="Forme libre 33">
-            <a:extLst>
-              <a:ext uri="{FF2B5EF4-FFF2-40B4-BE49-F238E27FC236}">
-                <a16:creationId xmlns:a16="http://schemas.microsoft.com/office/drawing/2014/main" id="{EE708D0A-0DCE-37D5-1AC9-B1BF8E086509}"/>
+            <a:endParaRPr lang="fr-FR" dirty="0"/>
+          </a:p>
+        </p:txBody>
+      </p:sp>
+      <p:sp>
+        <p:nvSpPr>
+          <p:cNvPr id="31" name="Forme libre 30">
+            <a:extLst>
+              <a:ext uri="{FF2B5EF4-FFF2-40B4-BE49-F238E27FC236}">
+                <a16:creationId xmlns:a16="http://schemas.microsoft.com/office/drawing/2014/main" id="{B8B6D54B-FCD8-DDFB-8E77-8E911E97EF4E}"/>
               </a:ext>
             </a:extLst>
           </p:cNvPr>
@@ -4348,9 +4932,9 @@
           <p:nvPr/>
         </p:nvSpPr>
         <p:spPr>
-          <a:xfrm rot="16557881">
-            <a:off x="5014861" y="3317829"/>
-            <a:ext cx="574334" cy="340690"/>
+          <a:xfrm rot="16557881" flipV="1">
+            <a:off x="5002989" y="2433819"/>
+            <a:ext cx="574334" cy="289722"/>
           </a:xfrm>
           <a:custGeom>
             <a:avLst/>
@@ -4403,7 +4987,11 @@
               </a:path>
             </a:pathLst>
           </a:custGeom>
-          <a:noFill/>
+          <a:solidFill>
+            <a:schemeClr val="bg2">
+              <a:lumMod val="90000"/>
+            </a:schemeClr>
+          </a:solidFill>
         </p:spPr>
         <p:style>
           <a:lnRef idx="2">
@@ -4426,633 +5014,170 @@
           <a:lstStyle/>
           <a:p>
             <a:pPr algn="ctr"/>
-            <a:endParaRPr lang="fr-FR"/>
-          </a:p>
-        </p:txBody>
-      </p:sp>
-      <p:cxnSp>
-        <p:nvCxnSpPr>
-          <p:cNvPr id="35" name="Connecteur en angle 10">
-            <a:extLst>
-              <a:ext uri="{FF2B5EF4-FFF2-40B4-BE49-F238E27FC236}">
-                <a16:creationId xmlns:a16="http://schemas.microsoft.com/office/drawing/2014/main" id="{50EFD5CF-A122-679A-52C7-C4C45E0CFA72}"/>
-              </a:ext>
-            </a:extLst>
-          </p:cNvPr>
-          <p:cNvCxnSpPr>
-            <a:cxnSpLocks/>
-            <a:stCxn id="9" idx="3"/>
-            <a:endCxn id="3" idx="2"/>
-          </p:cNvCxnSpPr>
+            <a:endParaRPr lang="fr-FR" dirty="0"/>
+          </a:p>
+        </p:txBody>
+      </p:sp>
+      <p:sp>
+        <p:nvSpPr>
+          <p:cNvPr id="2" name="Rectangle 1">
+            <a:extLst>
+              <a:ext uri="{FF2B5EF4-FFF2-40B4-BE49-F238E27FC236}">
+                <a16:creationId xmlns:a16="http://schemas.microsoft.com/office/drawing/2014/main" id="{EBD8FFAA-6021-972C-4259-5F30A79FFD11}"/>
+              </a:ext>
+            </a:extLst>
+          </p:cNvPr>
+          <p:cNvSpPr/>
           <p:nvPr/>
-        </p:nvCxnSpPr>
-        <p:spPr>
-          <a:xfrm>
-            <a:off x="4688595" y="1478019"/>
-            <a:ext cx="1003202" cy="1"/>
-          </a:xfrm>
-          <a:prstGeom prst="straightConnector1">
-            <a:avLst/>
-          </a:prstGeom>
-        </p:spPr>
-        <p:style>
-          <a:lnRef idx="2">
-            <a:schemeClr val="accent1"/>
-          </a:lnRef>
-          <a:fillRef idx="0">
-            <a:schemeClr val="accent1"/>
-          </a:fillRef>
-          <a:effectRef idx="1">
-            <a:schemeClr val="accent1"/>
-          </a:effectRef>
-          <a:fontRef idx="minor">
-            <a:schemeClr val="tx1"/>
-          </a:fontRef>
-        </p:style>
-      </p:cxnSp>
-      <p:cxnSp>
-        <p:nvCxnSpPr>
-          <p:cNvPr id="39" name="Connecteur en angle 10">
-            <a:extLst>
-              <a:ext uri="{FF2B5EF4-FFF2-40B4-BE49-F238E27FC236}">
-                <a16:creationId xmlns:a16="http://schemas.microsoft.com/office/drawing/2014/main" id="{9078C90B-ECAC-330C-22A7-BF561A4E1D6D}"/>
-              </a:ext>
-            </a:extLst>
-          </p:cNvPr>
-          <p:cNvCxnSpPr>
-            <a:cxnSpLocks/>
-            <a:stCxn id="17" idx="3"/>
-            <a:endCxn id="13" idx="2"/>
-          </p:cNvCxnSpPr>
-          <p:nvPr/>
-        </p:nvCxnSpPr>
-        <p:spPr>
-          <a:xfrm flipV="1">
-            <a:off x="4715562" y="2340722"/>
-            <a:ext cx="987362" cy="36501"/>
-          </a:xfrm>
-          <a:prstGeom prst="straightConnector1">
-            <a:avLst/>
-          </a:prstGeom>
-        </p:spPr>
-        <p:style>
-          <a:lnRef idx="2">
-            <a:schemeClr val="accent1"/>
-          </a:lnRef>
-          <a:fillRef idx="0">
-            <a:schemeClr val="accent1"/>
-          </a:fillRef>
-          <a:effectRef idx="1">
-            <a:schemeClr val="accent1"/>
-          </a:effectRef>
-          <a:fontRef idx="minor">
-            <a:schemeClr val="tx1"/>
-          </a:fontRef>
-        </p:style>
-      </p:cxnSp>
-      <p:cxnSp>
-        <p:nvCxnSpPr>
-          <p:cNvPr id="42" name="Connecteur en angle 10">
-            <a:extLst>
-              <a:ext uri="{FF2B5EF4-FFF2-40B4-BE49-F238E27FC236}">
-                <a16:creationId xmlns:a16="http://schemas.microsoft.com/office/drawing/2014/main" id="{1536CBD5-ECD6-55A0-3780-EEB82722D27B}"/>
-              </a:ext>
-            </a:extLst>
-          </p:cNvPr>
-          <p:cNvCxnSpPr>
-            <a:cxnSpLocks/>
-            <a:stCxn id="27" idx="3"/>
-            <a:endCxn id="14" idx="2"/>
-          </p:cNvCxnSpPr>
-          <p:nvPr/>
-        </p:nvCxnSpPr>
-        <p:spPr>
-          <a:xfrm flipV="1">
-            <a:off x="4730982" y="3377216"/>
-            <a:ext cx="992675" cy="1"/>
-          </a:xfrm>
-          <a:prstGeom prst="straightConnector1">
-            <a:avLst/>
-          </a:prstGeom>
-        </p:spPr>
-        <p:style>
-          <a:lnRef idx="2">
-            <a:schemeClr val="accent1"/>
-          </a:lnRef>
-          <a:fillRef idx="0">
-            <a:schemeClr val="accent1"/>
-          </a:fillRef>
-          <a:effectRef idx="1">
-            <a:schemeClr val="accent1"/>
-          </a:effectRef>
-          <a:fontRef idx="minor">
-            <a:schemeClr val="tx1"/>
-          </a:fontRef>
-        </p:style>
-      </p:cxnSp>
-      <p:grpSp>
-        <p:nvGrpSpPr>
-          <p:cNvPr id="56" name="Groupe 55">
-            <a:extLst>
-              <a:ext uri="{FF2B5EF4-FFF2-40B4-BE49-F238E27FC236}">
-                <a16:creationId xmlns:a16="http://schemas.microsoft.com/office/drawing/2014/main" id="{E03FFBF5-1F07-943F-25E1-647CD9274E9E}"/>
-              </a:ext>
-            </a:extLst>
-          </p:cNvPr>
-          <p:cNvGrpSpPr/>
-          <p:nvPr/>
-        </p:nvGrpSpPr>
-        <p:grpSpPr>
-          <a:xfrm>
-            <a:off x="4101326" y="1218489"/>
-            <a:ext cx="587269" cy="514711"/>
-            <a:chOff x="4101326" y="1218489"/>
-            <a:chExt cx="587269" cy="514711"/>
-          </a:xfrm>
-        </p:grpSpPr>
-        <p:sp>
-          <p:nvSpPr>
-            <p:cNvPr id="9" name="Rectangle 8">
-              <a:extLst>
-                <a:ext uri="{FF2B5EF4-FFF2-40B4-BE49-F238E27FC236}">
-                  <a16:creationId xmlns:a16="http://schemas.microsoft.com/office/drawing/2014/main" id="{8B79FB39-3136-5542-6B45-1DA0B643EB31}"/>
-                </a:ext>
-              </a:extLst>
-            </p:cNvPr>
-            <p:cNvSpPr/>
-            <p:nvPr/>
-          </p:nvSpPr>
-          <p:spPr>
-            <a:xfrm>
-              <a:off x="4101326" y="1222837"/>
-              <a:ext cx="587269" cy="510363"/>
-            </a:xfrm>
-            <a:prstGeom prst="rect">
-              <a:avLst/>
-            </a:prstGeom>
-            <a:noFill/>
-            <a:ln>
-              <a:solidFill>
-                <a:srgbClr val="FF0000"/>
-              </a:solidFill>
-            </a:ln>
-          </p:spPr>
-          <p:style>
-            <a:lnRef idx="2">
-              <a:schemeClr val="accent1">
-                <a:shade val="15000"/>
-              </a:schemeClr>
-            </a:lnRef>
-            <a:fillRef idx="1">
-              <a:schemeClr val="accent1"/>
-            </a:fillRef>
-            <a:effectRef idx="0">
-              <a:schemeClr val="accent1"/>
-            </a:effectRef>
-            <a:fontRef idx="minor">
-              <a:schemeClr val="lt1"/>
-            </a:fontRef>
-          </p:style>
-          <p:txBody>
-            <a:bodyPr rtlCol="0" anchor="ctr"/>
-            <a:lstStyle/>
-            <a:p>
-              <a:pPr algn="ctr"/>
-              <a:endParaRPr lang="fr-FR"/>
-            </a:p>
-          </p:txBody>
-        </p:sp>
-        <p:sp>
-          <p:nvSpPr>
-            <p:cNvPr id="47" name="ZoneTexte 46">
-              <a:extLst>
-                <a:ext uri="{FF2B5EF4-FFF2-40B4-BE49-F238E27FC236}">
-                  <a16:creationId xmlns:a16="http://schemas.microsoft.com/office/drawing/2014/main" id="{A22C660A-ABB5-86FD-611C-6560A3EBA9D1}"/>
-                </a:ext>
-              </a:extLst>
-            </p:cNvPr>
-            <p:cNvSpPr txBox="1"/>
-            <p:nvPr/>
-          </p:nvSpPr>
-          <p:spPr>
-            <a:xfrm>
-              <a:off x="4226055" y="1218489"/>
-              <a:ext cx="346570" cy="461665"/>
-            </a:xfrm>
-            <a:prstGeom prst="rect">
-              <a:avLst/>
-            </a:prstGeom>
-            <a:noFill/>
-          </p:spPr>
-          <p:txBody>
-            <a:bodyPr wrap="none" rtlCol="0">
-              <a:spAutoFit/>
-            </a:bodyPr>
-            <a:lstStyle/>
-            <a:p>
-              <a:r>
-                <a:rPr lang="fr-FR" sz="2400" dirty="0"/>
-                <a:t>∑</a:t>
-              </a:r>
-            </a:p>
-          </p:txBody>
-        </p:sp>
-      </p:grpSp>
-      <p:grpSp>
-        <p:nvGrpSpPr>
-          <p:cNvPr id="58" name="Groupe 57">
-            <a:extLst>
-              <a:ext uri="{FF2B5EF4-FFF2-40B4-BE49-F238E27FC236}">
-                <a16:creationId xmlns:a16="http://schemas.microsoft.com/office/drawing/2014/main" id="{425D65CD-683E-139C-3D6B-3D43907CB292}"/>
-              </a:ext>
-            </a:extLst>
-          </p:cNvPr>
-          <p:cNvGrpSpPr/>
-          <p:nvPr/>
-        </p:nvGrpSpPr>
-        <p:grpSpPr>
-          <a:xfrm>
-            <a:off x="4143713" y="3114949"/>
-            <a:ext cx="587269" cy="517449"/>
-            <a:chOff x="4143713" y="3114949"/>
-            <a:chExt cx="587269" cy="517449"/>
-          </a:xfrm>
-        </p:grpSpPr>
-        <p:sp>
-          <p:nvSpPr>
-            <p:cNvPr id="27" name="Rectangle 26">
-              <a:extLst>
-                <a:ext uri="{FF2B5EF4-FFF2-40B4-BE49-F238E27FC236}">
-                  <a16:creationId xmlns:a16="http://schemas.microsoft.com/office/drawing/2014/main" id="{B1585AB3-1115-16DB-1794-C6D36A24F84F}"/>
-                </a:ext>
-              </a:extLst>
-            </p:cNvPr>
-            <p:cNvSpPr/>
-            <p:nvPr/>
-          </p:nvSpPr>
-          <p:spPr>
-            <a:xfrm>
-              <a:off x="4143713" y="3122035"/>
-              <a:ext cx="587269" cy="510363"/>
-            </a:xfrm>
-            <a:prstGeom prst="rect">
-              <a:avLst/>
-            </a:prstGeom>
-            <a:noFill/>
-            <a:ln>
-              <a:solidFill>
-                <a:srgbClr val="92D050"/>
-              </a:solidFill>
-            </a:ln>
-          </p:spPr>
-          <p:style>
-            <a:lnRef idx="2">
-              <a:schemeClr val="accent1">
-                <a:shade val="15000"/>
-              </a:schemeClr>
-            </a:lnRef>
-            <a:fillRef idx="1">
-              <a:schemeClr val="accent1"/>
-            </a:fillRef>
-            <a:effectRef idx="0">
-              <a:schemeClr val="accent1"/>
-            </a:effectRef>
-            <a:fontRef idx="minor">
-              <a:schemeClr val="lt1"/>
-            </a:fontRef>
-          </p:style>
-          <p:txBody>
-            <a:bodyPr rtlCol="0" anchor="ctr"/>
-            <a:lstStyle/>
-            <a:p>
-              <a:pPr algn="ctr"/>
-              <a:endParaRPr lang="fr-FR"/>
-            </a:p>
-          </p:txBody>
-        </p:sp>
-        <p:sp>
-          <p:nvSpPr>
-            <p:cNvPr id="48" name="ZoneTexte 47">
-              <a:extLst>
-                <a:ext uri="{FF2B5EF4-FFF2-40B4-BE49-F238E27FC236}">
-                  <a16:creationId xmlns:a16="http://schemas.microsoft.com/office/drawing/2014/main" id="{69C24CD8-C03E-86AE-3C21-FE8629A6C3C3}"/>
-                </a:ext>
-              </a:extLst>
-            </p:cNvPr>
-            <p:cNvSpPr txBox="1"/>
-            <p:nvPr/>
-          </p:nvSpPr>
-          <p:spPr>
-            <a:xfrm>
-              <a:off x="4269244" y="3114949"/>
-              <a:ext cx="346570" cy="461665"/>
-            </a:xfrm>
-            <a:prstGeom prst="rect">
-              <a:avLst/>
-            </a:prstGeom>
-            <a:noFill/>
-          </p:spPr>
-          <p:txBody>
-            <a:bodyPr wrap="none" rtlCol="0">
-              <a:spAutoFit/>
-            </a:bodyPr>
-            <a:lstStyle/>
-            <a:p>
-              <a:r>
-                <a:rPr lang="fr-FR" sz="2400" dirty="0"/>
-                <a:t>∑</a:t>
-              </a:r>
-            </a:p>
-          </p:txBody>
-        </p:sp>
-      </p:grpSp>
-      <p:grpSp>
-        <p:nvGrpSpPr>
-          <p:cNvPr id="57" name="Groupe 56">
-            <a:extLst>
-              <a:ext uri="{FF2B5EF4-FFF2-40B4-BE49-F238E27FC236}">
-                <a16:creationId xmlns:a16="http://schemas.microsoft.com/office/drawing/2014/main" id="{80B3CE9F-6450-EA64-1967-7FBF2A11BF00}"/>
-              </a:ext>
-            </a:extLst>
-          </p:cNvPr>
-          <p:cNvGrpSpPr/>
-          <p:nvPr/>
-        </p:nvGrpSpPr>
-        <p:grpSpPr>
-          <a:xfrm>
-            <a:off x="4128293" y="2122041"/>
-            <a:ext cx="587269" cy="517030"/>
-            <a:chOff x="4128293" y="2122041"/>
-            <a:chExt cx="587269" cy="517030"/>
-          </a:xfrm>
-        </p:grpSpPr>
-        <p:sp>
-          <p:nvSpPr>
-            <p:cNvPr id="17" name="Rectangle 16">
-              <a:extLst>
-                <a:ext uri="{FF2B5EF4-FFF2-40B4-BE49-F238E27FC236}">
-                  <a16:creationId xmlns:a16="http://schemas.microsoft.com/office/drawing/2014/main" id="{3DD37AA3-26E6-7230-CDE6-0B7741B7065B}"/>
-                </a:ext>
-              </a:extLst>
-            </p:cNvPr>
-            <p:cNvSpPr/>
-            <p:nvPr/>
-          </p:nvSpPr>
-          <p:spPr>
-            <a:xfrm>
-              <a:off x="4128293" y="2122041"/>
-              <a:ext cx="587269" cy="510363"/>
-            </a:xfrm>
-            <a:prstGeom prst="rect">
-              <a:avLst/>
-            </a:prstGeom>
-            <a:noFill/>
-            <a:ln>
-              <a:solidFill>
-                <a:srgbClr val="FFC000"/>
-              </a:solidFill>
-            </a:ln>
-          </p:spPr>
-          <p:style>
-            <a:lnRef idx="2">
-              <a:schemeClr val="accent1">
-                <a:shade val="15000"/>
-              </a:schemeClr>
-            </a:lnRef>
-            <a:fillRef idx="1">
-              <a:schemeClr val="accent1"/>
-            </a:fillRef>
-            <a:effectRef idx="0">
-              <a:schemeClr val="accent1"/>
-            </a:effectRef>
-            <a:fontRef idx="minor">
-              <a:schemeClr val="lt1"/>
-            </a:fontRef>
-          </p:style>
-          <p:txBody>
-            <a:bodyPr rtlCol="0" anchor="ctr"/>
-            <a:lstStyle/>
-            <a:p>
-              <a:pPr algn="ctr"/>
-              <a:endParaRPr lang="fr-FR"/>
-            </a:p>
-          </p:txBody>
-        </p:sp>
-        <p:sp>
-          <p:nvSpPr>
-            <p:cNvPr id="49" name="ZoneTexte 48">
-              <a:extLst>
-                <a:ext uri="{FF2B5EF4-FFF2-40B4-BE49-F238E27FC236}">
-                  <a16:creationId xmlns:a16="http://schemas.microsoft.com/office/drawing/2014/main" id="{4592DB9F-7D39-8EFF-1B4B-DC03F01049FF}"/>
-                </a:ext>
-              </a:extLst>
-            </p:cNvPr>
-            <p:cNvSpPr txBox="1"/>
-            <p:nvPr/>
-          </p:nvSpPr>
-          <p:spPr>
-            <a:xfrm>
-              <a:off x="4270690" y="2177406"/>
-              <a:ext cx="346570" cy="461665"/>
-            </a:xfrm>
-            <a:prstGeom prst="rect">
-              <a:avLst/>
-            </a:prstGeom>
-            <a:noFill/>
-          </p:spPr>
-          <p:txBody>
-            <a:bodyPr wrap="none" rtlCol="0">
-              <a:spAutoFit/>
-            </a:bodyPr>
-            <a:lstStyle/>
-            <a:p>
-              <a:r>
-                <a:rPr lang="fr-FR" sz="2400" dirty="0"/>
-                <a:t>∑</a:t>
-              </a:r>
-            </a:p>
-          </p:txBody>
-        </p:sp>
-      </p:grpSp>
-      <p:sp>
-        <p:nvSpPr>
-          <p:cNvPr id="51" name="ZoneTexte 50">
-            <a:extLst>
-              <a:ext uri="{FF2B5EF4-FFF2-40B4-BE49-F238E27FC236}">
-                <a16:creationId xmlns:a16="http://schemas.microsoft.com/office/drawing/2014/main" id="{1B8D5B98-6D8E-F34B-0782-F27B4EE297C0}"/>
-              </a:ext>
-            </a:extLst>
-          </p:cNvPr>
-          <p:cNvSpPr txBox="1"/>
-          <p:nvPr/>
-        </p:nvSpPr>
-        <p:spPr>
-          <a:xfrm>
-            <a:off x="5588440" y="741391"/>
-            <a:ext cx="603050" cy="369332"/>
+        </p:nvSpPr>
+        <p:spPr>
+          <a:xfrm>
+            <a:off x="2883638" y="1117809"/>
+            <a:ext cx="2772410" cy="816373"/>
           </a:xfrm>
           <a:prstGeom prst="rect">
             <a:avLst/>
           </a:prstGeom>
           <a:noFill/>
-        </p:spPr>
-        <p:txBody>
-          <a:bodyPr wrap="none" rtlCol="0">
-            <a:spAutoFit/>
-          </a:bodyPr>
-          <a:lstStyle/>
-          <a:p>
-            <a:r>
-              <a:rPr lang="fr-FR" dirty="0"/>
-              <a:t>0 / 1</a:t>
-            </a:r>
-          </a:p>
-        </p:txBody>
-      </p:sp>
-      <p:sp>
-        <p:nvSpPr>
-          <p:cNvPr id="52" name="ZoneTexte 51">
-            <a:extLst>
-              <a:ext uri="{FF2B5EF4-FFF2-40B4-BE49-F238E27FC236}">
-                <a16:creationId xmlns:a16="http://schemas.microsoft.com/office/drawing/2014/main" id="{7D1D40CC-BBAA-88B5-F49C-79E8EBC005D1}"/>
-              </a:ext>
-            </a:extLst>
-          </p:cNvPr>
-          <p:cNvSpPr txBox="1"/>
+          <a:ln>
+            <a:solidFill>
+              <a:srgbClr val="FF0000"/>
+            </a:solidFill>
+          </a:ln>
+        </p:spPr>
+        <p:style>
+          <a:lnRef idx="2">
+            <a:schemeClr val="accent1">
+              <a:shade val="15000"/>
+            </a:schemeClr>
+          </a:lnRef>
+          <a:fillRef idx="1">
+            <a:schemeClr val="accent1"/>
+          </a:fillRef>
+          <a:effectRef idx="0">
+            <a:schemeClr val="accent1"/>
+          </a:effectRef>
+          <a:fontRef idx="minor">
+            <a:schemeClr val="lt1"/>
+          </a:fontRef>
+        </p:style>
+        <p:txBody>
+          <a:bodyPr rtlCol="0" anchor="ctr"/>
+          <a:lstStyle/>
+          <a:p>
+            <a:pPr algn="ctr"/>
+            <a:endParaRPr lang="fr-FR"/>
+          </a:p>
+        </p:txBody>
+      </p:sp>
+      <p:sp>
+        <p:nvSpPr>
+          <p:cNvPr id="6" name="Rectangle 5">
+            <a:extLst>
+              <a:ext uri="{FF2B5EF4-FFF2-40B4-BE49-F238E27FC236}">
+                <a16:creationId xmlns:a16="http://schemas.microsoft.com/office/drawing/2014/main" id="{DD21837E-15B4-A212-971D-51D1E65EB060}"/>
+              </a:ext>
+            </a:extLst>
+          </p:cNvPr>
+          <p:cNvSpPr/>
           <p:nvPr/>
         </p:nvSpPr>
         <p:spPr>
           <a:xfrm>
-            <a:off x="1064002" y="741391"/>
-            <a:ext cx="603050" cy="369332"/>
+            <a:off x="2883637" y="2078807"/>
+            <a:ext cx="2772411" cy="823501"/>
           </a:xfrm>
           <a:prstGeom prst="rect">
             <a:avLst/>
           </a:prstGeom>
           <a:noFill/>
-        </p:spPr>
-        <p:txBody>
-          <a:bodyPr wrap="none" rtlCol="0">
-            <a:spAutoFit/>
-          </a:bodyPr>
-          <a:lstStyle/>
-          <a:p>
-            <a:r>
-              <a:rPr lang="fr-FR" dirty="0"/>
-              <a:t>0 / 1</a:t>
-            </a:r>
-          </a:p>
-        </p:txBody>
-      </p:sp>
-      <p:sp>
-        <p:nvSpPr>
-          <p:cNvPr id="53" name="ZoneTexte 52">
-            <a:extLst>
-              <a:ext uri="{FF2B5EF4-FFF2-40B4-BE49-F238E27FC236}">
-                <a16:creationId xmlns:a16="http://schemas.microsoft.com/office/drawing/2014/main" id="{2F14F362-0C05-8223-A141-BD65665A2E6D}"/>
-              </a:ext>
-            </a:extLst>
-          </p:cNvPr>
-          <p:cNvSpPr txBox="1"/>
+          <a:ln>
+            <a:solidFill>
+              <a:srgbClr val="FFC000"/>
+            </a:solidFill>
+          </a:ln>
+        </p:spPr>
+        <p:style>
+          <a:lnRef idx="2">
+            <a:schemeClr val="accent1">
+              <a:shade val="15000"/>
+            </a:schemeClr>
+          </a:lnRef>
+          <a:fillRef idx="1">
+            <a:schemeClr val="accent1"/>
+          </a:fillRef>
+          <a:effectRef idx="0">
+            <a:schemeClr val="accent1"/>
+          </a:effectRef>
+          <a:fontRef idx="minor">
+            <a:schemeClr val="lt1"/>
+          </a:fontRef>
+        </p:style>
+        <p:txBody>
+          <a:bodyPr rtlCol="0" anchor="ctr"/>
+          <a:lstStyle/>
+          <a:p>
+            <a:pPr algn="ctr"/>
+            <a:endParaRPr lang="fr-FR"/>
+          </a:p>
+        </p:txBody>
+      </p:sp>
+      <p:sp>
+        <p:nvSpPr>
+          <p:cNvPr id="7" name="Rectangle 6">
+            <a:extLst>
+              <a:ext uri="{FF2B5EF4-FFF2-40B4-BE49-F238E27FC236}">
+                <a16:creationId xmlns:a16="http://schemas.microsoft.com/office/drawing/2014/main" id="{1D4FD614-72B2-7E90-A06C-40EAC3A23CD1}"/>
+              </a:ext>
+            </a:extLst>
+          </p:cNvPr>
+          <p:cNvSpPr/>
           <p:nvPr/>
         </p:nvSpPr>
         <p:spPr>
           <a:xfrm>
-            <a:off x="3858775" y="741391"/>
-            <a:ext cx="939681" cy="369332"/>
+            <a:off x="2883637" y="2964201"/>
+            <a:ext cx="2847312" cy="1075789"/>
           </a:xfrm>
           <a:prstGeom prst="rect">
             <a:avLst/>
           </a:prstGeom>
           <a:noFill/>
-        </p:spPr>
-        <p:txBody>
-          <a:bodyPr wrap="none" rtlCol="0">
-            <a:spAutoFit/>
-          </a:bodyPr>
-          <a:lstStyle/>
-          <a:p>
-            <a:r>
-              <a:rPr lang="fr-FR" dirty="0"/>
-              <a:t>somme</a:t>
-            </a:r>
-          </a:p>
-        </p:txBody>
-      </p:sp>
-      <p:sp>
-        <p:nvSpPr>
-          <p:cNvPr id="54" name="ZoneTexte 53">
-            <a:extLst>
-              <a:ext uri="{FF2B5EF4-FFF2-40B4-BE49-F238E27FC236}">
-                <a16:creationId xmlns:a16="http://schemas.microsoft.com/office/drawing/2014/main" id="{558C301E-E5E2-B182-402F-D06795CDEDEA}"/>
-              </a:ext>
-            </a:extLst>
-          </p:cNvPr>
-          <p:cNvSpPr txBox="1"/>
-          <p:nvPr/>
-        </p:nvSpPr>
-        <p:spPr>
-          <a:xfrm>
-            <a:off x="4853251" y="741391"/>
-            <a:ext cx="660758" cy="369332"/>
-          </a:xfrm>
-          <a:prstGeom prst="rect">
-            <a:avLst/>
-          </a:prstGeom>
-          <a:noFill/>
-        </p:spPr>
-        <p:txBody>
-          <a:bodyPr wrap="none" rtlCol="0">
-            <a:spAutoFit/>
-          </a:bodyPr>
-          <a:lstStyle/>
-          <a:p>
-            <a:r>
-              <a:rPr lang="fr-FR" dirty="0"/>
-              <a:t>seuil</a:t>
-            </a:r>
-          </a:p>
-        </p:txBody>
-      </p:sp>
-      <p:sp>
-        <p:nvSpPr>
-          <p:cNvPr id="55" name="ZoneTexte 54">
-            <a:extLst>
-              <a:ext uri="{FF2B5EF4-FFF2-40B4-BE49-F238E27FC236}">
-                <a16:creationId xmlns:a16="http://schemas.microsoft.com/office/drawing/2014/main" id="{40A7919D-E470-81E8-D5D3-FD0447E439A1}"/>
-              </a:ext>
-            </a:extLst>
-          </p:cNvPr>
-          <p:cNvSpPr txBox="1"/>
-          <p:nvPr/>
-        </p:nvSpPr>
-        <p:spPr>
-          <a:xfrm>
-            <a:off x="2883637" y="741391"/>
-            <a:ext cx="737702" cy="369332"/>
-          </a:xfrm>
-          <a:prstGeom prst="rect">
-            <a:avLst/>
-          </a:prstGeom>
-          <a:noFill/>
-        </p:spPr>
-        <p:txBody>
-          <a:bodyPr wrap="none" rtlCol="0">
-            <a:spAutoFit/>
-          </a:bodyPr>
-          <a:lstStyle/>
-          <a:p>
-            <a:r>
-              <a:rPr lang="fr-FR" dirty="0"/>
-              <a:t>poids</a:t>
-            </a:r>
+          <a:ln>
+            <a:solidFill>
+              <a:srgbClr val="92D050"/>
+            </a:solidFill>
+          </a:ln>
+        </p:spPr>
+        <p:style>
+          <a:lnRef idx="2">
+            <a:schemeClr val="accent1">
+              <a:shade val="15000"/>
+            </a:schemeClr>
+          </a:lnRef>
+          <a:fillRef idx="1">
+            <a:schemeClr val="accent1"/>
+          </a:fillRef>
+          <a:effectRef idx="0">
+            <a:schemeClr val="accent1"/>
+          </a:effectRef>
+          <a:fontRef idx="minor">
+            <a:schemeClr val="lt1"/>
+          </a:fontRef>
+        </p:style>
+        <p:txBody>
+          <a:bodyPr rtlCol="0" anchor="ctr"/>
+          <a:lstStyle/>
+          <a:p>
+            <a:pPr algn="ctr"/>
+            <a:endParaRPr lang="fr-FR"/>
           </a:p>
         </p:txBody>
       </p:sp>
     </p:spTree>
     <p:extLst>
       <p:ext uri="{BB962C8B-B14F-4D97-AF65-F5344CB8AC3E}">
-        <p14:creationId xmlns:p14="http://schemas.microsoft.com/office/powerpoint/2010/main" val="3797718654"/>
+        <p14:creationId xmlns:p14="http://schemas.microsoft.com/office/powerpoint/2010/main" val="4076495031"/>
       </p:ext>
     </p:extLst>
   </p:cSld>
@@ -5219,7 +5344,7 @@
         </p:nvSpPr>
         <p:spPr>
           <a:xfrm>
-            <a:off x="4427040" y="4825175"/>
+            <a:off x="4427040" y="5019145"/>
             <a:ext cx="467833" cy="498894"/>
           </a:xfrm>
           <a:prstGeom prst="ellipse">
@@ -5276,7 +5401,7 @@
         </p:nvSpPr>
         <p:spPr>
           <a:xfrm>
-            <a:off x="5486726" y="4857633"/>
+            <a:off x="5486726" y="5051603"/>
             <a:ext cx="467833" cy="498894"/>
           </a:xfrm>
           <a:prstGeom prst="ellipse">
@@ -5333,7 +5458,7 @@
         </p:nvSpPr>
         <p:spPr>
           <a:xfrm>
-            <a:off x="6460501" y="4825175"/>
+            <a:off x="6460501" y="5019145"/>
             <a:ext cx="467833" cy="498894"/>
           </a:xfrm>
           <a:prstGeom prst="ellipse">
@@ -5514,7 +5639,7 @@
         </p:nvGrpSpPr>
         <p:grpSpPr>
           <a:xfrm>
-            <a:off x="4088528" y="4430106"/>
+            <a:off x="4088528" y="4568549"/>
             <a:ext cx="4845726" cy="574334"/>
             <a:chOff x="4073236" y="3882289"/>
             <a:chExt cx="4845726" cy="574334"/>
@@ -5544,7 +5669,9 @@
             </a:prstGeom>
             <a:ln>
               <a:solidFill>
-                <a:srgbClr val="C00000"/>
+                <a:schemeClr val="bg1">
+                  <a:lumMod val="50000"/>
+                </a:schemeClr>
               </a:solidFill>
             </a:ln>
           </p:spPr>
@@ -5638,7 +5765,9 @@
             </a:solidFill>
             <a:ln>
               <a:solidFill>
-                <a:srgbClr val="C00000"/>
+                <a:schemeClr val="bg1">
+                  <a:lumMod val="50000"/>
+                </a:schemeClr>
               </a:solidFill>
             </a:ln>
           </p:spPr>
@@ -5688,6 +5817,13 @@
               <a:avLst/>
             </a:prstGeom>
             <a:noFill/>
+            <a:ln>
+              <a:solidFill>
+                <a:schemeClr val="bg1">
+                  <a:lumMod val="50000"/>
+                </a:schemeClr>
+              </a:solidFill>
+            </a:ln>
           </p:spPr>
           <p:txBody>
             <a:bodyPr wrap="none" rtlCol="0">
@@ -6438,7 +6574,7 @@
         <p:spPr>
           <a:xfrm flipH="1">
             <a:off x="4660957" y="4488280"/>
-            <a:ext cx="655" cy="336895"/>
+            <a:ext cx="655" cy="530865"/>
           </a:xfrm>
           <a:prstGeom prst="straightConnector1">
             <a:avLst/>
@@ -6481,7 +6617,7 @@
         <p:spPr>
           <a:xfrm flipH="1">
             <a:off x="5720643" y="4511215"/>
-            <a:ext cx="808" cy="346418"/>
+            <a:ext cx="808" cy="540388"/>
           </a:xfrm>
           <a:prstGeom prst="straightConnector1">
             <a:avLst/>
@@ -6524,7 +6660,7 @@
         <p:spPr>
           <a:xfrm>
             <a:off x="6680297" y="4518239"/>
-            <a:ext cx="14121" cy="306936"/>
+            <a:ext cx="14121" cy="500906"/>
           </a:xfrm>
           <a:prstGeom prst="straightConnector1">
             <a:avLst/>
@@ -6548,6 +6684,162 @@
           </a:fontRef>
         </p:style>
       </p:cxnSp>
+      <p:sp>
+        <p:nvSpPr>
+          <p:cNvPr id="2" name="Rectangle 1">
+            <a:extLst>
+              <a:ext uri="{FF2B5EF4-FFF2-40B4-BE49-F238E27FC236}">
+                <a16:creationId xmlns:a16="http://schemas.microsoft.com/office/drawing/2014/main" id="{2FA3DB61-34CB-06DB-6755-BC10F0F1685A}"/>
+              </a:ext>
+            </a:extLst>
+          </p:cNvPr>
+          <p:cNvSpPr/>
+          <p:nvPr/>
+        </p:nvSpPr>
+        <p:spPr>
+          <a:xfrm rot="5400000">
+            <a:off x="5444907" y="3011597"/>
+            <a:ext cx="2464938" cy="749385"/>
+          </a:xfrm>
+          <a:prstGeom prst="rect">
+            <a:avLst/>
+          </a:prstGeom>
+          <a:noFill/>
+          <a:ln>
+            <a:solidFill>
+              <a:srgbClr val="FF0000"/>
+            </a:solidFill>
+          </a:ln>
+        </p:spPr>
+        <p:style>
+          <a:lnRef idx="2">
+            <a:schemeClr val="accent1">
+              <a:shade val="15000"/>
+            </a:schemeClr>
+          </a:lnRef>
+          <a:fillRef idx="1">
+            <a:schemeClr val="accent1"/>
+          </a:fillRef>
+          <a:effectRef idx="0">
+            <a:schemeClr val="accent1"/>
+          </a:effectRef>
+          <a:fontRef idx="minor">
+            <a:schemeClr val="lt1"/>
+          </a:fontRef>
+        </p:style>
+        <p:txBody>
+          <a:bodyPr rtlCol="0" anchor="ctr"/>
+          <a:lstStyle/>
+          <a:p>
+            <a:pPr algn="ctr"/>
+            <a:endParaRPr lang="fr-FR"/>
+          </a:p>
+        </p:txBody>
+      </p:sp>
+      <p:sp>
+        <p:nvSpPr>
+          <p:cNvPr id="3" name="Rectangle 2">
+            <a:extLst>
+              <a:ext uri="{FF2B5EF4-FFF2-40B4-BE49-F238E27FC236}">
+                <a16:creationId xmlns:a16="http://schemas.microsoft.com/office/drawing/2014/main" id="{80CAD147-9CAF-FE57-2B27-09706974D2B6}"/>
+              </a:ext>
+            </a:extLst>
+          </p:cNvPr>
+          <p:cNvSpPr/>
+          <p:nvPr/>
+        </p:nvSpPr>
+        <p:spPr>
+          <a:xfrm rot="5400000">
+            <a:off x="4461271" y="3028425"/>
+            <a:ext cx="2464938" cy="749385"/>
+          </a:xfrm>
+          <a:prstGeom prst="rect">
+            <a:avLst/>
+          </a:prstGeom>
+          <a:noFill/>
+          <a:ln>
+            <a:solidFill>
+              <a:srgbClr val="FFC000"/>
+            </a:solidFill>
+          </a:ln>
+        </p:spPr>
+        <p:style>
+          <a:lnRef idx="2">
+            <a:schemeClr val="accent1">
+              <a:shade val="15000"/>
+            </a:schemeClr>
+          </a:lnRef>
+          <a:fillRef idx="1">
+            <a:schemeClr val="accent1"/>
+          </a:fillRef>
+          <a:effectRef idx="0">
+            <a:schemeClr val="accent1"/>
+          </a:effectRef>
+          <a:fontRef idx="minor">
+            <a:schemeClr val="lt1"/>
+          </a:fontRef>
+        </p:style>
+        <p:txBody>
+          <a:bodyPr rtlCol="0" anchor="ctr"/>
+          <a:lstStyle/>
+          <a:p>
+            <a:pPr algn="ctr"/>
+            <a:endParaRPr lang="fr-FR"/>
+          </a:p>
+        </p:txBody>
+      </p:sp>
+      <p:sp>
+        <p:nvSpPr>
+          <p:cNvPr id="10" name="Rectangle 9">
+            <a:extLst>
+              <a:ext uri="{FF2B5EF4-FFF2-40B4-BE49-F238E27FC236}">
+                <a16:creationId xmlns:a16="http://schemas.microsoft.com/office/drawing/2014/main" id="{16FB9796-0583-CB9C-1EFA-167F88A7FC23}"/>
+              </a:ext>
+            </a:extLst>
+          </p:cNvPr>
+          <p:cNvSpPr/>
+          <p:nvPr/>
+        </p:nvSpPr>
+        <p:spPr>
+          <a:xfrm rot="5400000">
+            <a:off x="3436029" y="3042275"/>
+            <a:ext cx="2464938" cy="749385"/>
+          </a:xfrm>
+          <a:prstGeom prst="rect">
+            <a:avLst/>
+          </a:prstGeom>
+          <a:noFill/>
+          <a:ln>
+            <a:solidFill>
+              <a:srgbClr val="92D050"/>
+            </a:solidFill>
+          </a:ln>
+        </p:spPr>
+        <p:style>
+          <a:lnRef idx="2">
+            <a:schemeClr val="accent1">
+              <a:shade val="15000"/>
+            </a:schemeClr>
+          </a:lnRef>
+          <a:fillRef idx="1">
+            <a:schemeClr val="accent1"/>
+          </a:fillRef>
+          <a:effectRef idx="0">
+            <a:schemeClr val="accent1"/>
+          </a:effectRef>
+          <a:fontRef idx="minor">
+            <a:schemeClr val="lt1"/>
+          </a:fontRef>
+        </p:style>
+        <p:txBody>
+          <a:bodyPr rtlCol="0" anchor="ctr"/>
+          <a:lstStyle/>
+          <a:p>
+            <a:pPr algn="ctr"/>
+            <a:endParaRPr lang="fr-FR"/>
+          </a:p>
+        </p:txBody>
+      </p:sp>
     </p:spTree>
     <p:extLst>
       <p:ext uri="{BB962C8B-B14F-4D97-AF65-F5344CB8AC3E}">
@@ -6566,13 +6858,7 @@
   <p:cSld>
     <p:spTree>
       <p:nvGrpSpPr>
-        <p:cNvPr id="1" name="">
-          <a:extLst>
-            <a:ext uri="{FF2B5EF4-FFF2-40B4-BE49-F238E27FC236}">
-              <a16:creationId xmlns:a16="http://schemas.microsoft.com/office/drawing/2014/main" id="{14373272-B996-5683-3B1B-13E87A59F2FA}"/>
-            </a:ext>
-          </a:extLst>
-        </p:cNvPr>
+        <p:cNvPr id="1" name=""/>
         <p:cNvGrpSpPr/>
         <p:nvPr/>
       </p:nvGrpSpPr>
@@ -6586,1689 +6872,88 @@
       </p:grpSpPr>
       <p:sp>
         <p:nvSpPr>
-          <p:cNvPr id="4" name="Ellipse 3">
-            <a:extLst>
-              <a:ext uri="{FF2B5EF4-FFF2-40B4-BE49-F238E27FC236}">
-                <a16:creationId xmlns:a16="http://schemas.microsoft.com/office/drawing/2014/main" id="{F48B0356-D8AF-91BC-4776-6CFD486E57EE}"/>
-              </a:ext>
-            </a:extLst>
-          </p:cNvPr>
-          <p:cNvSpPr/>
+          <p:cNvPr id="2" name="Titre 1">
+            <a:extLst>
+              <a:ext uri="{FF2B5EF4-FFF2-40B4-BE49-F238E27FC236}">
+                <a16:creationId xmlns:a16="http://schemas.microsoft.com/office/drawing/2014/main" id="{F2B86EAC-284E-62EF-A1DD-75F70367B607}"/>
+              </a:ext>
+            </a:extLst>
+          </p:cNvPr>
+          <p:cNvSpPr>
+            <a:spLocks noGrp="1"/>
+          </p:cNvSpPr>
+          <p:nvPr>
+            <p:ph type="title"/>
+          </p:nvPr>
+        </p:nvSpPr>
+        <p:spPr/>
+        <p:txBody>
+          <a:bodyPr/>
+          <a:lstStyle/>
+          <a:p>
+            <a:endParaRPr lang="fr-FR"/>
+          </a:p>
+        </p:txBody>
+      </p:sp>
+      <p:sp>
+        <p:nvSpPr>
+          <p:cNvPr id="3" name="Espace réservé du contenu 2">
+            <a:extLst>
+              <a:ext uri="{FF2B5EF4-FFF2-40B4-BE49-F238E27FC236}">
+                <a16:creationId xmlns:a16="http://schemas.microsoft.com/office/drawing/2014/main" id="{FF90CE95-16DC-B6D8-3FDC-663FEA193625}"/>
+              </a:ext>
+            </a:extLst>
+          </p:cNvPr>
+          <p:cNvSpPr>
+            <a:spLocks noGrp="1"/>
+          </p:cNvSpPr>
+          <p:nvPr>
+            <p:ph idx="1"/>
+          </p:nvPr>
+        </p:nvSpPr>
+        <p:spPr/>
+        <p:txBody>
+          <a:bodyPr/>
+          <a:lstStyle/>
+          <a:p>
+            <a:endParaRPr lang="fr-FR"/>
+          </a:p>
+        </p:txBody>
+      </p:sp>
+      <p:pic>
+        <p:nvPicPr>
+          <p:cNvPr id="4" name="Image 3">
+            <a:extLst>
+              <a:ext uri="{FF2B5EF4-FFF2-40B4-BE49-F238E27FC236}">
+                <a16:creationId xmlns:a16="http://schemas.microsoft.com/office/drawing/2014/main" id="{E62E45A2-F502-7519-9DF8-B24A27A6AEDB}"/>
+              </a:ext>
+            </a:extLst>
+          </p:cNvPr>
+          <p:cNvPicPr>
+            <a:picLocks noChangeAspect="1"/>
+          </p:cNvPicPr>
           <p:nvPr/>
-        </p:nvSpPr>
-        <p:spPr>
-          <a:xfrm>
-            <a:off x="1034831" y="1488590"/>
-            <a:ext cx="467833" cy="467833"/>
-          </a:xfrm>
-          <a:prstGeom prst="ellipse">
-            <a:avLst/>
-          </a:prstGeom>
-          <a:solidFill>
-            <a:schemeClr val="tx2">
-              <a:lumMod val="50000"/>
-              <a:lumOff val="50000"/>
-            </a:schemeClr>
-          </a:solidFill>
-          <a:ln>
-            <a:solidFill>
-              <a:schemeClr val="tx2">
-                <a:lumMod val="50000"/>
-                <a:lumOff val="50000"/>
-              </a:schemeClr>
-            </a:solidFill>
-          </a:ln>
-        </p:spPr>
-        <p:style>
-          <a:lnRef idx="2">
-            <a:schemeClr val="accent1">
-              <a:shade val="15000"/>
-            </a:schemeClr>
-          </a:lnRef>
-          <a:fillRef idx="1">
-            <a:schemeClr val="accent1"/>
-          </a:fillRef>
-          <a:effectRef idx="0">
-            <a:schemeClr val="accent1"/>
-          </a:effectRef>
-          <a:fontRef idx="minor">
-            <a:schemeClr val="lt1"/>
-          </a:fontRef>
-        </p:style>
-        <p:txBody>
-          <a:bodyPr lIns="0" tIns="0" rIns="0" bIns="0" rtlCol="0" anchor="ctr"/>
-          <a:lstStyle/>
-          <a:p>
-            <a:pPr algn="ctr"/>
-            <a:r>
-              <a:rPr lang="fr-FR" sz="1600" dirty="0"/>
-              <a:t>E1</a:t>
-            </a:r>
-          </a:p>
-        </p:txBody>
-      </p:sp>
-      <p:sp>
-        <p:nvSpPr>
-          <p:cNvPr id="5" name="Ellipse 4">
-            <a:extLst>
-              <a:ext uri="{FF2B5EF4-FFF2-40B4-BE49-F238E27FC236}">
-                <a16:creationId xmlns:a16="http://schemas.microsoft.com/office/drawing/2014/main" id="{50C6A811-A76E-702D-DA4D-1F855DE5A503}"/>
-              </a:ext>
-            </a:extLst>
-          </p:cNvPr>
-          <p:cNvSpPr/>
-          <p:nvPr/>
-        </p:nvSpPr>
-        <p:spPr>
-          <a:xfrm>
-            <a:off x="1064002" y="2700259"/>
-            <a:ext cx="467833" cy="467833"/>
-          </a:xfrm>
-          <a:prstGeom prst="ellipse">
-            <a:avLst/>
-          </a:prstGeom>
-          <a:solidFill>
-            <a:schemeClr val="tx2">
-              <a:lumMod val="50000"/>
-              <a:lumOff val="50000"/>
-            </a:schemeClr>
-          </a:solidFill>
-          <a:ln>
-            <a:solidFill>
-              <a:schemeClr val="tx2">
-                <a:lumMod val="50000"/>
-                <a:lumOff val="50000"/>
-              </a:schemeClr>
-            </a:solidFill>
-          </a:ln>
-        </p:spPr>
-        <p:style>
-          <a:lnRef idx="2">
-            <a:schemeClr val="accent1">
-              <a:shade val="15000"/>
-            </a:schemeClr>
-          </a:lnRef>
-          <a:fillRef idx="1">
-            <a:schemeClr val="accent1"/>
-          </a:fillRef>
-          <a:effectRef idx="0">
-            <a:schemeClr val="accent1"/>
-          </a:effectRef>
-          <a:fontRef idx="minor">
-            <a:schemeClr val="lt1"/>
-          </a:fontRef>
-        </p:style>
-        <p:txBody>
-          <a:bodyPr lIns="0" tIns="0" rIns="0" bIns="0" rtlCol="0" anchor="ctr"/>
-          <a:lstStyle/>
-          <a:p>
-            <a:pPr algn="ctr"/>
-            <a:r>
-              <a:rPr lang="fr-FR" sz="1600" dirty="0"/>
-              <a:t>E2</a:t>
-            </a:r>
-          </a:p>
-        </p:txBody>
-      </p:sp>
-      <p:cxnSp>
-        <p:nvCxnSpPr>
-          <p:cNvPr id="10" name="Connecteur en angle 9">
-            <a:extLst>
-              <a:ext uri="{FF2B5EF4-FFF2-40B4-BE49-F238E27FC236}">
-                <a16:creationId xmlns:a16="http://schemas.microsoft.com/office/drawing/2014/main" id="{9CA6DD80-A5D6-7836-356E-CBA39C4FA07C}"/>
-              </a:ext>
-            </a:extLst>
-          </p:cNvPr>
-          <p:cNvCxnSpPr>
-            <a:cxnSpLocks/>
-            <a:stCxn id="4" idx="6"/>
-            <a:endCxn id="27" idx="1"/>
-          </p:cNvCxnSpPr>
-          <p:nvPr/>
-        </p:nvCxnSpPr>
-        <p:spPr>
-          <a:xfrm>
-            <a:off x="1502664" y="1722507"/>
-            <a:ext cx="2641049" cy="1654710"/>
-          </a:xfrm>
-          <a:prstGeom prst="straightConnector1">
-            <a:avLst/>
-          </a:prstGeom>
-        </p:spPr>
-        <p:style>
-          <a:lnRef idx="2">
-            <a:schemeClr val="accent1"/>
-          </a:lnRef>
-          <a:fillRef idx="0">
-            <a:schemeClr val="accent1"/>
-          </a:fillRef>
-          <a:effectRef idx="1">
-            <a:schemeClr val="accent1"/>
-          </a:effectRef>
-          <a:fontRef idx="minor">
-            <a:schemeClr val="tx1"/>
-          </a:fontRef>
-        </p:style>
-      </p:cxnSp>
-      <p:cxnSp>
-        <p:nvCxnSpPr>
-          <p:cNvPr id="11" name="Connecteur en angle 10">
-            <a:extLst>
-              <a:ext uri="{FF2B5EF4-FFF2-40B4-BE49-F238E27FC236}">
-                <a16:creationId xmlns:a16="http://schemas.microsoft.com/office/drawing/2014/main" id="{88F20B6E-FF17-0C26-B5E8-CB2436E66CD8}"/>
-              </a:ext>
-            </a:extLst>
-          </p:cNvPr>
-          <p:cNvCxnSpPr>
-            <a:cxnSpLocks/>
-            <a:stCxn id="4" idx="6"/>
-            <a:endCxn id="9" idx="1"/>
-          </p:cNvCxnSpPr>
-          <p:nvPr/>
-        </p:nvCxnSpPr>
-        <p:spPr>
-          <a:xfrm flipV="1">
-            <a:off x="1502664" y="1478019"/>
-            <a:ext cx="2598662" cy="244488"/>
-          </a:xfrm>
-          <a:prstGeom prst="straightConnector1">
-            <a:avLst/>
-          </a:prstGeom>
-        </p:spPr>
-        <p:style>
-          <a:lnRef idx="2">
-            <a:schemeClr val="accent1"/>
-          </a:lnRef>
-          <a:fillRef idx="0">
-            <a:schemeClr val="accent1"/>
-          </a:fillRef>
-          <a:effectRef idx="1">
-            <a:schemeClr val="accent1"/>
-          </a:effectRef>
-          <a:fontRef idx="minor">
-            <a:schemeClr val="tx1"/>
-          </a:fontRef>
-        </p:style>
-      </p:cxnSp>
-      <p:cxnSp>
-        <p:nvCxnSpPr>
-          <p:cNvPr id="12" name="Connecteur en angle 11">
-            <a:extLst>
-              <a:ext uri="{FF2B5EF4-FFF2-40B4-BE49-F238E27FC236}">
-                <a16:creationId xmlns:a16="http://schemas.microsoft.com/office/drawing/2014/main" id="{C7138474-8EE5-7DB9-510B-3160319059CA}"/>
-              </a:ext>
-            </a:extLst>
-          </p:cNvPr>
-          <p:cNvCxnSpPr>
-            <a:cxnSpLocks/>
-            <a:stCxn id="4" idx="6"/>
-            <a:endCxn id="17" idx="1"/>
-          </p:cNvCxnSpPr>
-          <p:nvPr/>
-        </p:nvCxnSpPr>
-        <p:spPr>
-          <a:xfrm>
-            <a:off x="1502664" y="1722507"/>
-            <a:ext cx="2625629" cy="654716"/>
-          </a:xfrm>
-          <a:prstGeom prst="straightConnector1">
-            <a:avLst/>
-          </a:prstGeom>
-        </p:spPr>
-        <p:style>
-          <a:lnRef idx="2">
-            <a:schemeClr val="accent1"/>
-          </a:lnRef>
-          <a:fillRef idx="0">
-            <a:schemeClr val="accent1"/>
-          </a:fillRef>
-          <a:effectRef idx="1">
-            <a:schemeClr val="accent1"/>
-          </a:effectRef>
-          <a:fontRef idx="minor">
-            <a:schemeClr val="tx1"/>
-          </a:fontRef>
-        </p:style>
-      </p:cxnSp>
-      <p:cxnSp>
-        <p:nvCxnSpPr>
-          <p:cNvPr id="19" name="Connecteur en angle 18">
-            <a:extLst>
-              <a:ext uri="{FF2B5EF4-FFF2-40B4-BE49-F238E27FC236}">
-                <a16:creationId xmlns:a16="http://schemas.microsoft.com/office/drawing/2014/main" id="{88C35BFB-A176-D46B-5690-006DC753287F}"/>
-              </a:ext>
-            </a:extLst>
-          </p:cNvPr>
-          <p:cNvCxnSpPr>
-            <a:cxnSpLocks/>
-            <a:stCxn id="5" idx="6"/>
-            <a:endCxn id="27" idx="1"/>
-          </p:cNvCxnSpPr>
-          <p:nvPr/>
-        </p:nvCxnSpPr>
-        <p:spPr>
-          <a:xfrm>
-            <a:off x="1531835" y="2934176"/>
-            <a:ext cx="2611878" cy="443041"/>
-          </a:xfrm>
-          <a:prstGeom prst="straightConnector1">
-            <a:avLst/>
-          </a:prstGeom>
-        </p:spPr>
-        <p:style>
-          <a:lnRef idx="2">
-            <a:schemeClr val="accent1"/>
-          </a:lnRef>
-          <a:fillRef idx="0">
-            <a:schemeClr val="accent1"/>
-          </a:fillRef>
-          <a:effectRef idx="1">
-            <a:schemeClr val="accent1"/>
-          </a:effectRef>
-          <a:fontRef idx="minor">
-            <a:schemeClr val="tx1"/>
-          </a:fontRef>
-        </p:style>
-      </p:cxnSp>
-      <p:cxnSp>
-        <p:nvCxnSpPr>
-          <p:cNvPr id="22" name="Connecteur en angle 21">
-            <a:extLst>
-              <a:ext uri="{FF2B5EF4-FFF2-40B4-BE49-F238E27FC236}">
-                <a16:creationId xmlns:a16="http://schemas.microsoft.com/office/drawing/2014/main" id="{A2C1C670-A064-71E4-07A8-34582C08D868}"/>
-              </a:ext>
-            </a:extLst>
-          </p:cNvPr>
-          <p:cNvCxnSpPr>
-            <a:cxnSpLocks/>
-            <a:stCxn id="5" idx="6"/>
-            <a:endCxn id="17" idx="1"/>
-          </p:cNvCxnSpPr>
-          <p:nvPr/>
-        </p:nvCxnSpPr>
-        <p:spPr>
-          <a:xfrm flipV="1">
-            <a:off x="1531835" y="2377223"/>
-            <a:ext cx="2596458" cy="556953"/>
-          </a:xfrm>
-          <a:prstGeom prst="straightConnector1">
-            <a:avLst/>
-          </a:prstGeom>
-        </p:spPr>
-        <p:style>
-          <a:lnRef idx="2">
-            <a:schemeClr val="accent1"/>
-          </a:lnRef>
-          <a:fillRef idx="0">
-            <a:schemeClr val="accent1"/>
-          </a:fillRef>
-          <a:effectRef idx="1">
-            <a:schemeClr val="accent1"/>
-          </a:effectRef>
-          <a:fontRef idx="minor">
-            <a:schemeClr val="tx1"/>
-          </a:fontRef>
-        </p:style>
-      </p:cxnSp>
-      <p:cxnSp>
-        <p:nvCxnSpPr>
-          <p:cNvPr id="25" name="Connecteur en angle 24">
-            <a:extLst>
-              <a:ext uri="{FF2B5EF4-FFF2-40B4-BE49-F238E27FC236}">
-                <a16:creationId xmlns:a16="http://schemas.microsoft.com/office/drawing/2014/main" id="{1336422C-FB4A-FF57-E487-13769C12418F}"/>
-              </a:ext>
-            </a:extLst>
-          </p:cNvPr>
-          <p:cNvCxnSpPr>
-            <a:cxnSpLocks/>
-            <a:stCxn id="5" idx="6"/>
-            <a:endCxn id="9" idx="1"/>
-          </p:cNvCxnSpPr>
-          <p:nvPr/>
-        </p:nvCxnSpPr>
-        <p:spPr>
-          <a:xfrm flipV="1">
-            <a:off x="1531835" y="1478019"/>
-            <a:ext cx="2569491" cy="1456157"/>
-          </a:xfrm>
-          <a:prstGeom prst="straightConnector1">
-            <a:avLst/>
-          </a:prstGeom>
-        </p:spPr>
-        <p:style>
-          <a:lnRef idx="2">
-            <a:schemeClr val="accent1"/>
-          </a:lnRef>
-          <a:fillRef idx="0">
-            <a:schemeClr val="accent1"/>
-          </a:fillRef>
-          <a:effectRef idx="1">
-            <a:schemeClr val="accent1"/>
-          </a:effectRef>
-          <a:fontRef idx="minor">
-            <a:schemeClr val="tx1"/>
-          </a:fontRef>
-        </p:style>
-      </p:cxnSp>
-      <p:sp>
-        <p:nvSpPr>
-          <p:cNvPr id="77" name="ZoneTexte 76">
-            <a:extLst>
-              <a:ext uri="{FF2B5EF4-FFF2-40B4-BE49-F238E27FC236}">
-                <a16:creationId xmlns:a16="http://schemas.microsoft.com/office/drawing/2014/main" id="{458876C5-7412-36D5-0398-EBB52369E711}"/>
-              </a:ext>
-            </a:extLst>
-          </p:cNvPr>
-          <p:cNvSpPr txBox="1"/>
-          <p:nvPr/>
-        </p:nvSpPr>
-        <p:spPr>
-          <a:xfrm>
-            <a:off x="3047864" y="3118842"/>
-            <a:ext cx="585417" cy="369332"/>
+        </p:nvPicPr>
+        <p:blipFill>
+          <a:blip r:embed="rId2"/>
+          <a:stretch>
+            <a:fillRect/>
+          </a:stretch>
+        </p:blipFill>
+        <p:spPr>
+          <a:xfrm>
+            <a:off x="2609850" y="1504950"/>
+            <a:ext cx="6972300" cy="3848100"/>
           </a:xfrm>
           <a:prstGeom prst="rect">
             <a:avLst/>
           </a:prstGeom>
-          <a:solidFill>
-            <a:schemeClr val="bg1">
-              <a:lumMod val="95000"/>
-              <a:alpha val="69995"/>
-            </a:schemeClr>
-          </a:solidFill>
-        </p:spPr>
-        <p:txBody>
-          <a:bodyPr wrap="none" rtlCol="0">
-            <a:spAutoFit/>
-          </a:bodyPr>
-          <a:lstStyle/>
-          <a:p>
-            <a:r>
-              <a:rPr lang="fr-FR" dirty="0"/>
-              <a:t>W</a:t>
-            </a:r>
-            <a:r>
-              <a:rPr lang="fr-FR" sz="1200" dirty="0"/>
-              <a:t>2 1</a:t>
-            </a:r>
-            <a:endParaRPr lang="fr-FR" dirty="0"/>
-          </a:p>
-        </p:txBody>
-      </p:sp>
-      <p:sp>
-        <p:nvSpPr>
-          <p:cNvPr id="78" name="ZoneTexte 77">
-            <a:extLst>
-              <a:ext uri="{FF2B5EF4-FFF2-40B4-BE49-F238E27FC236}">
-                <a16:creationId xmlns:a16="http://schemas.microsoft.com/office/drawing/2014/main" id="{ABAAD53A-8937-7125-4F09-9B4F9C6B98AD}"/>
-              </a:ext>
-            </a:extLst>
-          </p:cNvPr>
-          <p:cNvSpPr txBox="1"/>
-          <p:nvPr/>
-        </p:nvSpPr>
-        <p:spPr>
-          <a:xfrm>
-            <a:off x="3031834" y="2024232"/>
-            <a:ext cx="617477" cy="369332"/>
-          </a:xfrm>
-          <a:prstGeom prst="rect">
-            <a:avLst/>
-          </a:prstGeom>
-          <a:solidFill>
-            <a:schemeClr val="bg1">
-              <a:lumMod val="95000"/>
-              <a:alpha val="71072"/>
-            </a:schemeClr>
-          </a:solidFill>
-        </p:spPr>
-        <p:txBody>
-          <a:bodyPr wrap="none" rtlCol="0">
-            <a:spAutoFit/>
-          </a:bodyPr>
-          <a:lstStyle/>
-          <a:p>
-            <a:r>
-              <a:rPr lang="fr-FR" dirty="0"/>
-              <a:t>W</a:t>
-            </a:r>
-            <a:r>
-              <a:rPr lang="fr-FR" sz="1200" dirty="0"/>
-              <a:t>1  2</a:t>
-            </a:r>
-            <a:endParaRPr lang="fr-FR" dirty="0"/>
-          </a:p>
-        </p:txBody>
-      </p:sp>
-      <p:sp>
-        <p:nvSpPr>
-          <p:cNvPr id="79" name="ZoneTexte 78">
-            <a:extLst>
-              <a:ext uri="{FF2B5EF4-FFF2-40B4-BE49-F238E27FC236}">
-                <a16:creationId xmlns:a16="http://schemas.microsoft.com/office/drawing/2014/main" id="{E07C2E40-8F59-5494-8461-F2E775B6E17B}"/>
-              </a:ext>
-            </a:extLst>
-          </p:cNvPr>
-          <p:cNvSpPr txBox="1"/>
-          <p:nvPr/>
-        </p:nvSpPr>
-        <p:spPr>
-          <a:xfrm>
-            <a:off x="3031834" y="2288853"/>
-            <a:ext cx="617477" cy="369332"/>
-          </a:xfrm>
-          <a:prstGeom prst="rect">
-            <a:avLst/>
-          </a:prstGeom>
-          <a:solidFill>
-            <a:schemeClr val="bg1">
-              <a:lumMod val="95000"/>
-              <a:alpha val="69596"/>
-            </a:schemeClr>
-          </a:solidFill>
-        </p:spPr>
-        <p:txBody>
-          <a:bodyPr wrap="none" rtlCol="0">
-            <a:spAutoFit/>
-          </a:bodyPr>
-          <a:lstStyle/>
-          <a:p>
-            <a:r>
-              <a:rPr lang="fr-FR" dirty="0"/>
-              <a:t>W</a:t>
-            </a:r>
-            <a:r>
-              <a:rPr lang="fr-FR" sz="1200" dirty="0"/>
-              <a:t>2  2</a:t>
-            </a:r>
-            <a:endParaRPr lang="fr-FR" dirty="0"/>
-          </a:p>
-        </p:txBody>
-      </p:sp>
-      <p:sp>
-        <p:nvSpPr>
-          <p:cNvPr id="80" name="ZoneTexte 79">
-            <a:extLst>
-              <a:ext uri="{FF2B5EF4-FFF2-40B4-BE49-F238E27FC236}">
-                <a16:creationId xmlns:a16="http://schemas.microsoft.com/office/drawing/2014/main" id="{EF11B74F-17F1-7D95-E815-AF6652F1DB30}"/>
-              </a:ext>
-            </a:extLst>
-          </p:cNvPr>
-          <p:cNvSpPr txBox="1"/>
-          <p:nvPr/>
-        </p:nvSpPr>
-        <p:spPr>
-          <a:xfrm>
-            <a:off x="3031834" y="1168509"/>
-            <a:ext cx="617477" cy="369332"/>
-          </a:xfrm>
-          <a:prstGeom prst="rect">
-            <a:avLst/>
-          </a:prstGeom>
-          <a:solidFill>
-            <a:schemeClr val="bg1">
-              <a:lumMod val="95000"/>
-              <a:alpha val="70000"/>
-            </a:schemeClr>
-          </a:solidFill>
-        </p:spPr>
-        <p:txBody>
-          <a:bodyPr wrap="none" rtlCol="0">
-            <a:spAutoFit/>
-          </a:bodyPr>
-          <a:lstStyle/>
-          <a:p>
-            <a:r>
-              <a:rPr lang="fr-FR" dirty="0"/>
-              <a:t>W</a:t>
-            </a:r>
-            <a:r>
-              <a:rPr lang="fr-FR" sz="1200" dirty="0"/>
-              <a:t>1  3</a:t>
-            </a:r>
-            <a:endParaRPr lang="fr-FR" dirty="0"/>
-          </a:p>
-        </p:txBody>
-      </p:sp>
-      <p:sp>
-        <p:nvSpPr>
-          <p:cNvPr id="81" name="ZoneTexte 80">
-            <a:extLst>
-              <a:ext uri="{FF2B5EF4-FFF2-40B4-BE49-F238E27FC236}">
-                <a16:creationId xmlns:a16="http://schemas.microsoft.com/office/drawing/2014/main" id="{9FF5E186-1428-1DAC-7A5D-3103C7311391}"/>
-              </a:ext>
-            </a:extLst>
-          </p:cNvPr>
-          <p:cNvSpPr txBox="1"/>
-          <p:nvPr/>
-        </p:nvSpPr>
-        <p:spPr>
-          <a:xfrm>
-            <a:off x="3031834" y="1623658"/>
-            <a:ext cx="617477" cy="369332"/>
-          </a:xfrm>
-          <a:prstGeom prst="rect">
-            <a:avLst/>
-          </a:prstGeom>
-          <a:solidFill>
-            <a:schemeClr val="bg1">
-              <a:lumMod val="95000"/>
-              <a:alpha val="71012"/>
-            </a:schemeClr>
-          </a:solidFill>
-        </p:spPr>
-        <p:txBody>
-          <a:bodyPr wrap="none" rtlCol="0">
-            <a:spAutoFit/>
-          </a:bodyPr>
-          <a:lstStyle/>
-          <a:p>
-            <a:r>
-              <a:rPr lang="fr-FR" dirty="0"/>
-              <a:t>W</a:t>
-            </a:r>
-            <a:r>
-              <a:rPr lang="fr-FR" sz="1200" dirty="0"/>
-              <a:t>2  3</a:t>
-            </a:r>
-            <a:endParaRPr lang="fr-FR" dirty="0"/>
-          </a:p>
-        </p:txBody>
-      </p:sp>
-      <p:sp>
-        <p:nvSpPr>
-          <p:cNvPr id="76" name="ZoneTexte 75">
-            <a:extLst>
-              <a:ext uri="{FF2B5EF4-FFF2-40B4-BE49-F238E27FC236}">
-                <a16:creationId xmlns:a16="http://schemas.microsoft.com/office/drawing/2014/main" id="{A95F3F2D-688F-3082-9585-C96BA1C33EFA}"/>
-              </a:ext>
-            </a:extLst>
-          </p:cNvPr>
-          <p:cNvSpPr txBox="1"/>
-          <p:nvPr/>
-        </p:nvSpPr>
-        <p:spPr>
-          <a:xfrm>
-            <a:off x="3035537" y="2712307"/>
-            <a:ext cx="610070" cy="369332"/>
-          </a:xfrm>
-          <a:prstGeom prst="rect">
-            <a:avLst/>
-          </a:prstGeom>
-          <a:solidFill>
-            <a:schemeClr val="bg2">
-              <a:alpha val="56121"/>
-            </a:schemeClr>
-          </a:solidFill>
-        </p:spPr>
-        <p:txBody>
-          <a:bodyPr wrap="square" rtlCol="0">
-            <a:spAutoFit/>
-          </a:bodyPr>
-          <a:lstStyle/>
-          <a:p>
-            <a:r>
-              <a:rPr lang="fr-FR" dirty="0"/>
-              <a:t>W</a:t>
-            </a:r>
-            <a:r>
-              <a:rPr lang="fr-FR" sz="1200" dirty="0"/>
-              <a:t>1 1</a:t>
-            </a:r>
-            <a:endParaRPr lang="fr-FR" dirty="0"/>
-          </a:p>
-        </p:txBody>
-      </p:sp>
-      <p:sp>
-        <p:nvSpPr>
-          <p:cNvPr id="3" name="Ellipse 2">
-            <a:extLst>
-              <a:ext uri="{FF2B5EF4-FFF2-40B4-BE49-F238E27FC236}">
-                <a16:creationId xmlns:a16="http://schemas.microsoft.com/office/drawing/2014/main" id="{91CC4009-725A-77A3-EEE4-667E529096F9}"/>
-              </a:ext>
-            </a:extLst>
-          </p:cNvPr>
-          <p:cNvSpPr/>
-          <p:nvPr/>
-        </p:nvSpPr>
-        <p:spPr>
-          <a:xfrm>
-            <a:off x="7558785" y="3909621"/>
-            <a:ext cx="467833" cy="467833"/>
-          </a:xfrm>
-          <a:prstGeom prst="ellipse">
-            <a:avLst/>
-          </a:prstGeom>
-          <a:solidFill>
-            <a:schemeClr val="tx2">
-              <a:lumMod val="50000"/>
-              <a:lumOff val="50000"/>
-            </a:schemeClr>
-          </a:solidFill>
-          <a:ln>
-            <a:solidFill>
-              <a:schemeClr val="tx2">
-                <a:lumMod val="50000"/>
-                <a:lumOff val="50000"/>
-              </a:schemeClr>
-            </a:solidFill>
-          </a:ln>
-        </p:spPr>
-        <p:style>
-          <a:lnRef idx="2">
-            <a:schemeClr val="accent1">
-              <a:shade val="15000"/>
-            </a:schemeClr>
-          </a:lnRef>
-          <a:fillRef idx="1">
-            <a:schemeClr val="accent1"/>
-          </a:fillRef>
-          <a:effectRef idx="0">
-            <a:schemeClr val="accent1"/>
-          </a:effectRef>
-          <a:fontRef idx="minor">
-            <a:schemeClr val="lt1"/>
-          </a:fontRef>
-        </p:style>
-        <p:txBody>
-          <a:bodyPr lIns="0" tIns="0" rIns="0" bIns="0" rtlCol="0" anchor="ctr"/>
-          <a:lstStyle/>
-          <a:p>
-            <a:pPr algn="ctr"/>
-            <a:r>
-              <a:rPr lang="fr-FR" sz="1600" dirty="0"/>
-              <a:t>s3</a:t>
-            </a:r>
-          </a:p>
-        </p:txBody>
-      </p:sp>
-      <p:sp>
-        <p:nvSpPr>
-          <p:cNvPr id="9" name="Rectangle 8">
-            <a:extLst>
-              <a:ext uri="{FF2B5EF4-FFF2-40B4-BE49-F238E27FC236}">
-                <a16:creationId xmlns:a16="http://schemas.microsoft.com/office/drawing/2014/main" id="{9E3FF7E1-D7CE-A97E-0830-B4FB1F034C41}"/>
-              </a:ext>
-            </a:extLst>
-          </p:cNvPr>
-          <p:cNvSpPr/>
-          <p:nvPr/>
-        </p:nvSpPr>
-        <p:spPr>
-          <a:xfrm>
-            <a:off x="4101326" y="1222837"/>
-            <a:ext cx="587269" cy="510363"/>
-          </a:xfrm>
-          <a:prstGeom prst="rect">
-            <a:avLst/>
-          </a:prstGeom>
-          <a:noFill/>
-          <a:ln>
-            <a:solidFill>
-              <a:srgbClr val="FF0000"/>
-            </a:solidFill>
-          </a:ln>
-        </p:spPr>
-        <p:style>
-          <a:lnRef idx="2">
-            <a:schemeClr val="accent1">
-              <a:shade val="15000"/>
-            </a:schemeClr>
-          </a:lnRef>
-          <a:fillRef idx="1">
-            <a:schemeClr val="accent1"/>
-          </a:fillRef>
-          <a:effectRef idx="0">
-            <a:schemeClr val="accent1"/>
-          </a:effectRef>
-          <a:fontRef idx="minor">
-            <a:schemeClr val="lt1"/>
-          </a:fontRef>
-        </p:style>
-        <p:txBody>
-          <a:bodyPr rtlCol="0" anchor="ctr"/>
-          <a:lstStyle/>
-          <a:p>
-            <a:pPr algn="ctr"/>
-            <a:endParaRPr lang="fr-FR"/>
-          </a:p>
-        </p:txBody>
-      </p:sp>
-      <p:sp>
-        <p:nvSpPr>
-          <p:cNvPr id="13" name="Ellipse 12">
-            <a:extLst>
-              <a:ext uri="{FF2B5EF4-FFF2-40B4-BE49-F238E27FC236}">
-                <a16:creationId xmlns:a16="http://schemas.microsoft.com/office/drawing/2014/main" id="{57A60CF6-8702-1CEA-3E4C-4A1CD55A69CA}"/>
-              </a:ext>
-            </a:extLst>
-          </p:cNvPr>
-          <p:cNvSpPr/>
-          <p:nvPr/>
-        </p:nvSpPr>
-        <p:spPr>
-          <a:xfrm>
-            <a:off x="6581114" y="3937330"/>
-            <a:ext cx="467833" cy="467833"/>
-          </a:xfrm>
-          <a:prstGeom prst="ellipse">
-            <a:avLst/>
-          </a:prstGeom>
-          <a:solidFill>
-            <a:schemeClr val="tx2">
-              <a:lumMod val="50000"/>
-              <a:lumOff val="50000"/>
-            </a:schemeClr>
-          </a:solidFill>
-          <a:ln>
-            <a:solidFill>
-              <a:schemeClr val="tx2">
-                <a:lumMod val="50000"/>
-                <a:lumOff val="50000"/>
-              </a:schemeClr>
-            </a:solidFill>
-          </a:ln>
-        </p:spPr>
-        <p:style>
-          <a:lnRef idx="2">
-            <a:schemeClr val="accent1">
-              <a:shade val="15000"/>
-            </a:schemeClr>
-          </a:lnRef>
-          <a:fillRef idx="1">
-            <a:schemeClr val="accent1"/>
-          </a:fillRef>
-          <a:effectRef idx="0">
-            <a:schemeClr val="accent1"/>
-          </a:effectRef>
-          <a:fontRef idx="minor">
-            <a:schemeClr val="lt1"/>
-          </a:fontRef>
-        </p:style>
-        <p:txBody>
-          <a:bodyPr lIns="0" tIns="0" rIns="0" bIns="0" rtlCol="0" anchor="ctr"/>
-          <a:lstStyle/>
-          <a:p>
-            <a:pPr algn="ctr"/>
-            <a:r>
-              <a:rPr lang="fr-FR" sz="1600" dirty="0"/>
-              <a:t>s2</a:t>
-            </a:r>
-          </a:p>
-        </p:txBody>
-      </p:sp>
-      <p:sp>
-        <p:nvSpPr>
-          <p:cNvPr id="14" name="Ellipse 13">
-            <a:extLst>
-              <a:ext uri="{FF2B5EF4-FFF2-40B4-BE49-F238E27FC236}">
-                <a16:creationId xmlns:a16="http://schemas.microsoft.com/office/drawing/2014/main" id="{5438B2DD-65A7-D5A6-4E30-D8BF01E57D34}"/>
-              </a:ext>
-            </a:extLst>
-          </p:cNvPr>
-          <p:cNvSpPr/>
-          <p:nvPr/>
-        </p:nvSpPr>
-        <p:spPr>
-          <a:xfrm>
-            <a:off x="5656048" y="3920767"/>
-            <a:ext cx="467833" cy="467833"/>
-          </a:xfrm>
-          <a:prstGeom prst="ellipse">
-            <a:avLst/>
-          </a:prstGeom>
-          <a:solidFill>
-            <a:schemeClr val="tx2">
-              <a:lumMod val="50000"/>
-              <a:lumOff val="50000"/>
-            </a:schemeClr>
-          </a:solidFill>
-          <a:ln>
-            <a:solidFill>
-              <a:schemeClr val="tx2">
-                <a:lumMod val="50000"/>
-                <a:lumOff val="50000"/>
-              </a:schemeClr>
-            </a:solidFill>
-          </a:ln>
-        </p:spPr>
-        <p:style>
-          <a:lnRef idx="2">
-            <a:schemeClr val="accent1">
-              <a:shade val="15000"/>
-            </a:schemeClr>
-          </a:lnRef>
-          <a:fillRef idx="1">
-            <a:schemeClr val="accent1"/>
-          </a:fillRef>
-          <a:effectRef idx="0">
-            <a:schemeClr val="accent1"/>
-          </a:effectRef>
-          <a:fontRef idx="minor">
-            <a:schemeClr val="lt1"/>
-          </a:fontRef>
-        </p:style>
-        <p:txBody>
-          <a:bodyPr lIns="0" tIns="0" rIns="0" bIns="0" rtlCol="0" anchor="ctr"/>
-          <a:lstStyle/>
-          <a:p>
-            <a:pPr algn="ctr"/>
-            <a:r>
-              <a:rPr lang="fr-FR" sz="1600" dirty="0"/>
-              <a:t>S1</a:t>
-            </a:r>
-          </a:p>
-        </p:txBody>
-      </p:sp>
-      <p:sp>
-        <p:nvSpPr>
-          <p:cNvPr id="17" name="Rectangle 16">
-            <a:extLst>
-              <a:ext uri="{FF2B5EF4-FFF2-40B4-BE49-F238E27FC236}">
-                <a16:creationId xmlns:a16="http://schemas.microsoft.com/office/drawing/2014/main" id="{33FF0AFC-0FE4-07C5-BA85-34110FA42229}"/>
-              </a:ext>
-            </a:extLst>
-          </p:cNvPr>
-          <p:cNvSpPr/>
-          <p:nvPr/>
-        </p:nvSpPr>
-        <p:spPr>
-          <a:xfrm>
-            <a:off x="4128293" y="2122041"/>
-            <a:ext cx="587269" cy="510363"/>
-          </a:xfrm>
-          <a:prstGeom prst="rect">
-            <a:avLst/>
-          </a:prstGeom>
-          <a:noFill/>
-          <a:ln>
-            <a:solidFill>
-              <a:srgbClr val="FFC000"/>
-            </a:solidFill>
-          </a:ln>
-        </p:spPr>
-        <p:style>
-          <a:lnRef idx="2">
-            <a:schemeClr val="accent1">
-              <a:shade val="15000"/>
-            </a:schemeClr>
-          </a:lnRef>
-          <a:fillRef idx="1">
-            <a:schemeClr val="accent1"/>
-          </a:fillRef>
-          <a:effectRef idx="0">
-            <a:schemeClr val="accent1"/>
-          </a:effectRef>
-          <a:fontRef idx="minor">
-            <a:schemeClr val="lt1"/>
-          </a:fontRef>
-        </p:style>
-        <p:txBody>
-          <a:bodyPr rtlCol="0" anchor="ctr"/>
-          <a:lstStyle/>
-          <a:p>
-            <a:pPr algn="ctr"/>
-            <a:endParaRPr lang="fr-FR"/>
-          </a:p>
-        </p:txBody>
-      </p:sp>
-      <p:sp>
-        <p:nvSpPr>
-          <p:cNvPr id="27" name="Rectangle 26">
-            <a:extLst>
-              <a:ext uri="{FF2B5EF4-FFF2-40B4-BE49-F238E27FC236}">
-                <a16:creationId xmlns:a16="http://schemas.microsoft.com/office/drawing/2014/main" id="{984137C5-2372-EA5B-9502-A7B497B20766}"/>
-              </a:ext>
-            </a:extLst>
-          </p:cNvPr>
-          <p:cNvSpPr/>
-          <p:nvPr/>
-        </p:nvSpPr>
-        <p:spPr>
-          <a:xfrm>
-            <a:off x="4143713" y="3122035"/>
-            <a:ext cx="587269" cy="510363"/>
-          </a:xfrm>
-          <a:prstGeom prst="rect">
-            <a:avLst/>
-          </a:prstGeom>
-          <a:noFill/>
-          <a:ln>
-            <a:solidFill>
-              <a:srgbClr val="92D050"/>
-            </a:solidFill>
-          </a:ln>
-        </p:spPr>
-        <p:style>
-          <a:lnRef idx="2">
-            <a:schemeClr val="accent1">
-              <a:shade val="15000"/>
-            </a:schemeClr>
-          </a:lnRef>
-          <a:fillRef idx="1">
-            <a:schemeClr val="accent1"/>
-          </a:fillRef>
-          <a:effectRef idx="0">
-            <a:schemeClr val="accent1"/>
-          </a:effectRef>
-          <a:fontRef idx="minor">
-            <a:schemeClr val="lt1"/>
-          </a:fontRef>
-        </p:style>
-        <p:txBody>
-          <a:bodyPr rtlCol="0" anchor="ctr"/>
-          <a:lstStyle/>
-          <a:p>
-            <a:pPr algn="ctr"/>
-            <a:endParaRPr lang="fr-FR"/>
-          </a:p>
-        </p:txBody>
-      </p:sp>
-      <p:cxnSp>
-        <p:nvCxnSpPr>
-          <p:cNvPr id="39" name="Connecteur en angle 10">
-            <a:extLst>
-              <a:ext uri="{FF2B5EF4-FFF2-40B4-BE49-F238E27FC236}">
-                <a16:creationId xmlns:a16="http://schemas.microsoft.com/office/drawing/2014/main" id="{0E345B31-338E-2280-5794-ECBD8E70B250}"/>
-              </a:ext>
-            </a:extLst>
-          </p:cNvPr>
-          <p:cNvCxnSpPr>
-            <a:cxnSpLocks/>
-            <a:stCxn id="17" idx="3"/>
-            <a:endCxn id="13" idx="0"/>
-          </p:cNvCxnSpPr>
-          <p:nvPr/>
-        </p:nvCxnSpPr>
-        <p:spPr>
-          <a:xfrm>
-            <a:off x="4715562" y="2377223"/>
-            <a:ext cx="2099469" cy="1560107"/>
-          </a:xfrm>
-          <a:prstGeom prst="bentConnector2">
-            <a:avLst/>
-          </a:prstGeom>
-        </p:spPr>
-        <p:style>
-          <a:lnRef idx="2">
-            <a:schemeClr val="accent1"/>
-          </a:lnRef>
-          <a:fillRef idx="0">
-            <a:schemeClr val="accent1"/>
-          </a:fillRef>
-          <a:effectRef idx="1">
-            <a:schemeClr val="accent1"/>
-          </a:effectRef>
-          <a:fontRef idx="minor">
-            <a:schemeClr val="tx1"/>
-          </a:fontRef>
-        </p:style>
-      </p:cxnSp>
-      <p:cxnSp>
-        <p:nvCxnSpPr>
-          <p:cNvPr id="42" name="Connecteur en angle 10">
-            <a:extLst>
-              <a:ext uri="{FF2B5EF4-FFF2-40B4-BE49-F238E27FC236}">
-                <a16:creationId xmlns:a16="http://schemas.microsoft.com/office/drawing/2014/main" id="{7A465D79-E8F2-CCE3-29B0-F0249C0C88A5}"/>
-              </a:ext>
-            </a:extLst>
-          </p:cNvPr>
-          <p:cNvCxnSpPr>
-            <a:cxnSpLocks/>
-            <a:stCxn id="27" idx="3"/>
-            <a:endCxn id="14" idx="0"/>
-          </p:cNvCxnSpPr>
-          <p:nvPr/>
-        </p:nvCxnSpPr>
-        <p:spPr>
-          <a:xfrm>
-            <a:off x="4730982" y="3377217"/>
-            <a:ext cx="1158983" cy="543550"/>
-          </a:xfrm>
-          <a:prstGeom prst="bentConnector2">
-            <a:avLst/>
-          </a:prstGeom>
-        </p:spPr>
-        <p:style>
-          <a:lnRef idx="2">
-            <a:schemeClr val="accent1"/>
-          </a:lnRef>
-          <a:fillRef idx="0">
-            <a:schemeClr val="accent1"/>
-          </a:fillRef>
-          <a:effectRef idx="1">
-            <a:schemeClr val="accent1"/>
-          </a:effectRef>
-          <a:fontRef idx="minor">
-            <a:schemeClr val="tx1"/>
-          </a:fontRef>
-        </p:style>
-      </p:cxnSp>
-      <p:sp>
-        <p:nvSpPr>
-          <p:cNvPr id="47" name="ZoneTexte 46">
-            <a:extLst>
-              <a:ext uri="{FF2B5EF4-FFF2-40B4-BE49-F238E27FC236}">
-                <a16:creationId xmlns:a16="http://schemas.microsoft.com/office/drawing/2014/main" id="{4EAF8AB6-30F9-4276-4471-3F8562D672BB}"/>
-              </a:ext>
-            </a:extLst>
-          </p:cNvPr>
-          <p:cNvSpPr txBox="1"/>
-          <p:nvPr/>
-        </p:nvSpPr>
-        <p:spPr>
-          <a:xfrm>
-            <a:off x="4226055" y="1218489"/>
-            <a:ext cx="346570" cy="461665"/>
-          </a:xfrm>
-          <a:prstGeom prst="rect">
-            <a:avLst/>
-          </a:prstGeom>
-          <a:noFill/>
-        </p:spPr>
-        <p:txBody>
-          <a:bodyPr wrap="none" rtlCol="0">
-            <a:spAutoFit/>
-          </a:bodyPr>
-          <a:lstStyle/>
-          <a:p>
-            <a:r>
-              <a:rPr lang="fr-FR" sz="2400" dirty="0"/>
-              <a:t>∑</a:t>
-            </a:r>
-          </a:p>
-        </p:txBody>
-      </p:sp>
-      <p:sp>
-        <p:nvSpPr>
-          <p:cNvPr id="48" name="ZoneTexte 47">
-            <a:extLst>
-              <a:ext uri="{FF2B5EF4-FFF2-40B4-BE49-F238E27FC236}">
-                <a16:creationId xmlns:a16="http://schemas.microsoft.com/office/drawing/2014/main" id="{4CE9383F-BFC5-4EE8-0FAB-840E07171D96}"/>
-              </a:ext>
-            </a:extLst>
-          </p:cNvPr>
-          <p:cNvSpPr txBox="1"/>
-          <p:nvPr/>
-        </p:nvSpPr>
-        <p:spPr>
-          <a:xfrm>
-            <a:off x="4269244" y="3114949"/>
-            <a:ext cx="346570" cy="461665"/>
-          </a:xfrm>
-          <a:prstGeom prst="rect">
-            <a:avLst/>
-          </a:prstGeom>
-          <a:noFill/>
-        </p:spPr>
-        <p:txBody>
-          <a:bodyPr wrap="none" rtlCol="0">
-            <a:spAutoFit/>
-          </a:bodyPr>
-          <a:lstStyle/>
-          <a:p>
-            <a:r>
-              <a:rPr lang="fr-FR" sz="2400" dirty="0"/>
-              <a:t>∑</a:t>
-            </a:r>
-          </a:p>
-        </p:txBody>
-      </p:sp>
-      <p:sp>
-        <p:nvSpPr>
-          <p:cNvPr id="49" name="ZoneTexte 48">
-            <a:extLst>
-              <a:ext uri="{FF2B5EF4-FFF2-40B4-BE49-F238E27FC236}">
-                <a16:creationId xmlns:a16="http://schemas.microsoft.com/office/drawing/2014/main" id="{E4318403-FF95-8191-B277-7E9DAE34F2E8}"/>
-              </a:ext>
-            </a:extLst>
-          </p:cNvPr>
-          <p:cNvSpPr txBox="1"/>
-          <p:nvPr/>
-        </p:nvSpPr>
-        <p:spPr>
-          <a:xfrm>
-            <a:off x="4270690" y="2177406"/>
-            <a:ext cx="346570" cy="461665"/>
-          </a:xfrm>
-          <a:prstGeom prst="rect">
-            <a:avLst/>
-          </a:prstGeom>
-          <a:noFill/>
-        </p:spPr>
-        <p:txBody>
-          <a:bodyPr wrap="none" rtlCol="0">
-            <a:spAutoFit/>
-          </a:bodyPr>
-          <a:lstStyle/>
-          <a:p>
-            <a:r>
-              <a:rPr lang="fr-FR" sz="2400" dirty="0"/>
-              <a:t>∑</a:t>
-            </a:r>
-          </a:p>
-        </p:txBody>
-      </p:sp>
-      <p:sp>
-        <p:nvSpPr>
-          <p:cNvPr id="51" name="ZoneTexte 50">
-            <a:extLst>
-              <a:ext uri="{FF2B5EF4-FFF2-40B4-BE49-F238E27FC236}">
-                <a16:creationId xmlns:a16="http://schemas.microsoft.com/office/drawing/2014/main" id="{0E5F238F-367E-A687-CC60-D25429F8E6F0}"/>
-              </a:ext>
-            </a:extLst>
-          </p:cNvPr>
-          <p:cNvSpPr txBox="1"/>
-          <p:nvPr/>
-        </p:nvSpPr>
-        <p:spPr>
-          <a:xfrm>
-            <a:off x="6513505" y="740373"/>
-            <a:ext cx="603050" cy="369332"/>
-          </a:xfrm>
-          <a:prstGeom prst="rect">
-            <a:avLst/>
-          </a:prstGeom>
-          <a:noFill/>
-        </p:spPr>
-        <p:txBody>
-          <a:bodyPr wrap="none" rtlCol="0">
-            <a:spAutoFit/>
-          </a:bodyPr>
-          <a:lstStyle/>
-          <a:p>
-            <a:r>
-              <a:rPr lang="fr-FR" dirty="0"/>
-              <a:t>0 / 1</a:t>
-            </a:r>
-          </a:p>
-        </p:txBody>
-      </p:sp>
-      <p:sp>
-        <p:nvSpPr>
-          <p:cNvPr id="52" name="ZoneTexte 51">
-            <a:extLst>
-              <a:ext uri="{FF2B5EF4-FFF2-40B4-BE49-F238E27FC236}">
-                <a16:creationId xmlns:a16="http://schemas.microsoft.com/office/drawing/2014/main" id="{D90273BB-A92E-A48F-0A16-321EC6DB8F54}"/>
-              </a:ext>
-            </a:extLst>
-          </p:cNvPr>
-          <p:cNvSpPr txBox="1"/>
-          <p:nvPr/>
-        </p:nvSpPr>
-        <p:spPr>
-          <a:xfrm>
-            <a:off x="1064002" y="741391"/>
-            <a:ext cx="603050" cy="369332"/>
-          </a:xfrm>
-          <a:prstGeom prst="rect">
-            <a:avLst/>
-          </a:prstGeom>
-          <a:noFill/>
-        </p:spPr>
-        <p:txBody>
-          <a:bodyPr wrap="none" rtlCol="0">
-            <a:spAutoFit/>
-          </a:bodyPr>
-          <a:lstStyle/>
-          <a:p>
-            <a:r>
-              <a:rPr lang="fr-FR" dirty="0"/>
-              <a:t>0 / 1</a:t>
-            </a:r>
-          </a:p>
-        </p:txBody>
-      </p:sp>
-      <p:sp>
-        <p:nvSpPr>
-          <p:cNvPr id="53" name="ZoneTexte 52">
-            <a:extLst>
-              <a:ext uri="{FF2B5EF4-FFF2-40B4-BE49-F238E27FC236}">
-                <a16:creationId xmlns:a16="http://schemas.microsoft.com/office/drawing/2014/main" id="{BAAB3AA3-0B71-52A9-4264-8CE864C562DF}"/>
-              </a:ext>
-            </a:extLst>
-          </p:cNvPr>
-          <p:cNvSpPr txBox="1"/>
-          <p:nvPr/>
-        </p:nvSpPr>
-        <p:spPr>
-          <a:xfrm>
-            <a:off x="3858775" y="741391"/>
-            <a:ext cx="939681" cy="369332"/>
-          </a:xfrm>
-          <a:prstGeom prst="rect">
-            <a:avLst/>
-          </a:prstGeom>
-          <a:noFill/>
-        </p:spPr>
-        <p:txBody>
-          <a:bodyPr wrap="none" rtlCol="0">
-            <a:spAutoFit/>
-          </a:bodyPr>
-          <a:lstStyle/>
-          <a:p>
-            <a:r>
-              <a:rPr lang="fr-FR" dirty="0"/>
-              <a:t>somme</a:t>
-            </a:r>
-          </a:p>
-        </p:txBody>
-      </p:sp>
-      <p:sp>
-        <p:nvSpPr>
-          <p:cNvPr id="54" name="ZoneTexte 53">
-            <a:extLst>
-              <a:ext uri="{FF2B5EF4-FFF2-40B4-BE49-F238E27FC236}">
-                <a16:creationId xmlns:a16="http://schemas.microsoft.com/office/drawing/2014/main" id="{86AA09F2-9C5B-8DA4-9746-A9635449D524}"/>
-              </a:ext>
-            </a:extLst>
-          </p:cNvPr>
-          <p:cNvSpPr txBox="1"/>
-          <p:nvPr/>
-        </p:nvSpPr>
-        <p:spPr>
-          <a:xfrm>
-            <a:off x="4853251" y="741391"/>
-            <a:ext cx="660758" cy="369332"/>
-          </a:xfrm>
-          <a:prstGeom prst="rect">
-            <a:avLst/>
-          </a:prstGeom>
-          <a:noFill/>
-        </p:spPr>
-        <p:txBody>
-          <a:bodyPr wrap="none" rtlCol="0">
-            <a:spAutoFit/>
-          </a:bodyPr>
-          <a:lstStyle/>
-          <a:p>
-            <a:r>
-              <a:rPr lang="fr-FR" dirty="0"/>
-              <a:t>seuil</a:t>
-            </a:r>
-          </a:p>
-        </p:txBody>
-      </p:sp>
-      <p:sp>
-        <p:nvSpPr>
-          <p:cNvPr id="55" name="ZoneTexte 54">
-            <a:extLst>
-              <a:ext uri="{FF2B5EF4-FFF2-40B4-BE49-F238E27FC236}">
-                <a16:creationId xmlns:a16="http://schemas.microsoft.com/office/drawing/2014/main" id="{81F13F09-9D55-5B45-D6C6-4B09C54E0D1E}"/>
-              </a:ext>
-            </a:extLst>
-          </p:cNvPr>
-          <p:cNvSpPr txBox="1"/>
-          <p:nvPr/>
-        </p:nvSpPr>
-        <p:spPr>
-          <a:xfrm>
-            <a:off x="2883637" y="741391"/>
-            <a:ext cx="873957" cy="369332"/>
-          </a:xfrm>
-          <a:prstGeom prst="rect">
-            <a:avLst/>
-          </a:prstGeom>
-          <a:noFill/>
-        </p:spPr>
-        <p:txBody>
-          <a:bodyPr wrap="none" rtlCol="0">
-            <a:spAutoFit/>
-          </a:bodyPr>
-          <a:lstStyle/>
-          <a:p>
-            <a:r>
-              <a:rPr lang="fr-FR" sz="1400" dirty="0"/>
-              <a:t>X </a:t>
-            </a:r>
-            <a:r>
-              <a:rPr lang="fr-FR" dirty="0"/>
-              <a:t>poids</a:t>
-            </a:r>
-          </a:p>
-        </p:txBody>
-      </p:sp>
-      <p:cxnSp>
-        <p:nvCxnSpPr>
-          <p:cNvPr id="16" name="Connecteur en angle 10">
-            <a:extLst>
-              <a:ext uri="{FF2B5EF4-FFF2-40B4-BE49-F238E27FC236}">
-                <a16:creationId xmlns:a16="http://schemas.microsoft.com/office/drawing/2014/main" id="{2D510080-C5B9-DDD2-E5C6-E759877C3EFB}"/>
-              </a:ext>
-            </a:extLst>
-          </p:cNvPr>
-          <p:cNvCxnSpPr>
-            <a:cxnSpLocks/>
-            <a:stCxn id="9" idx="3"/>
-            <a:endCxn id="3" idx="0"/>
-          </p:cNvCxnSpPr>
-          <p:nvPr/>
-        </p:nvCxnSpPr>
-        <p:spPr>
-          <a:xfrm>
-            <a:off x="4688595" y="1478019"/>
-            <a:ext cx="3104107" cy="2431602"/>
-          </a:xfrm>
-          <a:prstGeom prst="bentConnector2">
-            <a:avLst/>
-          </a:prstGeom>
-        </p:spPr>
-        <p:style>
-          <a:lnRef idx="2">
-            <a:schemeClr val="accent1"/>
-          </a:lnRef>
-          <a:fillRef idx="0">
-            <a:schemeClr val="accent1"/>
-          </a:fillRef>
-          <a:effectRef idx="1">
-            <a:schemeClr val="accent1"/>
-          </a:effectRef>
-          <a:fontRef idx="minor">
-            <a:schemeClr val="tx1"/>
-          </a:fontRef>
-        </p:style>
-      </p:cxnSp>
-      <p:sp>
-        <p:nvSpPr>
-          <p:cNvPr id="34" name="Forme libre 33">
-            <a:extLst>
-              <a:ext uri="{FF2B5EF4-FFF2-40B4-BE49-F238E27FC236}">
-                <a16:creationId xmlns:a16="http://schemas.microsoft.com/office/drawing/2014/main" id="{AAB92076-EC75-4767-F557-6B1ADE3E1352}"/>
-              </a:ext>
-            </a:extLst>
-          </p:cNvPr>
-          <p:cNvSpPr/>
-          <p:nvPr/>
-        </p:nvSpPr>
-        <p:spPr>
-          <a:xfrm rot="16557881" flipV="1">
-            <a:off x="5002989" y="1431699"/>
-            <a:ext cx="574334" cy="289722"/>
-          </a:xfrm>
-          <a:custGeom>
-            <a:avLst/>
-            <a:gdLst>
-              <a:gd name="csX0" fmla="*/ 112238 w 920336"/>
-              <a:gd name="csY0" fmla="*/ 0 h 497502"/>
-              <a:gd name="csX1" fmla="*/ 920313 w 920336"/>
-              <a:gd name="csY1" fmla="*/ 159488 h 497502"/>
-              <a:gd name="csX2" fmla="*/ 90973 w 920336"/>
-              <a:gd name="csY2" fmla="*/ 467832 h 497502"/>
-              <a:gd name="csX3" fmla="*/ 59075 w 920336"/>
-              <a:gd name="csY3" fmla="*/ 467832 h 497502"/>
-            </a:gdLst>
-            <a:ahLst/>
-            <a:cxnLst>
-              <a:cxn ang="0">
-                <a:pos x="csX0" y="csY0"/>
-              </a:cxn>
-              <a:cxn ang="0">
-                <a:pos x="csX1" y="csY1"/>
-              </a:cxn>
-              <a:cxn ang="0">
-                <a:pos x="csX2" y="csY2"/>
-              </a:cxn>
-              <a:cxn ang="0">
-                <a:pos x="csX3" y="csY3"/>
-              </a:cxn>
-            </a:cxnLst>
-            <a:rect l="l" t="t" r="r" b="b"/>
-            <a:pathLst>
-              <a:path w="920336" h="497502">
-                <a:moveTo>
-                  <a:pt x="112238" y="0"/>
-                </a:moveTo>
-                <a:cubicBezTo>
-                  <a:pt x="518047" y="40758"/>
-                  <a:pt x="923857" y="81516"/>
-                  <a:pt x="920313" y="159488"/>
-                </a:cubicBezTo>
-                <a:cubicBezTo>
-                  <a:pt x="916769" y="237460"/>
-                  <a:pt x="234513" y="416441"/>
-                  <a:pt x="90973" y="467832"/>
-                </a:cubicBezTo>
-                <a:cubicBezTo>
-                  <a:pt x="-52567" y="519223"/>
-                  <a:pt x="3254" y="493527"/>
-                  <a:pt x="59075" y="467832"/>
-                </a:cubicBezTo>
-              </a:path>
-            </a:pathLst>
-          </a:custGeom>
-          <a:solidFill>
-            <a:schemeClr val="bg2">
-              <a:lumMod val="90000"/>
-            </a:schemeClr>
-          </a:solidFill>
-        </p:spPr>
-        <p:style>
-          <a:lnRef idx="2">
-            <a:schemeClr val="accent1">
-              <a:shade val="15000"/>
-            </a:schemeClr>
-          </a:lnRef>
-          <a:fillRef idx="1">
-            <a:schemeClr val="accent1"/>
-          </a:fillRef>
-          <a:effectRef idx="0">
-            <a:schemeClr val="accent1"/>
-          </a:effectRef>
-          <a:fontRef idx="minor">
-            <a:schemeClr val="lt1"/>
-          </a:fontRef>
-        </p:style>
-        <p:txBody>
-          <a:bodyPr rtlCol="0" anchor="ctr"/>
-          <a:lstStyle/>
-          <a:p>
-            <a:pPr algn="ctr"/>
-            <a:endParaRPr lang="fr-FR" dirty="0"/>
-          </a:p>
-        </p:txBody>
-      </p:sp>
-      <p:sp>
-        <p:nvSpPr>
-          <p:cNvPr id="30" name="Forme libre 29">
-            <a:extLst>
-              <a:ext uri="{FF2B5EF4-FFF2-40B4-BE49-F238E27FC236}">
-                <a16:creationId xmlns:a16="http://schemas.microsoft.com/office/drawing/2014/main" id="{2B0D1B1D-F9AB-C627-D258-9B1D3C6FC82A}"/>
-              </a:ext>
-            </a:extLst>
-          </p:cNvPr>
-          <p:cNvSpPr/>
-          <p:nvPr/>
-        </p:nvSpPr>
-        <p:spPr>
-          <a:xfrm rot="16557881" flipV="1">
-            <a:off x="5002989" y="3238407"/>
-            <a:ext cx="574334" cy="289722"/>
-          </a:xfrm>
-          <a:custGeom>
-            <a:avLst/>
-            <a:gdLst>
-              <a:gd name="csX0" fmla="*/ 112238 w 920336"/>
-              <a:gd name="csY0" fmla="*/ 0 h 497502"/>
-              <a:gd name="csX1" fmla="*/ 920313 w 920336"/>
-              <a:gd name="csY1" fmla="*/ 159488 h 497502"/>
-              <a:gd name="csX2" fmla="*/ 90973 w 920336"/>
-              <a:gd name="csY2" fmla="*/ 467832 h 497502"/>
-              <a:gd name="csX3" fmla="*/ 59075 w 920336"/>
-              <a:gd name="csY3" fmla="*/ 467832 h 497502"/>
-            </a:gdLst>
-            <a:ahLst/>
-            <a:cxnLst>
-              <a:cxn ang="0">
-                <a:pos x="csX0" y="csY0"/>
-              </a:cxn>
-              <a:cxn ang="0">
-                <a:pos x="csX1" y="csY1"/>
-              </a:cxn>
-              <a:cxn ang="0">
-                <a:pos x="csX2" y="csY2"/>
-              </a:cxn>
-              <a:cxn ang="0">
-                <a:pos x="csX3" y="csY3"/>
-              </a:cxn>
-            </a:cxnLst>
-            <a:rect l="l" t="t" r="r" b="b"/>
-            <a:pathLst>
-              <a:path w="920336" h="497502">
-                <a:moveTo>
-                  <a:pt x="112238" y="0"/>
-                </a:moveTo>
-                <a:cubicBezTo>
-                  <a:pt x="518047" y="40758"/>
-                  <a:pt x="923857" y="81516"/>
-                  <a:pt x="920313" y="159488"/>
-                </a:cubicBezTo>
-                <a:cubicBezTo>
-                  <a:pt x="916769" y="237460"/>
-                  <a:pt x="234513" y="416441"/>
-                  <a:pt x="90973" y="467832"/>
-                </a:cubicBezTo>
-                <a:cubicBezTo>
-                  <a:pt x="-52567" y="519223"/>
-                  <a:pt x="3254" y="493527"/>
-                  <a:pt x="59075" y="467832"/>
-                </a:cubicBezTo>
-              </a:path>
-            </a:pathLst>
-          </a:custGeom>
-          <a:solidFill>
-            <a:schemeClr val="bg2">
-              <a:lumMod val="90000"/>
-            </a:schemeClr>
-          </a:solidFill>
-        </p:spPr>
-        <p:style>
-          <a:lnRef idx="2">
-            <a:schemeClr val="accent1">
-              <a:shade val="15000"/>
-            </a:schemeClr>
-          </a:lnRef>
-          <a:fillRef idx="1">
-            <a:schemeClr val="accent1"/>
-          </a:fillRef>
-          <a:effectRef idx="0">
-            <a:schemeClr val="accent1"/>
-          </a:effectRef>
-          <a:fontRef idx="minor">
-            <a:schemeClr val="lt1"/>
-          </a:fontRef>
-        </p:style>
-        <p:txBody>
-          <a:bodyPr rtlCol="0" anchor="ctr"/>
-          <a:lstStyle/>
-          <a:p>
-            <a:pPr algn="ctr"/>
-            <a:endParaRPr lang="fr-FR" dirty="0"/>
-          </a:p>
-        </p:txBody>
-      </p:sp>
-      <p:sp>
-        <p:nvSpPr>
-          <p:cNvPr id="31" name="Forme libre 30">
-            <a:extLst>
-              <a:ext uri="{FF2B5EF4-FFF2-40B4-BE49-F238E27FC236}">
-                <a16:creationId xmlns:a16="http://schemas.microsoft.com/office/drawing/2014/main" id="{B8B6D54B-FCD8-DDFB-8E77-8E911E97EF4E}"/>
-              </a:ext>
-            </a:extLst>
-          </p:cNvPr>
-          <p:cNvSpPr/>
-          <p:nvPr/>
-        </p:nvSpPr>
-        <p:spPr>
-          <a:xfrm rot="16557881" flipV="1">
-            <a:off x="5002989" y="2306223"/>
-            <a:ext cx="574334" cy="289722"/>
-          </a:xfrm>
-          <a:custGeom>
-            <a:avLst/>
-            <a:gdLst>
-              <a:gd name="csX0" fmla="*/ 112238 w 920336"/>
-              <a:gd name="csY0" fmla="*/ 0 h 497502"/>
-              <a:gd name="csX1" fmla="*/ 920313 w 920336"/>
-              <a:gd name="csY1" fmla="*/ 159488 h 497502"/>
-              <a:gd name="csX2" fmla="*/ 90973 w 920336"/>
-              <a:gd name="csY2" fmla="*/ 467832 h 497502"/>
-              <a:gd name="csX3" fmla="*/ 59075 w 920336"/>
-              <a:gd name="csY3" fmla="*/ 467832 h 497502"/>
-            </a:gdLst>
-            <a:ahLst/>
-            <a:cxnLst>
-              <a:cxn ang="0">
-                <a:pos x="csX0" y="csY0"/>
-              </a:cxn>
-              <a:cxn ang="0">
-                <a:pos x="csX1" y="csY1"/>
-              </a:cxn>
-              <a:cxn ang="0">
-                <a:pos x="csX2" y="csY2"/>
-              </a:cxn>
-              <a:cxn ang="0">
-                <a:pos x="csX3" y="csY3"/>
-              </a:cxn>
-            </a:cxnLst>
-            <a:rect l="l" t="t" r="r" b="b"/>
-            <a:pathLst>
-              <a:path w="920336" h="497502">
-                <a:moveTo>
-                  <a:pt x="112238" y="0"/>
-                </a:moveTo>
-                <a:cubicBezTo>
-                  <a:pt x="518047" y="40758"/>
-                  <a:pt x="923857" y="81516"/>
-                  <a:pt x="920313" y="159488"/>
-                </a:cubicBezTo>
-                <a:cubicBezTo>
-                  <a:pt x="916769" y="237460"/>
-                  <a:pt x="234513" y="416441"/>
-                  <a:pt x="90973" y="467832"/>
-                </a:cubicBezTo>
-                <a:cubicBezTo>
-                  <a:pt x="-52567" y="519223"/>
-                  <a:pt x="3254" y="493527"/>
-                  <a:pt x="59075" y="467832"/>
-                </a:cubicBezTo>
-              </a:path>
-            </a:pathLst>
-          </a:custGeom>
-          <a:solidFill>
-            <a:schemeClr val="bg2">
-              <a:lumMod val="90000"/>
-            </a:schemeClr>
-          </a:solidFill>
-        </p:spPr>
-        <p:style>
-          <a:lnRef idx="2">
-            <a:schemeClr val="accent1">
-              <a:shade val="15000"/>
-            </a:schemeClr>
-          </a:lnRef>
-          <a:fillRef idx="1">
-            <a:schemeClr val="accent1"/>
-          </a:fillRef>
-          <a:effectRef idx="0">
-            <a:schemeClr val="accent1"/>
-          </a:effectRef>
-          <a:fontRef idx="minor">
-            <a:schemeClr val="lt1"/>
-          </a:fontRef>
-        </p:style>
-        <p:txBody>
-          <a:bodyPr rtlCol="0" anchor="ctr"/>
-          <a:lstStyle/>
-          <a:p>
-            <a:pPr algn="ctr"/>
-            <a:endParaRPr lang="fr-FR" dirty="0"/>
-          </a:p>
-        </p:txBody>
-      </p:sp>
+        </p:spPr>
+      </p:pic>
     </p:spTree>
     <p:extLst>
       <p:ext uri="{BB962C8B-B14F-4D97-AF65-F5344CB8AC3E}">
-        <p14:creationId xmlns:p14="http://schemas.microsoft.com/office/powerpoint/2010/main" val="4076495031"/>
+        <p14:creationId xmlns:p14="http://schemas.microsoft.com/office/powerpoint/2010/main" val="667193975"/>
       </p:ext>
     </p:extLst>
   </p:cSld>
@@ -8300,7 +6985,7 @@
           <p:cNvPr id="2" name="Titre 1">
             <a:extLst>
               <a:ext uri="{FF2B5EF4-FFF2-40B4-BE49-F238E27FC236}">
-                <a16:creationId xmlns:a16="http://schemas.microsoft.com/office/drawing/2014/main" id="{F2B86EAC-284E-62EF-A1DD-75F70367B607}"/>
+                <a16:creationId xmlns:a16="http://schemas.microsoft.com/office/drawing/2014/main" id="{98F86401-3D31-5798-8271-B8CBDE949B77}"/>
               </a:ext>
             </a:extLst>
           </p:cNvPr>
@@ -8325,7 +7010,7 @@
           <p:cNvPr id="3" name="Espace réservé du contenu 2">
             <a:extLst>
               <a:ext uri="{FF2B5EF4-FFF2-40B4-BE49-F238E27FC236}">
-                <a16:creationId xmlns:a16="http://schemas.microsoft.com/office/drawing/2014/main" id="{FF90CE95-16DC-B6D8-3FDC-663FEA193625}"/>
+                <a16:creationId xmlns:a16="http://schemas.microsoft.com/office/drawing/2014/main" id="{704FBE3E-697F-4FC8-E33A-FEEA0E9DDEF3}"/>
               </a:ext>
             </a:extLst>
           </p:cNvPr>
@@ -8347,10 +7032,10 @@
       </p:sp>
       <p:pic>
         <p:nvPicPr>
-          <p:cNvPr id="5" name="Image 4">
-            <a:extLst>
-              <a:ext uri="{FF2B5EF4-FFF2-40B4-BE49-F238E27FC236}">
-                <a16:creationId xmlns:a16="http://schemas.microsoft.com/office/drawing/2014/main" id="{822B6366-7D5A-A438-399A-DD90FAD9668E}"/>
+          <p:cNvPr id="4" name="Image 3">
+            <a:extLst>
+              <a:ext uri="{FF2B5EF4-FFF2-40B4-BE49-F238E27FC236}">
+                <a16:creationId xmlns:a16="http://schemas.microsoft.com/office/drawing/2014/main" id="{CA76F867-F921-85F4-CDF2-378D706D0434}"/>
               </a:ext>
             </a:extLst>
           </p:cNvPr>
@@ -8367,118 +7052,8 @@
         </p:blipFill>
         <p:spPr>
           <a:xfrm>
-            <a:off x="100446" y="115094"/>
-            <a:ext cx="7086600" cy="3886200"/>
-          </a:xfrm>
-          <a:prstGeom prst="rect">
-            <a:avLst/>
-          </a:prstGeom>
-        </p:spPr>
-      </p:pic>
-    </p:spTree>
-    <p:extLst>
-      <p:ext uri="{BB962C8B-B14F-4D97-AF65-F5344CB8AC3E}">
-        <p14:creationId xmlns:p14="http://schemas.microsoft.com/office/powerpoint/2010/main" val="667193975"/>
-      </p:ext>
-    </p:extLst>
-  </p:cSld>
-  <p:clrMapOvr>
-    <a:masterClrMapping/>
-  </p:clrMapOvr>
-</p:sld>
-</file>
-
-<file path=ppt/slides/slide5.xml><?xml version="1.0" encoding="utf-8"?>
-<p:sld xmlns:a="http://schemas.openxmlformats.org/drawingml/2006/main" xmlns:r="http://schemas.openxmlformats.org/officeDocument/2006/relationships" xmlns:p="http://schemas.openxmlformats.org/presentationml/2006/main">
-  <p:cSld>
-    <p:spTree>
-      <p:nvGrpSpPr>
-        <p:cNvPr id="1" name=""/>
-        <p:cNvGrpSpPr/>
-        <p:nvPr/>
-      </p:nvGrpSpPr>
-      <p:grpSpPr>
-        <a:xfrm>
-          <a:off x="0" y="0"/>
-          <a:ext cx="0" cy="0"/>
-          <a:chOff x="0" y="0"/>
-          <a:chExt cx="0" cy="0"/>
-        </a:xfrm>
-      </p:grpSpPr>
-      <p:sp>
-        <p:nvSpPr>
-          <p:cNvPr id="2" name="Titre 1">
-            <a:extLst>
-              <a:ext uri="{FF2B5EF4-FFF2-40B4-BE49-F238E27FC236}">
-                <a16:creationId xmlns:a16="http://schemas.microsoft.com/office/drawing/2014/main" id="{98F86401-3D31-5798-8271-B8CBDE949B77}"/>
-              </a:ext>
-            </a:extLst>
-          </p:cNvPr>
-          <p:cNvSpPr>
-            <a:spLocks noGrp="1"/>
-          </p:cNvSpPr>
-          <p:nvPr>
-            <p:ph type="title"/>
-          </p:nvPr>
-        </p:nvSpPr>
-        <p:spPr/>
-        <p:txBody>
-          <a:bodyPr/>
-          <a:lstStyle/>
-          <a:p>
-            <a:endParaRPr lang="fr-FR"/>
-          </a:p>
-        </p:txBody>
-      </p:sp>
-      <p:sp>
-        <p:nvSpPr>
-          <p:cNvPr id="3" name="Espace réservé du contenu 2">
-            <a:extLst>
-              <a:ext uri="{FF2B5EF4-FFF2-40B4-BE49-F238E27FC236}">
-                <a16:creationId xmlns:a16="http://schemas.microsoft.com/office/drawing/2014/main" id="{704FBE3E-697F-4FC8-E33A-FEEA0E9DDEF3}"/>
-              </a:ext>
-            </a:extLst>
-          </p:cNvPr>
-          <p:cNvSpPr>
-            <a:spLocks noGrp="1"/>
-          </p:cNvSpPr>
-          <p:nvPr>
-            <p:ph idx="1"/>
-          </p:nvPr>
-        </p:nvSpPr>
-        <p:spPr/>
-        <p:txBody>
-          <a:bodyPr/>
-          <a:lstStyle/>
-          <a:p>
-            <a:endParaRPr lang="fr-FR"/>
-          </a:p>
-        </p:txBody>
-      </p:sp>
-      <p:pic>
-        <p:nvPicPr>
-          <p:cNvPr id="5" name="Image 4">
-            <a:extLst>
-              <a:ext uri="{FF2B5EF4-FFF2-40B4-BE49-F238E27FC236}">
-                <a16:creationId xmlns:a16="http://schemas.microsoft.com/office/drawing/2014/main" id="{F9F692F3-80D2-AD33-6E8C-BAAA2C86261D}"/>
-              </a:ext>
-            </a:extLst>
-          </p:cNvPr>
-          <p:cNvPicPr>
-            <a:picLocks noChangeAspect="1"/>
-          </p:cNvPicPr>
-          <p:nvPr/>
-        </p:nvPicPr>
-        <p:blipFill>
-          <a:blip r:embed="rId2"/>
-          <a:stretch>
-            <a:fillRect/>
-          </a:stretch>
-        </p:blipFill>
-        <p:spPr>
-          <a:xfrm>
-            <a:off x="4791808" y="2672269"/>
-            <a:ext cx="5190392" cy="3011617"/>
+            <a:off x="3777096" y="1825625"/>
+            <a:ext cx="5524500" cy="3746500"/>
           </a:xfrm>
           <a:prstGeom prst="rect">
             <a:avLst/>

</xml_diff>

<commit_message>
une version avec schémas avec H
</commit_message>
<xml_diff>
--- a/outillage.pptx
+++ b/outillage.pptx
@@ -6,9 +6,10 @@
   </p:sldMasterIdLst>
   <p:sldIdLst>
     <p:sldId id="257" r:id="rId2"/>
-    <p:sldId id="259" r:id="rId3"/>
-    <p:sldId id="258" r:id="rId4"/>
-    <p:sldId id="260" r:id="rId5"/>
+    <p:sldId id="261" r:id="rId3"/>
+    <p:sldId id="259" r:id="rId4"/>
+    <p:sldId id="258" r:id="rId5"/>
+    <p:sldId id="260" r:id="rId6"/>
   </p:sldIdLst>
   <p:sldSz cx="12192000" cy="6858000"/>
   <p:notesSz cx="6858000" cy="9144000"/>
@@ -262,7 +263,7 @@
           <a:p>
             <a:fld id="{D7B9B2F6-DB6D-6549-8947-FBFB6C213823}" type="datetimeFigureOut">
               <a:rPr lang="fr-FR" smtClean="0"/>
-              <a:t>22/10/2026</a:t>
+              <a:t>25/10/2026</a:t>
             </a:fld>
             <a:endParaRPr lang="fr-FR"/>
           </a:p>
@@ -460,7 +461,7 @@
           <a:p>
             <a:fld id="{D7B9B2F6-DB6D-6549-8947-FBFB6C213823}" type="datetimeFigureOut">
               <a:rPr lang="fr-FR" smtClean="0"/>
-              <a:t>22/10/2026</a:t>
+              <a:t>25/10/2026</a:t>
             </a:fld>
             <a:endParaRPr lang="fr-FR"/>
           </a:p>
@@ -668,7 +669,7 @@
           <a:p>
             <a:fld id="{D7B9B2F6-DB6D-6549-8947-FBFB6C213823}" type="datetimeFigureOut">
               <a:rPr lang="fr-FR" smtClean="0"/>
-              <a:t>22/10/2026</a:t>
+              <a:t>25/10/2026</a:t>
             </a:fld>
             <a:endParaRPr lang="fr-FR"/>
           </a:p>
@@ -866,7 +867,7 @@
           <a:p>
             <a:fld id="{D7B9B2F6-DB6D-6549-8947-FBFB6C213823}" type="datetimeFigureOut">
               <a:rPr lang="fr-FR" smtClean="0"/>
-              <a:t>22/10/2026</a:t>
+              <a:t>25/10/2026</a:t>
             </a:fld>
             <a:endParaRPr lang="fr-FR"/>
           </a:p>
@@ -1141,7 +1142,7 @@
           <a:p>
             <a:fld id="{D7B9B2F6-DB6D-6549-8947-FBFB6C213823}" type="datetimeFigureOut">
               <a:rPr lang="fr-FR" smtClean="0"/>
-              <a:t>22/10/2026</a:t>
+              <a:t>25/10/2026</a:t>
             </a:fld>
             <a:endParaRPr lang="fr-FR"/>
           </a:p>
@@ -1406,7 +1407,7 @@
           <a:p>
             <a:fld id="{D7B9B2F6-DB6D-6549-8947-FBFB6C213823}" type="datetimeFigureOut">
               <a:rPr lang="fr-FR" smtClean="0"/>
-              <a:t>22/10/2026</a:t>
+              <a:t>25/10/2026</a:t>
             </a:fld>
             <a:endParaRPr lang="fr-FR"/>
           </a:p>
@@ -1818,7 +1819,7 @@
           <a:p>
             <a:fld id="{D7B9B2F6-DB6D-6549-8947-FBFB6C213823}" type="datetimeFigureOut">
               <a:rPr lang="fr-FR" smtClean="0"/>
-              <a:t>22/10/2026</a:t>
+              <a:t>25/10/2026</a:t>
             </a:fld>
             <a:endParaRPr lang="fr-FR"/>
           </a:p>
@@ -1959,7 +1960,7 @@
           <a:p>
             <a:fld id="{D7B9B2F6-DB6D-6549-8947-FBFB6C213823}" type="datetimeFigureOut">
               <a:rPr lang="fr-FR" smtClean="0"/>
-              <a:t>22/10/2026</a:t>
+              <a:t>25/10/2026</a:t>
             </a:fld>
             <a:endParaRPr lang="fr-FR"/>
           </a:p>
@@ -2072,7 +2073,7 @@
           <a:p>
             <a:fld id="{D7B9B2F6-DB6D-6549-8947-FBFB6C213823}" type="datetimeFigureOut">
               <a:rPr lang="fr-FR" smtClean="0"/>
-              <a:t>22/10/2026</a:t>
+              <a:t>25/10/2026</a:t>
             </a:fld>
             <a:endParaRPr lang="fr-FR"/>
           </a:p>
@@ -2383,7 +2384,7 @@
           <a:p>
             <a:fld id="{D7B9B2F6-DB6D-6549-8947-FBFB6C213823}" type="datetimeFigureOut">
               <a:rPr lang="fr-FR" smtClean="0"/>
-              <a:t>22/10/2026</a:t>
+              <a:t>25/10/2026</a:t>
             </a:fld>
             <a:endParaRPr lang="fr-FR"/>
           </a:p>
@@ -2671,7 +2672,7 @@
           <a:p>
             <a:fld id="{D7B9B2F6-DB6D-6549-8947-FBFB6C213823}" type="datetimeFigureOut">
               <a:rPr lang="fr-FR" smtClean="0"/>
-              <a:t>22/10/2026</a:t>
+              <a:t>25/10/2026</a:t>
             </a:fld>
             <a:endParaRPr lang="fr-FR"/>
           </a:p>
@@ -2912,7 +2913,7 @@
           <a:p>
             <a:fld id="{D7B9B2F6-DB6D-6549-8947-FBFB6C213823}" type="datetimeFigureOut">
               <a:rPr lang="fr-FR" smtClean="0"/>
-              <a:t>22/10/2026</a:t>
+              <a:t>25/10/2026</a:t>
             </a:fld>
             <a:endParaRPr lang="fr-FR"/>
           </a:p>
@@ -5192,6 +5193,1561 @@
   <p:cSld>
     <p:spTree>
       <p:nvGrpSpPr>
+        <p:cNvPr id="1" name="">
+          <a:extLst>
+            <a:ext uri="{FF2B5EF4-FFF2-40B4-BE49-F238E27FC236}">
+              <a16:creationId xmlns:a16="http://schemas.microsoft.com/office/drawing/2014/main" id="{50C7B168-3853-5269-ABE3-788941C3F2B3}"/>
+            </a:ext>
+          </a:extLst>
+        </p:cNvPr>
+        <p:cNvGrpSpPr/>
+        <p:nvPr/>
+      </p:nvGrpSpPr>
+      <p:grpSpPr>
+        <a:xfrm>
+          <a:off x="0" y="0"/>
+          <a:ext cx="0" cy="0"/>
+          <a:chOff x="0" y="0"/>
+          <a:chExt cx="0" cy="0"/>
+        </a:xfrm>
+      </p:grpSpPr>
+      <p:sp>
+        <p:nvSpPr>
+          <p:cNvPr id="4" name="Ellipse 3">
+            <a:extLst>
+              <a:ext uri="{FF2B5EF4-FFF2-40B4-BE49-F238E27FC236}">
+                <a16:creationId xmlns:a16="http://schemas.microsoft.com/office/drawing/2014/main" id="{6188876D-91CF-45DB-3E0C-E27416640159}"/>
+              </a:ext>
+            </a:extLst>
+          </p:cNvPr>
+          <p:cNvSpPr/>
+          <p:nvPr/>
+        </p:nvSpPr>
+        <p:spPr>
+          <a:xfrm>
+            <a:off x="961956" y="1059946"/>
+            <a:ext cx="467833" cy="467833"/>
+          </a:xfrm>
+          <a:prstGeom prst="ellipse">
+            <a:avLst/>
+          </a:prstGeom>
+          <a:solidFill>
+            <a:schemeClr val="tx2">
+              <a:lumMod val="50000"/>
+              <a:lumOff val="50000"/>
+            </a:schemeClr>
+          </a:solidFill>
+          <a:ln>
+            <a:solidFill>
+              <a:schemeClr val="tx2">
+                <a:lumMod val="50000"/>
+                <a:lumOff val="50000"/>
+              </a:schemeClr>
+            </a:solidFill>
+          </a:ln>
+        </p:spPr>
+        <p:style>
+          <a:lnRef idx="2">
+            <a:schemeClr val="accent1">
+              <a:shade val="15000"/>
+            </a:schemeClr>
+          </a:lnRef>
+          <a:fillRef idx="1">
+            <a:schemeClr val="accent1"/>
+          </a:fillRef>
+          <a:effectRef idx="0">
+            <a:schemeClr val="accent1"/>
+          </a:effectRef>
+          <a:fontRef idx="minor">
+            <a:schemeClr val="lt1"/>
+          </a:fontRef>
+        </p:style>
+        <p:txBody>
+          <a:bodyPr lIns="0" tIns="0" rIns="0" bIns="0" rtlCol="0" anchor="ctr"/>
+          <a:lstStyle/>
+          <a:p>
+            <a:pPr algn="ctr"/>
+            <a:r>
+              <a:rPr lang="fr-FR" sz="1600" dirty="0"/>
+              <a:t>E1</a:t>
+            </a:r>
+          </a:p>
+        </p:txBody>
+      </p:sp>
+      <p:sp>
+        <p:nvSpPr>
+          <p:cNvPr id="5" name="Ellipse 4">
+            <a:extLst>
+              <a:ext uri="{FF2B5EF4-FFF2-40B4-BE49-F238E27FC236}">
+                <a16:creationId xmlns:a16="http://schemas.microsoft.com/office/drawing/2014/main" id="{3B518EB1-BC35-C02D-A64F-AE92CB08409F}"/>
+              </a:ext>
+            </a:extLst>
+          </p:cNvPr>
+          <p:cNvSpPr/>
+          <p:nvPr/>
+        </p:nvSpPr>
+        <p:spPr>
+          <a:xfrm>
+            <a:off x="989354" y="1853756"/>
+            <a:ext cx="467833" cy="467833"/>
+          </a:xfrm>
+          <a:prstGeom prst="ellipse">
+            <a:avLst/>
+          </a:prstGeom>
+          <a:solidFill>
+            <a:schemeClr val="tx2">
+              <a:lumMod val="50000"/>
+              <a:lumOff val="50000"/>
+            </a:schemeClr>
+          </a:solidFill>
+          <a:ln>
+            <a:solidFill>
+              <a:schemeClr val="tx2">
+                <a:lumMod val="50000"/>
+                <a:lumOff val="50000"/>
+              </a:schemeClr>
+            </a:solidFill>
+          </a:ln>
+        </p:spPr>
+        <p:style>
+          <a:lnRef idx="2">
+            <a:schemeClr val="accent1">
+              <a:shade val="15000"/>
+            </a:schemeClr>
+          </a:lnRef>
+          <a:fillRef idx="1">
+            <a:schemeClr val="accent1"/>
+          </a:fillRef>
+          <a:effectRef idx="0">
+            <a:schemeClr val="accent1"/>
+          </a:effectRef>
+          <a:fontRef idx="minor">
+            <a:schemeClr val="lt1"/>
+          </a:fontRef>
+        </p:style>
+        <p:txBody>
+          <a:bodyPr lIns="0" tIns="0" rIns="0" bIns="0" rtlCol="0" anchor="ctr"/>
+          <a:lstStyle/>
+          <a:p>
+            <a:pPr algn="ctr"/>
+            <a:r>
+              <a:rPr lang="fr-FR" sz="1600" dirty="0"/>
+              <a:t>E2</a:t>
+            </a:r>
+          </a:p>
+        </p:txBody>
+      </p:sp>
+      <p:cxnSp>
+        <p:nvCxnSpPr>
+          <p:cNvPr id="11" name="Connecteur en angle 10">
+            <a:extLst>
+              <a:ext uri="{FF2B5EF4-FFF2-40B4-BE49-F238E27FC236}">
+                <a16:creationId xmlns:a16="http://schemas.microsoft.com/office/drawing/2014/main" id="{89C27128-FFC0-1306-42BA-5E2B25B1B423}"/>
+              </a:ext>
+            </a:extLst>
+          </p:cNvPr>
+          <p:cNvCxnSpPr>
+            <a:cxnSpLocks/>
+            <a:stCxn id="4" idx="6"/>
+            <a:endCxn id="9" idx="1"/>
+          </p:cNvCxnSpPr>
+          <p:nvPr/>
+        </p:nvCxnSpPr>
+        <p:spPr>
+          <a:xfrm>
+            <a:off x="1429789" y="1293863"/>
+            <a:ext cx="2671537" cy="184156"/>
+          </a:xfrm>
+          <a:prstGeom prst="straightConnector1">
+            <a:avLst/>
+          </a:prstGeom>
+        </p:spPr>
+        <p:style>
+          <a:lnRef idx="2">
+            <a:schemeClr val="accent1"/>
+          </a:lnRef>
+          <a:fillRef idx="0">
+            <a:schemeClr val="accent1"/>
+          </a:fillRef>
+          <a:effectRef idx="1">
+            <a:schemeClr val="accent1"/>
+          </a:effectRef>
+          <a:fontRef idx="minor">
+            <a:schemeClr val="tx1"/>
+          </a:fontRef>
+        </p:style>
+      </p:cxnSp>
+      <p:cxnSp>
+        <p:nvCxnSpPr>
+          <p:cNvPr id="25" name="Connecteur en angle 24">
+            <a:extLst>
+              <a:ext uri="{FF2B5EF4-FFF2-40B4-BE49-F238E27FC236}">
+                <a16:creationId xmlns:a16="http://schemas.microsoft.com/office/drawing/2014/main" id="{3663E2EF-D460-641C-E1BA-800BA540E78E}"/>
+              </a:ext>
+            </a:extLst>
+          </p:cNvPr>
+          <p:cNvCxnSpPr>
+            <a:cxnSpLocks/>
+            <a:stCxn id="5" idx="6"/>
+            <a:endCxn id="9" idx="1"/>
+          </p:cNvCxnSpPr>
+          <p:nvPr/>
+        </p:nvCxnSpPr>
+        <p:spPr>
+          <a:xfrm flipV="1">
+            <a:off x="1457187" y="1478019"/>
+            <a:ext cx="2644139" cy="609654"/>
+          </a:xfrm>
+          <a:prstGeom prst="straightConnector1">
+            <a:avLst/>
+          </a:prstGeom>
+        </p:spPr>
+        <p:style>
+          <a:lnRef idx="2">
+            <a:schemeClr val="accent1"/>
+          </a:lnRef>
+          <a:fillRef idx="0">
+            <a:schemeClr val="accent1"/>
+          </a:fillRef>
+          <a:effectRef idx="1">
+            <a:schemeClr val="accent1"/>
+          </a:effectRef>
+          <a:fontRef idx="minor">
+            <a:schemeClr val="tx1"/>
+          </a:fontRef>
+        </p:style>
+      </p:cxnSp>
+      <p:sp>
+        <p:nvSpPr>
+          <p:cNvPr id="80" name="ZoneTexte 79">
+            <a:extLst>
+              <a:ext uri="{FF2B5EF4-FFF2-40B4-BE49-F238E27FC236}">
+                <a16:creationId xmlns:a16="http://schemas.microsoft.com/office/drawing/2014/main" id="{41BDFD13-86A6-25FB-75C4-69FAED6B5694}"/>
+              </a:ext>
+            </a:extLst>
+          </p:cNvPr>
+          <p:cNvSpPr txBox="1"/>
+          <p:nvPr/>
+        </p:nvSpPr>
+        <p:spPr>
+          <a:xfrm>
+            <a:off x="3031834" y="1168509"/>
+            <a:ext cx="484428" cy="307777"/>
+          </a:xfrm>
+          <a:prstGeom prst="rect">
+            <a:avLst/>
+          </a:prstGeom>
+          <a:solidFill>
+            <a:schemeClr val="bg1">
+              <a:lumMod val="95000"/>
+              <a:alpha val="70000"/>
+            </a:schemeClr>
+          </a:solidFill>
+        </p:spPr>
+        <p:txBody>
+          <a:bodyPr wrap="none" rtlCol="0">
+            <a:spAutoFit/>
+          </a:bodyPr>
+          <a:lstStyle/>
+          <a:p>
+            <a:r>
+              <a:rPr lang="fr-FR" sz="1400" dirty="0"/>
+              <a:t>w1  </a:t>
+            </a:r>
+            <a:endParaRPr lang="fr-FR" sz="2000" dirty="0"/>
+          </a:p>
+        </p:txBody>
+      </p:sp>
+      <p:sp>
+        <p:nvSpPr>
+          <p:cNvPr id="3" name="Ellipse 2">
+            <a:extLst>
+              <a:ext uri="{FF2B5EF4-FFF2-40B4-BE49-F238E27FC236}">
+                <a16:creationId xmlns:a16="http://schemas.microsoft.com/office/drawing/2014/main" id="{7F6EE462-1024-7D06-1210-F80696B7AA00}"/>
+              </a:ext>
+            </a:extLst>
+          </p:cNvPr>
+          <p:cNvSpPr/>
+          <p:nvPr/>
+        </p:nvSpPr>
+        <p:spPr>
+          <a:xfrm>
+            <a:off x="8295640" y="1218099"/>
+            <a:ext cx="467833" cy="467833"/>
+          </a:xfrm>
+          <a:prstGeom prst="ellipse">
+            <a:avLst/>
+          </a:prstGeom>
+          <a:solidFill>
+            <a:schemeClr val="tx2">
+              <a:lumMod val="50000"/>
+              <a:lumOff val="50000"/>
+            </a:schemeClr>
+          </a:solidFill>
+          <a:ln>
+            <a:solidFill>
+              <a:schemeClr val="tx2">
+                <a:lumMod val="50000"/>
+                <a:lumOff val="50000"/>
+              </a:schemeClr>
+            </a:solidFill>
+          </a:ln>
+        </p:spPr>
+        <p:style>
+          <a:lnRef idx="2">
+            <a:schemeClr val="accent1">
+              <a:shade val="15000"/>
+            </a:schemeClr>
+          </a:lnRef>
+          <a:fillRef idx="1">
+            <a:schemeClr val="accent1"/>
+          </a:fillRef>
+          <a:effectRef idx="0">
+            <a:schemeClr val="accent1"/>
+          </a:effectRef>
+          <a:fontRef idx="minor">
+            <a:schemeClr val="lt1"/>
+          </a:fontRef>
+        </p:style>
+        <p:txBody>
+          <a:bodyPr lIns="0" tIns="0" rIns="0" bIns="0" rtlCol="0" anchor="ctr"/>
+          <a:lstStyle/>
+          <a:p>
+            <a:pPr algn="ctr"/>
+            <a:r>
+              <a:rPr lang="fr-FR" sz="1600" dirty="0"/>
+              <a:t>S</a:t>
+            </a:r>
+          </a:p>
+        </p:txBody>
+      </p:sp>
+      <p:sp>
+        <p:nvSpPr>
+          <p:cNvPr id="9" name="Rectangle 8">
+            <a:extLst>
+              <a:ext uri="{FF2B5EF4-FFF2-40B4-BE49-F238E27FC236}">
+                <a16:creationId xmlns:a16="http://schemas.microsoft.com/office/drawing/2014/main" id="{4874FD60-D35D-EE5D-0538-0D2493667C74}"/>
+              </a:ext>
+            </a:extLst>
+          </p:cNvPr>
+          <p:cNvSpPr/>
+          <p:nvPr/>
+        </p:nvSpPr>
+        <p:spPr>
+          <a:xfrm>
+            <a:off x="4101326" y="1222837"/>
+            <a:ext cx="587269" cy="510363"/>
+          </a:xfrm>
+          <a:prstGeom prst="rect">
+            <a:avLst/>
+          </a:prstGeom>
+          <a:noFill/>
+          <a:ln>
+            <a:solidFill>
+              <a:schemeClr val="bg1">
+                <a:lumMod val="75000"/>
+              </a:schemeClr>
+            </a:solidFill>
+          </a:ln>
+        </p:spPr>
+        <p:style>
+          <a:lnRef idx="2">
+            <a:schemeClr val="accent1">
+              <a:shade val="15000"/>
+            </a:schemeClr>
+          </a:lnRef>
+          <a:fillRef idx="1">
+            <a:schemeClr val="accent1"/>
+          </a:fillRef>
+          <a:effectRef idx="0">
+            <a:schemeClr val="accent1"/>
+          </a:effectRef>
+          <a:fontRef idx="minor">
+            <a:schemeClr val="lt1"/>
+          </a:fontRef>
+        </p:style>
+        <p:txBody>
+          <a:bodyPr rtlCol="0" anchor="ctr"/>
+          <a:lstStyle/>
+          <a:p>
+            <a:pPr algn="ctr"/>
+            <a:endParaRPr lang="fr-FR"/>
+          </a:p>
+        </p:txBody>
+      </p:sp>
+      <p:sp>
+        <p:nvSpPr>
+          <p:cNvPr id="47" name="ZoneTexte 46">
+            <a:extLst>
+              <a:ext uri="{FF2B5EF4-FFF2-40B4-BE49-F238E27FC236}">
+                <a16:creationId xmlns:a16="http://schemas.microsoft.com/office/drawing/2014/main" id="{B9C1933E-3E1E-AD74-FA96-1FE487E0D7EE}"/>
+              </a:ext>
+            </a:extLst>
+          </p:cNvPr>
+          <p:cNvSpPr txBox="1"/>
+          <p:nvPr/>
+        </p:nvSpPr>
+        <p:spPr>
+          <a:xfrm>
+            <a:off x="4226055" y="1218489"/>
+            <a:ext cx="346570" cy="461665"/>
+          </a:xfrm>
+          <a:prstGeom prst="rect">
+            <a:avLst/>
+          </a:prstGeom>
+          <a:noFill/>
+        </p:spPr>
+        <p:txBody>
+          <a:bodyPr wrap="none" rtlCol="0">
+            <a:spAutoFit/>
+          </a:bodyPr>
+          <a:lstStyle/>
+          <a:p>
+            <a:r>
+              <a:rPr lang="fr-FR" sz="2400" dirty="0"/>
+              <a:t>∑</a:t>
+            </a:r>
+          </a:p>
+        </p:txBody>
+      </p:sp>
+      <p:sp>
+        <p:nvSpPr>
+          <p:cNvPr id="51" name="ZoneTexte 50">
+            <a:extLst>
+              <a:ext uri="{FF2B5EF4-FFF2-40B4-BE49-F238E27FC236}">
+                <a16:creationId xmlns:a16="http://schemas.microsoft.com/office/drawing/2014/main" id="{CBE71320-9033-0F85-6C2C-EA3C6044076F}"/>
+              </a:ext>
+            </a:extLst>
+          </p:cNvPr>
+          <p:cNvSpPr txBox="1"/>
+          <p:nvPr/>
+        </p:nvSpPr>
+        <p:spPr>
+          <a:xfrm>
+            <a:off x="8088273" y="652732"/>
+            <a:ext cx="752129" cy="369332"/>
+          </a:xfrm>
+          <a:prstGeom prst="rect">
+            <a:avLst/>
+          </a:prstGeom>
+          <a:noFill/>
+        </p:spPr>
+        <p:txBody>
+          <a:bodyPr wrap="none" rtlCol="0">
+            <a:spAutoFit/>
+          </a:bodyPr>
+          <a:lstStyle/>
+          <a:p>
+            <a:r>
+              <a:rPr lang="fr-FR" dirty="0"/>
+              <a:t>sortie</a:t>
+            </a:r>
+          </a:p>
+        </p:txBody>
+      </p:sp>
+      <p:sp>
+        <p:nvSpPr>
+          <p:cNvPr id="52" name="ZoneTexte 51">
+            <a:extLst>
+              <a:ext uri="{FF2B5EF4-FFF2-40B4-BE49-F238E27FC236}">
+                <a16:creationId xmlns:a16="http://schemas.microsoft.com/office/drawing/2014/main" id="{BDF0BFD9-3BB3-4B63-5F99-6B3C8BAA4D9C}"/>
+              </a:ext>
+            </a:extLst>
+          </p:cNvPr>
+          <p:cNvSpPr txBox="1"/>
+          <p:nvPr/>
+        </p:nvSpPr>
+        <p:spPr>
+          <a:xfrm>
+            <a:off x="723595" y="603783"/>
+            <a:ext cx="944554" cy="369332"/>
+          </a:xfrm>
+          <a:prstGeom prst="rect">
+            <a:avLst/>
+          </a:prstGeom>
+          <a:noFill/>
+        </p:spPr>
+        <p:txBody>
+          <a:bodyPr wrap="none" rtlCol="0">
+            <a:spAutoFit/>
+          </a:bodyPr>
+          <a:lstStyle/>
+          <a:p>
+            <a:r>
+              <a:rPr lang="fr-FR" dirty="0"/>
+              <a:t>Entrées</a:t>
+            </a:r>
+          </a:p>
+        </p:txBody>
+      </p:sp>
+      <p:sp>
+        <p:nvSpPr>
+          <p:cNvPr id="53" name="ZoneTexte 52">
+            <a:extLst>
+              <a:ext uri="{FF2B5EF4-FFF2-40B4-BE49-F238E27FC236}">
+                <a16:creationId xmlns:a16="http://schemas.microsoft.com/office/drawing/2014/main" id="{24F90893-D37D-27D4-C194-163B8B3169BA}"/>
+              </a:ext>
+            </a:extLst>
+          </p:cNvPr>
+          <p:cNvSpPr txBox="1"/>
+          <p:nvPr/>
+        </p:nvSpPr>
+        <p:spPr>
+          <a:xfrm>
+            <a:off x="3858775" y="613286"/>
+            <a:ext cx="939681" cy="369332"/>
+          </a:xfrm>
+          <a:prstGeom prst="rect">
+            <a:avLst/>
+          </a:prstGeom>
+          <a:noFill/>
+        </p:spPr>
+        <p:txBody>
+          <a:bodyPr wrap="none" rtlCol="0">
+            <a:spAutoFit/>
+          </a:bodyPr>
+          <a:lstStyle/>
+          <a:p>
+            <a:r>
+              <a:rPr lang="fr-FR" dirty="0"/>
+              <a:t>somme</a:t>
+            </a:r>
+          </a:p>
+        </p:txBody>
+      </p:sp>
+      <p:sp>
+        <p:nvSpPr>
+          <p:cNvPr id="54" name="ZoneTexte 53">
+            <a:extLst>
+              <a:ext uri="{FF2B5EF4-FFF2-40B4-BE49-F238E27FC236}">
+                <a16:creationId xmlns:a16="http://schemas.microsoft.com/office/drawing/2014/main" id="{1CB2523D-4C88-20A9-03E7-39DE8276260D}"/>
+              </a:ext>
+            </a:extLst>
+          </p:cNvPr>
+          <p:cNvSpPr txBox="1"/>
+          <p:nvPr/>
+        </p:nvSpPr>
+        <p:spPr>
+          <a:xfrm>
+            <a:off x="4853251" y="613286"/>
+            <a:ext cx="660758" cy="369332"/>
+          </a:xfrm>
+          <a:prstGeom prst="rect">
+            <a:avLst/>
+          </a:prstGeom>
+          <a:noFill/>
+        </p:spPr>
+        <p:txBody>
+          <a:bodyPr wrap="none" rtlCol="0">
+            <a:spAutoFit/>
+          </a:bodyPr>
+          <a:lstStyle/>
+          <a:p>
+            <a:r>
+              <a:rPr lang="fr-FR" dirty="0"/>
+              <a:t>seuil</a:t>
+            </a:r>
+          </a:p>
+        </p:txBody>
+      </p:sp>
+      <p:sp>
+        <p:nvSpPr>
+          <p:cNvPr id="55" name="ZoneTexte 54">
+            <a:extLst>
+              <a:ext uri="{FF2B5EF4-FFF2-40B4-BE49-F238E27FC236}">
+                <a16:creationId xmlns:a16="http://schemas.microsoft.com/office/drawing/2014/main" id="{5197A22A-D37C-F759-10B1-0BF5077E42BE}"/>
+              </a:ext>
+            </a:extLst>
+          </p:cNvPr>
+          <p:cNvSpPr txBox="1"/>
+          <p:nvPr/>
+        </p:nvSpPr>
+        <p:spPr>
+          <a:xfrm>
+            <a:off x="2883637" y="613286"/>
+            <a:ext cx="737702" cy="369332"/>
+          </a:xfrm>
+          <a:prstGeom prst="rect">
+            <a:avLst/>
+          </a:prstGeom>
+          <a:noFill/>
+        </p:spPr>
+        <p:txBody>
+          <a:bodyPr wrap="none" rtlCol="0">
+            <a:spAutoFit/>
+          </a:bodyPr>
+          <a:lstStyle/>
+          <a:p>
+            <a:r>
+              <a:rPr lang="fr-FR" dirty="0"/>
+              <a:t>poids</a:t>
+            </a:r>
+          </a:p>
+        </p:txBody>
+      </p:sp>
+      <p:cxnSp>
+        <p:nvCxnSpPr>
+          <p:cNvPr id="16" name="Connecteur en angle 10">
+            <a:extLst>
+              <a:ext uri="{FF2B5EF4-FFF2-40B4-BE49-F238E27FC236}">
+                <a16:creationId xmlns:a16="http://schemas.microsoft.com/office/drawing/2014/main" id="{305ECF67-80B0-2700-518D-12107D365785}"/>
+              </a:ext>
+            </a:extLst>
+          </p:cNvPr>
+          <p:cNvCxnSpPr>
+            <a:cxnSpLocks/>
+            <a:stCxn id="9" idx="3"/>
+            <a:endCxn id="41" idx="1"/>
+          </p:cNvCxnSpPr>
+          <p:nvPr/>
+        </p:nvCxnSpPr>
+        <p:spPr>
+          <a:xfrm flipV="1">
+            <a:off x="4688595" y="1469573"/>
+            <a:ext cx="1407405" cy="8446"/>
+          </a:xfrm>
+          <a:prstGeom prst="bentConnector3">
+            <a:avLst>
+              <a:gd name="adj1" fmla="val 50000"/>
+            </a:avLst>
+          </a:prstGeom>
+        </p:spPr>
+        <p:style>
+          <a:lnRef idx="2">
+            <a:schemeClr val="accent1"/>
+          </a:lnRef>
+          <a:fillRef idx="0">
+            <a:schemeClr val="accent1"/>
+          </a:fillRef>
+          <a:effectRef idx="1">
+            <a:schemeClr val="accent1"/>
+          </a:effectRef>
+          <a:fontRef idx="minor">
+            <a:schemeClr val="tx1"/>
+          </a:fontRef>
+        </p:style>
+      </p:cxnSp>
+      <p:sp>
+        <p:nvSpPr>
+          <p:cNvPr id="34" name="Forme libre 33">
+            <a:extLst>
+              <a:ext uri="{FF2B5EF4-FFF2-40B4-BE49-F238E27FC236}">
+                <a16:creationId xmlns:a16="http://schemas.microsoft.com/office/drawing/2014/main" id="{E1C3803F-FCEA-6E6D-708D-96ADC5F9C009}"/>
+              </a:ext>
+            </a:extLst>
+          </p:cNvPr>
+          <p:cNvSpPr/>
+          <p:nvPr/>
+        </p:nvSpPr>
+        <p:spPr>
+          <a:xfrm rot="16557881" flipV="1">
+            <a:off x="5002989" y="1431699"/>
+            <a:ext cx="574334" cy="289722"/>
+          </a:xfrm>
+          <a:custGeom>
+            <a:avLst/>
+            <a:gdLst>
+              <a:gd name="csX0" fmla="*/ 112238 w 920336"/>
+              <a:gd name="csY0" fmla="*/ 0 h 497502"/>
+              <a:gd name="csX1" fmla="*/ 920313 w 920336"/>
+              <a:gd name="csY1" fmla="*/ 159488 h 497502"/>
+              <a:gd name="csX2" fmla="*/ 90973 w 920336"/>
+              <a:gd name="csY2" fmla="*/ 467832 h 497502"/>
+              <a:gd name="csX3" fmla="*/ 59075 w 920336"/>
+              <a:gd name="csY3" fmla="*/ 467832 h 497502"/>
+            </a:gdLst>
+            <a:ahLst/>
+            <a:cxnLst>
+              <a:cxn ang="0">
+                <a:pos x="csX0" y="csY0"/>
+              </a:cxn>
+              <a:cxn ang="0">
+                <a:pos x="csX1" y="csY1"/>
+              </a:cxn>
+              <a:cxn ang="0">
+                <a:pos x="csX2" y="csY2"/>
+              </a:cxn>
+              <a:cxn ang="0">
+                <a:pos x="csX3" y="csY3"/>
+              </a:cxn>
+            </a:cxnLst>
+            <a:rect l="l" t="t" r="r" b="b"/>
+            <a:pathLst>
+              <a:path w="920336" h="497502">
+                <a:moveTo>
+                  <a:pt x="112238" y="0"/>
+                </a:moveTo>
+                <a:cubicBezTo>
+                  <a:pt x="518047" y="40758"/>
+                  <a:pt x="923857" y="81516"/>
+                  <a:pt x="920313" y="159488"/>
+                </a:cubicBezTo>
+                <a:cubicBezTo>
+                  <a:pt x="916769" y="237460"/>
+                  <a:pt x="234513" y="416441"/>
+                  <a:pt x="90973" y="467832"/>
+                </a:cubicBezTo>
+                <a:cubicBezTo>
+                  <a:pt x="-52567" y="519223"/>
+                  <a:pt x="3254" y="493527"/>
+                  <a:pt x="59075" y="467832"/>
+                </a:cubicBezTo>
+              </a:path>
+            </a:pathLst>
+          </a:custGeom>
+          <a:solidFill>
+            <a:schemeClr val="bg2">
+              <a:lumMod val="90000"/>
+            </a:schemeClr>
+          </a:solidFill>
+        </p:spPr>
+        <p:style>
+          <a:lnRef idx="2">
+            <a:schemeClr val="accent1">
+              <a:shade val="15000"/>
+            </a:schemeClr>
+          </a:lnRef>
+          <a:fillRef idx="1">
+            <a:schemeClr val="accent1"/>
+          </a:fillRef>
+          <a:effectRef idx="0">
+            <a:schemeClr val="accent1"/>
+          </a:effectRef>
+          <a:fontRef idx="minor">
+            <a:schemeClr val="lt1"/>
+          </a:fontRef>
+        </p:style>
+        <p:txBody>
+          <a:bodyPr rtlCol="0" anchor="ctr"/>
+          <a:lstStyle/>
+          <a:p>
+            <a:pPr algn="ctr"/>
+            <a:endParaRPr lang="fr-FR" dirty="0"/>
+          </a:p>
+        </p:txBody>
+      </p:sp>
+      <p:sp>
+        <p:nvSpPr>
+          <p:cNvPr id="2" name="Rectangle 1">
+            <a:extLst>
+              <a:ext uri="{FF2B5EF4-FFF2-40B4-BE49-F238E27FC236}">
+                <a16:creationId xmlns:a16="http://schemas.microsoft.com/office/drawing/2014/main" id="{F3E303F2-80A5-330F-722A-52DC648F0D3B}"/>
+              </a:ext>
+            </a:extLst>
+          </p:cNvPr>
+          <p:cNvSpPr/>
+          <p:nvPr/>
+        </p:nvSpPr>
+        <p:spPr>
+          <a:xfrm>
+            <a:off x="2883638" y="1117809"/>
+            <a:ext cx="2772410" cy="816373"/>
+          </a:xfrm>
+          <a:prstGeom prst="rect">
+            <a:avLst/>
+          </a:prstGeom>
+          <a:noFill/>
+          <a:ln>
+            <a:solidFill>
+              <a:schemeClr val="bg1">
+                <a:lumMod val="65000"/>
+              </a:schemeClr>
+            </a:solidFill>
+          </a:ln>
+        </p:spPr>
+        <p:style>
+          <a:lnRef idx="2">
+            <a:schemeClr val="accent1">
+              <a:shade val="15000"/>
+            </a:schemeClr>
+          </a:lnRef>
+          <a:fillRef idx="1">
+            <a:schemeClr val="accent1"/>
+          </a:fillRef>
+          <a:effectRef idx="0">
+            <a:schemeClr val="accent1"/>
+          </a:effectRef>
+          <a:fontRef idx="minor">
+            <a:schemeClr val="lt1"/>
+          </a:fontRef>
+        </p:style>
+        <p:txBody>
+          <a:bodyPr rtlCol="0" anchor="ctr"/>
+          <a:lstStyle/>
+          <a:p>
+            <a:pPr algn="ctr"/>
+            <a:endParaRPr lang="fr-FR"/>
+          </a:p>
+        </p:txBody>
+      </p:sp>
+      <p:sp>
+        <p:nvSpPr>
+          <p:cNvPr id="24" name="ZoneTexte 23">
+            <a:extLst>
+              <a:ext uri="{FF2B5EF4-FFF2-40B4-BE49-F238E27FC236}">
+                <a16:creationId xmlns:a16="http://schemas.microsoft.com/office/drawing/2014/main" id="{AC3C52E5-EC90-9BC2-809D-09F56F055355}"/>
+              </a:ext>
+            </a:extLst>
+          </p:cNvPr>
+          <p:cNvSpPr txBox="1"/>
+          <p:nvPr/>
+        </p:nvSpPr>
+        <p:spPr>
+          <a:xfrm>
+            <a:off x="3031834" y="1513559"/>
+            <a:ext cx="447558" cy="307777"/>
+          </a:xfrm>
+          <a:prstGeom prst="rect">
+            <a:avLst/>
+          </a:prstGeom>
+          <a:solidFill>
+            <a:schemeClr val="bg1">
+              <a:lumMod val="95000"/>
+              <a:alpha val="70000"/>
+            </a:schemeClr>
+          </a:solidFill>
+        </p:spPr>
+        <p:txBody>
+          <a:bodyPr wrap="none" rtlCol="0">
+            <a:spAutoFit/>
+          </a:bodyPr>
+          <a:lstStyle/>
+          <a:p>
+            <a:r>
+              <a:rPr lang="fr-FR" sz="1400" dirty="0"/>
+              <a:t>w2 </a:t>
+            </a:r>
+            <a:endParaRPr lang="fr-FR" sz="2000" dirty="0"/>
+          </a:p>
+        </p:txBody>
+      </p:sp>
+      <p:sp>
+        <p:nvSpPr>
+          <p:cNvPr id="29" name="Ellipse 28">
+            <a:extLst>
+              <a:ext uri="{FF2B5EF4-FFF2-40B4-BE49-F238E27FC236}">
+                <a16:creationId xmlns:a16="http://schemas.microsoft.com/office/drawing/2014/main" id="{3917DA11-396F-C47C-4A82-E49EACE7FED7}"/>
+              </a:ext>
+            </a:extLst>
+          </p:cNvPr>
+          <p:cNvSpPr/>
+          <p:nvPr/>
+        </p:nvSpPr>
+        <p:spPr>
+          <a:xfrm>
+            <a:off x="9811917" y="1182083"/>
+            <a:ext cx="467833" cy="467833"/>
+          </a:xfrm>
+          <a:prstGeom prst="ellipse">
+            <a:avLst/>
+          </a:prstGeom>
+          <a:solidFill>
+            <a:schemeClr val="accent2">
+              <a:lumMod val="60000"/>
+              <a:lumOff val="40000"/>
+            </a:schemeClr>
+          </a:solidFill>
+          <a:ln>
+            <a:solidFill>
+              <a:schemeClr val="accent2">
+                <a:lumMod val="50000"/>
+              </a:schemeClr>
+            </a:solidFill>
+          </a:ln>
+        </p:spPr>
+        <p:style>
+          <a:lnRef idx="2">
+            <a:schemeClr val="accent1">
+              <a:shade val="15000"/>
+            </a:schemeClr>
+          </a:lnRef>
+          <a:fillRef idx="1">
+            <a:schemeClr val="accent1"/>
+          </a:fillRef>
+          <a:effectRef idx="0">
+            <a:schemeClr val="accent1"/>
+          </a:effectRef>
+          <a:fontRef idx="minor">
+            <a:schemeClr val="lt1"/>
+          </a:fontRef>
+        </p:style>
+        <p:txBody>
+          <a:bodyPr lIns="0" tIns="0" rIns="0" bIns="0" rtlCol="0" anchor="ctr"/>
+          <a:lstStyle/>
+          <a:p>
+            <a:pPr algn="ctr"/>
+            <a:r>
+              <a:rPr lang="fr-FR" sz="1600" dirty="0"/>
+              <a:t>O</a:t>
+            </a:r>
+          </a:p>
+        </p:txBody>
+      </p:sp>
+      <p:sp>
+        <p:nvSpPr>
+          <p:cNvPr id="32" name="ZoneTexte 31">
+            <a:extLst>
+              <a:ext uri="{FF2B5EF4-FFF2-40B4-BE49-F238E27FC236}">
+                <a16:creationId xmlns:a16="http://schemas.microsoft.com/office/drawing/2014/main" id="{B14AABB2-03CB-48C9-2B39-22C9940BE4F4}"/>
+              </a:ext>
+            </a:extLst>
+          </p:cNvPr>
+          <p:cNvSpPr txBox="1"/>
+          <p:nvPr/>
+        </p:nvSpPr>
+        <p:spPr>
+          <a:xfrm>
+            <a:off x="9555955" y="627647"/>
+            <a:ext cx="979755" cy="369332"/>
+          </a:xfrm>
+          <a:prstGeom prst="rect">
+            <a:avLst/>
+          </a:prstGeom>
+          <a:noFill/>
+        </p:spPr>
+        <p:txBody>
+          <a:bodyPr wrap="none" rtlCol="0">
+            <a:spAutoFit/>
+          </a:bodyPr>
+          <a:lstStyle/>
+          <a:p>
+            <a:pPr algn="ctr"/>
+            <a:r>
+              <a:rPr lang="fr-FR" dirty="0"/>
+              <a:t>Objectif</a:t>
+            </a:r>
+          </a:p>
+        </p:txBody>
+      </p:sp>
+      <p:sp>
+        <p:nvSpPr>
+          <p:cNvPr id="35" name="Forme libre 34">
+            <a:extLst>
+              <a:ext uri="{FF2B5EF4-FFF2-40B4-BE49-F238E27FC236}">
+                <a16:creationId xmlns:a16="http://schemas.microsoft.com/office/drawing/2014/main" id="{3D65CBDB-372B-F758-97E6-E8150F859186}"/>
+              </a:ext>
+            </a:extLst>
+          </p:cNvPr>
+          <p:cNvSpPr/>
+          <p:nvPr/>
+        </p:nvSpPr>
+        <p:spPr>
+          <a:xfrm>
+            <a:off x="8782495" y="1120601"/>
+            <a:ext cx="988828" cy="782795"/>
+          </a:xfrm>
+          <a:custGeom>
+            <a:avLst/>
+            <a:gdLst>
+              <a:gd name="csX0" fmla="*/ 0 w 988828"/>
+              <a:gd name="csY0" fmla="*/ 325427 h 782795"/>
+              <a:gd name="csX1" fmla="*/ 159489 w 988828"/>
+              <a:gd name="csY1" fmla="*/ 17083 h 782795"/>
+              <a:gd name="csX2" fmla="*/ 255182 w 988828"/>
+              <a:gd name="csY2" fmla="*/ 782627 h 782795"/>
+              <a:gd name="csX3" fmla="*/ 382772 w 988828"/>
+              <a:gd name="csY3" fmla="*/ 91511 h 782795"/>
+              <a:gd name="csX4" fmla="*/ 531628 w 988828"/>
+              <a:gd name="csY4" fmla="*/ 612506 h 782795"/>
+              <a:gd name="csX5" fmla="*/ 627321 w 988828"/>
+              <a:gd name="csY5" fmla="*/ 38348 h 782795"/>
+              <a:gd name="csX6" fmla="*/ 754912 w 988828"/>
+              <a:gd name="csY6" fmla="*/ 686934 h 782795"/>
+              <a:gd name="csX7" fmla="*/ 797442 w 988828"/>
+              <a:gd name="csY7" fmla="*/ 27715 h 782795"/>
+              <a:gd name="csX8" fmla="*/ 988828 w 988828"/>
+              <a:gd name="csY8" fmla="*/ 250999 h 782795"/>
+            </a:gdLst>
+            <a:ahLst/>
+            <a:cxnLst>
+              <a:cxn ang="0">
+                <a:pos x="csX0" y="csY0"/>
+              </a:cxn>
+              <a:cxn ang="0">
+                <a:pos x="csX1" y="csY1"/>
+              </a:cxn>
+              <a:cxn ang="0">
+                <a:pos x="csX2" y="csY2"/>
+              </a:cxn>
+              <a:cxn ang="0">
+                <a:pos x="csX3" y="csY3"/>
+              </a:cxn>
+              <a:cxn ang="0">
+                <a:pos x="csX4" y="csY4"/>
+              </a:cxn>
+              <a:cxn ang="0">
+                <a:pos x="csX5" y="csY5"/>
+              </a:cxn>
+              <a:cxn ang="0">
+                <a:pos x="csX6" y="csY6"/>
+              </a:cxn>
+              <a:cxn ang="0">
+                <a:pos x="csX7" y="csY7"/>
+              </a:cxn>
+              <a:cxn ang="0">
+                <a:pos x="csX8" y="csY8"/>
+              </a:cxn>
+            </a:cxnLst>
+            <a:rect l="l" t="t" r="r" b="b"/>
+            <a:pathLst>
+              <a:path w="988828" h="782795" extrusionOk="0">
+                <a:moveTo>
+                  <a:pt x="0" y="325427"/>
+                </a:moveTo>
+                <a:cubicBezTo>
+                  <a:pt x="38676" y="120940"/>
+                  <a:pt x="94018" y="-50507"/>
+                  <a:pt x="159489" y="17083"/>
+                </a:cubicBezTo>
+                <a:cubicBezTo>
+                  <a:pt x="211839" y="95350"/>
+                  <a:pt x="216828" y="770258"/>
+                  <a:pt x="255182" y="782627"/>
+                </a:cubicBezTo>
+                <a:cubicBezTo>
+                  <a:pt x="282368" y="804825"/>
+                  <a:pt x="334309" y="133068"/>
+                  <a:pt x="382772" y="91511"/>
+                </a:cubicBezTo>
+                <a:cubicBezTo>
+                  <a:pt x="419905" y="58266"/>
+                  <a:pt x="499172" y="625333"/>
+                  <a:pt x="531628" y="612506"/>
+                </a:cubicBezTo>
+                <a:cubicBezTo>
+                  <a:pt x="573688" y="603800"/>
+                  <a:pt x="594623" y="16650"/>
+                  <a:pt x="627321" y="38348"/>
+                </a:cubicBezTo>
+                <a:cubicBezTo>
+                  <a:pt x="663369" y="50574"/>
+                  <a:pt x="723424" y="691657"/>
+                  <a:pt x="754912" y="686934"/>
+                </a:cubicBezTo>
+                <a:cubicBezTo>
+                  <a:pt x="781952" y="672637"/>
+                  <a:pt x="755676" y="104235"/>
+                  <a:pt x="797442" y="27715"/>
+                </a:cubicBezTo>
+                <a:cubicBezTo>
+                  <a:pt x="841558" y="-42069"/>
+                  <a:pt x="960891" y="186249"/>
+                  <a:pt x="988828" y="250999"/>
+                </a:cubicBezTo>
+              </a:path>
+            </a:pathLst>
+          </a:custGeom>
+          <a:noFill/>
+          <a:ln>
+            <a:solidFill>
+              <a:schemeClr val="bg1">
+                <a:lumMod val="75000"/>
+              </a:schemeClr>
+            </a:solidFill>
+            <a:extLst>
+              <a:ext uri="{C807C97D-BFC1-408E-A445-0C87EB9F89A2}">
+                <ask:lineSketchStyleProps xmlns:ask="http://schemas.microsoft.com/office/drawing/2018/sketchyshapes" sd="1219033472">
+                  <a:custGeom>
+                    <a:avLst/>
+                    <a:gdLst>
+                      <a:gd name="csX0" fmla="*/ 0 w 988828"/>
+                      <a:gd name="csY0" fmla="*/ 325427 h 782795"/>
+                      <a:gd name="csX1" fmla="*/ 159489 w 988828"/>
+                      <a:gd name="csY1" fmla="*/ 17083 h 782795"/>
+                      <a:gd name="csX2" fmla="*/ 255182 w 988828"/>
+                      <a:gd name="csY2" fmla="*/ 782627 h 782795"/>
+                      <a:gd name="csX3" fmla="*/ 382772 w 988828"/>
+                      <a:gd name="csY3" fmla="*/ 91511 h 782795"/>
+                      <a:gd name="csX4" fmla="*/ 531628 w 988828"/>
+                      <a:gd name="csY4" fmla="*/ 612506 h 782795"/>
+                      <a:gd name="csX5" fmla="*/ 627321 w 988828"/>
+                      <a:gd name="csY5" fmla="*/ 38348 h 782795"/>
+                      <a:gd name="csX6" fmla="*/ 754912 w 988828"/>
+                      <a:gd name="csY6" fmla="*/ 686934 h 782795"/>
+                      <a:gd name="csX7" fmla="*/ 797442 w 988828"/>
+                      <a:gd name="csY7" fmla="*/ 27715 h 782795"/>
+                      <a:gd name="csX8" fmla="*/ 988828 w 988828"/>
+                      <a:gd name="csY8" fmla="*/ 250999 h 782795"/>
+                    </a:gdLst>
+                    <a:ahLst/>
+                    <a:cxnLst>
+                      <a:cxn ang="0">
+                        <a:pos x="csX0" y="csY0"/>
+                      </a:cxn>
+                      <a:cxn ang="0">
+                        <a:pos x="csX1" y="csY1"/>
+                      </a:cxn>
+                      <a:cxn ang="0">
+                        <a:pos x="csX2" y="csY2"/>
+                      </a:cxn>
+                      <a:cxn ang="0">
+                        <a:pos x="csX3" y="csY3"/>
+                      </a:cxn>
+                      <a:cxn ang="0">
+                        <a:pos x="csX4" y="csY4"/>
+                      </a:cxn>
+                      <a:cxn ang="0">
+                        <a:pos x="csX5" y="csY5"/>
+                      </a:cxn>
+                      <a:cxn ang="0">
+                        <a:pos x="csX6" y="csY6"/>
+                      </a:cxn>
+                      <a:cxn ang="0">
+                        <a:pos x="csX7" y="csY7"/>
+                      </a:cxn>
+                      <a:cxn ang="0">
+                        <a:pos x="csX8" y="csY8"/>
+                      </a:cxn>
+                    </a:cxnLst>
+                    <a:rect l="l" t="t" r="r" b="b"/>
+                    <a:pathLst>
+                      <a:path w="988828" h="782795">
+                        <a:moveTo>
+                          <a:pt x="0" y="325427"/>
+                        </a:moveTo>
+                        <a:cubicBezTo>
+                          <a:pt x="58479" y="133155"/>
+                          <a:pt x="116959" y="-59117"/>
+                          <a:pt x="159489" y="17083"/>
+                        </a:cubicBezTo>
+                        <a:cubicBezTo>
+                          <a:pt x="202019" y="93283"/>
+                          <a:pt x="217968" y="770222"/>
+                          <a:pt x="255182" y="782627"/>
+                        </a:cubicBezTo>
+                        <a:cubicBezTo>
+                          <a:pt x="292396" y="795032"/>
+                          <a:pt x="336698" y="119864"/>
+                          <a:pt x="382772" y="91511"/>
+                        </a:cubicBezTo>
+                        <a:cubicBezTo>
+                          <a:pt x="428846" y="63158"/>
+                          <a:pt x="490870" y="621366"/>
+                          <a:pt x="531628" y="612506"/>
+                        </a:cubicBezTo>
+                        <a:cubicBezTo>
+                          <a:pt x="572386" y="603646"/>
+                          <a:pt x="590107" y="25943"/>
+                          <a:pt x="627321" y="38348"/>
+                        </a:cubicBezTo>
+                        <a:cubicBezTo>
+                          <a:pt x="664535" y="50753"/>
+                          <a:pt x="726559" y="688706"/>
+                          <a:pt x="754912" y="686934"/>
+                        </a:cubicBezTo>
+                        <a:cubicBezTo>
+                          <a:pt x="783265" y="685162"/>
+                          <a:pt x="758456" y="100371"/>
+                          <a:pt x="797442" y="27715"/>
+                        </a:cubicBezTo>
+                        <a:cubicBezTo>
+                          <a:pt x="836428" y="-44941"/>
+                          <a:pt x="942754" y="181888"/>
+                          <a:pt x="988828" y="250999"/>
+                        </a:cubicBezTo>
+                      </a:path>
+                    </a:pathLst>
+                  </a:custGeom>
+                  <ask:type>
+                    <ask:lineSketchScribble/>
+                  </ask:type>
+                </ask:lineSketchStyleProps>
+              </a:ext>
+            </a:extLst>
+          </a:ln>
+        </p:spPr>
+        <p:style>
+          <a:lnRef idx="2">
+            <a:schemeClr val="accent1">
+              <a:shade val="15000"/>
+            </a:schemeClr>
+          </a:lnRef>
+          <a:fillRef idx="1">
+            <a:schemeClr val="accent1"/>
+          </a:fillRef>
+          <a:effectRef idx="0">
+            <a:schemeClr val="accent1"/>
+          </a:effectRef>
+          <a:fontRef idx="minor">
+            <a:schemeClr val="lt1"/>
+          </a:fontRef>
+        </p:style>
+        <p:txBody>
+          <a:bodyPr rtlCol="0" anchor="ctr"/>
+          <a:lstStyle/>
+          <a:p>
+            <a:pPr algn="ctr"/>
+            <a:endParaRPr lang="fr-FR"/>
+          </a:p>
+        </p:txBody>
+      </p:sp>
+      <p:sp>
+        <p:nvSpPr>
+          <p:cNvPr id="38" name="ZoneTexte 37">
+            <a:extLst>
+              <a:ext uri="{FF2B5EF4-FFF2-40B4-BE49-F238E27FC236}">
+                <a16:creationId xmlns:a16="http://schemas.microsoft.com/office/drawing/2014/main" id="{6C9E5668-1488-091E-7E89-DC3C4978B0B8}"/>
+              </a:ext>
+            </a:extLst>
+          </p:cNvPr>
+          <p:cNvSpPr txBox="1"/>
+          <p:nvPr/>
+        </p:nvSpPr>
+        <p:spPr>
+          <a:xfrm>
+            <a:off x="5068315" y="1218218"/>
+            <a:ext cx="308098" cy="307777"/>
+          </a:xfrm>
+          <a:prstGeom prst="rect">
+            <a:avLst/>
+          </a:prstGeom>
+          <a:solidFill>
+            <a:schemeClr val="bg1">
+              <a:lumMod val="95000"/>
+              <a:alpha val="70000"/>
+            </a:schemeClr>
+          </a:solidFill>
+        </p:spPr>
+        <p:txBody>
+          <a:bodyPr wrap="none" rtlCol="0">
+            <a:spAutoFit/>
+          </a:bodyPr>
+          <a:lstStyle/>
+          <a:p>
+            <a:r>
+              <a:rPr lang="fr-FR" sz="1400" dirty="0"/>
+              <a:t>s </a:t>
+            </a:r>
+            <a:endParaRPr lang="fr-FR" sz="2000" dirty="0"/>
+          </a:p>
+        </p:txBody>
+      </p:sp>
+      <p:sp>
+        <p:nvSpPr>
+          <p:cNvPr id="40" name="ZoneTexte 39">
+            <a:extLst>
+              <a:ext uri="{FF2B5EF4-FFF2-40B4-BE49-F238E27FC236}">
+                <a16:creationId xmlns:a16="http://schemas.microsoft.com/office/drawing/2014/main" id="{0F51C727-68E5-EE58-7747-279DA022F8DE}"/>
+              </a:ext>
+            </a:extLst>
+          </p:cNvPr>
+          <p:cNvSpPr txBox="1"/>
+          <p:nvPr/>
+        </p:nvSpPr>
+        <p:spPr>
+          <a:xfrm>
+            <a:off x="6272547" y="1187711"/>
+            <a:ext cx="1089722" cy="523220"/>
+          </a:xfrm>
+          <a:prstGeom prst="rect">
+            <a:avLst/>
+          </a:prstGeom>
+          <a:solidFill>
+            <a:schemeClr val="accent2">
+              <a:lumMod val="60000"/>
+              <a:lumOff val="40000"/>
+            </a:schemeClr>
+          </a:solidFill>
+        </p:spPr>
+        <p:txBody>
+          <a:bodyPr wrap="none" rtlCol="0">
+            <a:spAutoFit/>
+          </a:bodyPr>
+          <a:lstStyle/>
+          <a:p>
+            <a:pPr algn="ctr"/>
+            <a:r>
+              <a:rPr lang="fr-FR" sz="1400" dirty="0"/>
+              <a:t>Fonction </a:t>
+            </a:r>
+            <a:br>
+              <a:rPr lang="fr-FR" sz="1400" dirty="0"/>
+            </a:br>
+            <a:r>
+              <a:rPr lang="fr-FR" sz="1400" dirty="0"/>
+              <a:t>d’activation</a:t>
+            </a:r>
+          </a:p>
+        </p:txBody>
+      </p:sp>
+      <p:sp>
+        <p:nvSpPr>
+          <p:cNvPr id="41" name="Accolade ouvrante 40">
+            <a:extLst>
+              <a:ext uri="{FF2B5EF4-FFF2-40B4-BE49-F238E27FC236}">
+                <a16:creationId xmlns:a16="http://schemas.microsoft.com/office/drawing/2014/main" id="{99726E9F-9780-0510-5C2F-9A3BF4E51762}"/>
+              </a:ext>
+            </a:extLst>
+          </p:cNvPr>
+          <p:cNvSpPr/>
+          <p:nvPr/>
+        </p:nvSpPr>
+        <p:spPr>
+          <a:xfrm>
+            <a:off x="6096000" y="1117809"/>
+            <a:ext cx="198474" cy="703527"/>
+          </a:xfrm>
+          <a:prstGeom prst="leftBrace">
+            <a:avLst/>
+          </a:prstGeom>
+          <a:ln>
+            <a:solidFill>
+              <a:schemeClr val="accent2">
+                <a:lumMod val="75000"/>
+              </a:schemeClr>
+            </a:solidFill>
+          </a:ln>
+        </p:spPr>
+        <p:style>
+          <a:lnRef idx="2">
+            <a:schemeClr val="accent1"/>
+          </a:lnRef>
+          <a:fillRef idx="0">
+            <a:schemeClr val="accent1"/>
+          </a:fillRef>
+          <a:effectRef idx="1">
+            <a:schemeClr val="accent1"/>
+          </a:effectRef>
+          <a:fontRef idx="minor">
+            <a:schemeClr val="tx1"/>
+          </a:fontRef>
+        </p:style>
+        <p:txBody>
+          <a:bodyPr rtlCol="0" anchor="ctr"/>
+          <a:lstStyle/>
+          <a:p>
+            <a:pPr algn="ctr"/>
+            <a:endParaRPr lang="fr-FR"/>
+          </a:p>
+        </p:txBody>
+      </p:sp>
+      <p:sp>
+        <p:nvSpPr>
+          <p:cNvPr id="44" name="Accolade fermante 43">
+            <a:extLst>
+              <a:ext uri="{FF2B5EF4-FFF2-40B4-BE49-F238E27FC236}">
+                <a16:creationId xmlns:a16="http://schemas.microsoft.com/office/drawing/2014/main" id="{740F0470-DC39-1F42-9AFA-CD404DAD67EB}"/>
+              </a:ext>
+            </a:extLst>
+          </p:cNvPr>
+          <p:cNvSpPr/>
+          <p:nvPr/>
+        </p:nvSpPr>
+        <p:spPr>
+          <a:xfrm>
+            <a:off x="7330370" y="1059946"/>
+            <a:ext cx="197481" cy="793810"/>
+          </a:xfrm>
+          <a:prstGeom prst="rightBrace">
+            <a:avLst/>
+          </a:prstGeom>
+          <a:ln>
+            <a:solidFill>
+              <a:schemeClr val="accent2">
+                <a:lumMod val="75000"/>
+              </a:schemeClr>
+            </a:solidFill>
+          </a:ln>
+        </p:spPr>
+        <p:style>
+          <a:lnRef idx="2">
+            <a:schemeClr val="accent1"/>
+          </a:lnRef>
+          <a:fillRef idx="0">
+            <a:schemeClr val="accent1"/>
+          </a:fillRef>
+          <a:effectRef idx="1">
+            <a:schemeClr val="accent1"/>
+          </a:effectRef>
+          <a:fontRef idx="minor">
+            <a:schemeClr val="tx1"/>
+          </a:fontRef>
+        </p:style>
+        <p:txBody>
+          <a:bodyPr rtlCol="0" anchor="ctr"/>
+          <a:lstStyle/>
+          <a:p>
+            <a:pPr algn="ctr"/>
+            <a:endParaRPr lang="fr-FR"/>
+          </a:p>
+        </p:txBody>
+      </p:sp>
+      <p:cxnSp>
+        <p:nvCxnSpPr>
+          <p:cNvPr id="58" name="Connecteur droit 57">
+            <a:extLst>
+              <a:ext uri="{FF2B5EF4-FFF2-40B4-BE49-F238E27FC236}">
+                <a16:creationId xmlns:a16="http://schemas.microsoft.com/office/drawing/2014/main" id="{3620A07D-8365-2A26-963B-272B488BA958}"/>
+              </a:ext>
+            </a:extLst>
+          </p:cNvPr>
+          <p:cNvCxnSpPr>
+            <a:stCxn id="44" idx="1"/>
+            <a:endCxn id="3" idx="2"/>
+          </p:cNvCxnSpPr>
+          <p:nvPr/>
+        </p:nvCxnSpPr>
+        <p:spPr>
+          <a:xfrm flipV="1">
+            <a:off x="7527851" y="1452016"/>
+            <a:ext cx="767789" cy="4835"/>
+          </a:xfrm>
+          <a:prstGeom prst="line">
+            <a:avLst/>
+          </a:prstGeom>
+          <a:ln>
+            <a:tailEnd type="triangle"/>
+          </a:ln>
+        </p:spPr>
+        <p:style>
+          <a:lnRef idx="2">
+            <a:schemeClr val="accent1"/>
+          </a:lnRef>
+          <a:fillRef idx="0">
+            <a:schemeClr val="accent1"/>
+          </a:fillRef>
+          <a:effectRef idx="1">
+            <a:schemeClr val="accent1"/>
+          </a:effectRef>
+          <a:fontRef idx="minor">
+            <a:schemeClr val="tx1"/>
+          </a:fontRef>
+        </p:style>
+      </p:cxnSp>
+      <p:sp>
+        <p:nvSpPr>
+          <p:cNvPr id="60" name="ZoneTexte 59">
+            <a:extLst>
+              <a:ext uri="{FF2B5EF4-FFF2-40B4-BE49-F238E27FC236}">
+                <a16:creationId xmlns:a16="http://schemas.microsoft.com/office/drawing/2014/main" id="{01F4BE66-5511-B225-8E11-67F6F5A9E6A1}"/>
+              </a:ext>
+            </a:extLst>
+          </p:cNvPr>
+          <p:cNvSpPr txBox="1"/>
+          <p:nvPr/>
+        </p:nvSpPr>
+        <p:spPr>
+          <a:xfrm>
+            <a:off x="8688344" y="2070098"/>
+            <a:ext cx="1357488" cy="307777"/>
+          </a:xfrm>
+          <a:prstGeom prst="rect">
+            <a:avLst/>
+          </a:prstGeom>
+          <a:solidFill>
+            <a:schemeClr val="bg1">
+              <a:lumMod val="95000"/>
+              <a:alpha val="70000"/>
+            </a:schemeClr>
+          </a:solidFill>
+        </p:spPr>
+        <p:txBody>
+          <a:bodyPr wrap="none" rtlCol="0">
+            <a:spAutoFit/>
+          </a:bodyPr>
+          <a:lstStyle/>
+          <a:p>
+            <a:r>
+              <a:rPr lang="fr-FR" sz="1400" dirty="0"/>
+              <a:t>apprentissage  </a:t>
+            </a:r>
+            <a:endParaRPr lang="fr-FR" sz="2000" dirty="0"/>
+          </a:p>
+        </p:txBody>
+      </p:sp>
+      <p:cxnSp>
+        <p:nvCxnSpPr>
+          <p:cNvPr id="62" name="Connecteur en angle 61">
+            <a:extLst>
+              <a:ext uri="{FF2B5EF4-FFF2-40B4-BE49-F238E27FC236}">
+                <a16:creationId xmlns:a16="http://schemas.microsoft.com/office/drawing/2014/main" id="{4859D3E4-1B7E-0A99-0285-320127233248}"/>
+              </a:ext>
+            </a:extLst>
+          </p:cNvPr>
+          <p:cNvCxnSpPr>
+            <a:cxnSpLocks/>
+            <a:stCxn id="60" idx="2"/>
+            <a:endCxn id="2" idx="2"/>
+          </p:cNvCxnSpPr>
+          <p:nvPr/>
+        </p:nvCxnSpPr>
+        <p:spPr>
+          <a:xfrm rot="5400000" flipH="1">
+            <a:off x="6596619" y="-392593"/>
+            <a:ext cx="443693" cy="5097245"/>
+          </a:xfrm>
+          <a:prstGeom prst="bentConnector3">
+            <a:avLst>
+              <a:gd name="adj1" fmla="val -51522"/>
+            </a:avLst>
+          </a:prstGeom>
+          <a:ln>
+            <a:tailEnd type="stealth"/>
+          </a:ln>
+        </p:spPr>
+        <p:style>
+          <a:lnRef idx="2">
+            <a:schemeClr val="accent1"/>
+          </a:lnRef>
+          <a:fillRef idx="0">
+            <a:schemeClr val="accent1"/>
+          </a:fillRef>
+          <a:effectRef idx="1">
+            <a:schemeClr val="accent1"/>
+          </a:effectRef>
+          <a:fontRef idx="minor">
+            <a:schemeClr val="tx1"/>
+          </a:fontRef>
+        </p:style>
+      </p:cxnSp>
+      <p:pic>
+        <p:nvPicPr>
+          <p:cNvPr id="66" name="Image 65">
+            <a:extLst>
+              <a:ext uri="{FF2B5EF4-FFF2-40B4-BE49-F238E27FC236}">
+                <a16:creationId xmlns:a16="http://schemas.microsoft.com/office/drawing/2014/main" id="{D40F3C90-5F79-4E45-F610-0C5B03A52037}"/>
+              </a:ext>
+            </a:extLst>
+          </p:cNvPr>
+          <p:cNvPicPr>
+            <a:picLocks noChangeAspect="1"/>
+          </p:cNvPicPr>
+          <p:nvPr/>
+        </p:nvPicPr>
+        <p:blipFill>
+          <a:blip r:embed="rId2"/>
+          <a:stretch>
+            <a:fillRect/>
+          </a:stretch>
+        </p:blipFill>
+        <p:spPr>
+          <a:xfrm>
+            <a:off x="2273432" y="3289995"/>
+            <a:ext cx="7772400" cy="1940359"/>
+          </a:xfrm>
+          <a:prstGeom prst="rect">
+            <a:avLst/>
+          </a:prstGeom>
+        </p:spPr>
+      </p:pic>
+    </p:spTree>
+    <p:extLst>
+      <p:ext uri="{BB962C8B-B14F-4D97-AF65-F5344CB8AC3E}">
+        <p14:creationId xmlns:p14="http://schemas.microsoft.com/office/powerpoint/2010/main" val="3301366004"/>
+      </p:ext>
+    </p:extLst>
+  </p:cSld>
+  <p:clrMapOvr>
+    <a:masterClrMapping/>
+  </p:clrMapOvr>
+</p:sld>
+</file>
+
+<file path=ppt/slides/slide3.xml><?xml version="1.0" encoding="utf-8"?>
+<p:sld xmlns:a="http://schemas.openxmlformats.org/drawingml/2006/main" xmlns:r="http://schemas.openxmlformats.org/officeDocument/2006/relationships" xmlns:p="http://schemas.openxmlformats.org/presentationml/2006/main">
+  <p:cSld>
+    <p:spTree>
+      <p:nvGrpSpPr>
         <p:cNvPr id="1" name=""/>
         <p:cNvGrpSpPr/>
         <p:nvPr/>
@@ -6853,7 +8409,7 @@
 </p:sld>
 </file>
 
-<file path=ppt/slides/slide3.xml><?xml version="1.0" encoding="utf-8"?>
+<file path=ppt/slides/slide4.xml><?xml version="1.0" encoding="utf-8"?>
 <p:sld xmlns:a="http://schemas.openxmlformats.org/drawingml/2006/main" xmlns:r="http://schemas.openxmlformats.org/officeDocument/2006/relationships" xmlns:p="http://schemas.openxmlformats.org/presentationml/2006/main">
   <p:cSld>
     <p:spTree>
@@ -6963,7 +8519,7 @@
 </p:sld>
 </file>
 
-<file path=ppt/slides/slide4.xml><?xml version="1.0" encoding="utf-8"?>
+<file path=ppt/slides/slide5.xml><?xml version="1.0" encoding="utf-8"?>
 <p:sld xmlns:a="http://schemas.openxmlformats.org/drawingml/2006/main" xmlns:r="http://schemas.openxmlformats.org/officeDocument/2006/relationships" xmlns:p="http://schemas.openxmlformats.org/presentationml/2006/main">
   <p:cSld>
     <p:spTree>

</xml_diff>

<commit_message>
intro rectifiée avant appel IA
</commit_message>
<xml_diff>
--- a/outillage.pptx
+++ b/outillage.pptx
@@ -7,9 +7,10 @@
   <p:sldIdLst>
     <p:sldId id="257" r:id="rId2"/>
     <p:sldId id="261" r:id="rId3"/>
-    <p:sldId id="259" r:id="rId4"/>
-    <p:sldId id="258" r:id="rId5"/>
-    <p:sldId id="260" r:id="rId6"/>
+    <p:sldId id="262" r:id="rId4"/>
+    <p:sldId id="259" r:id="rId5"/>
+    <p:sldId id="263" r:id="rId6"/>
+    <p:sldId id="264" r:id="rId7"/>
   </p:sldIdLst>
   <p:sldSz cx="12192000" cy="6858000"/>
   <p:notesSz cx="6858000" cy="9144000"/>
@@ -263,7 +264,7 @@
           <a:p>
             <a:fld id="{D7B9B2F6-DB6D-6549-8947-FBFB6C213823}" type="datetimeFigureOut">
               <a:rPr lang="fr-FR" smtClean="0"/>
-              <a:t>25/10/2026</a:t>
+              <a:t>27/10/2026</a:t>
             </a:fld>
             <a:endParaRPr lang="fr-FR"/>
           </a:p>
@@ -461,7 +462,7 @@
           <a:p>
             <a:fld id="{D7B9B2F6-DB6D-6549-8947-FBFB6C213823}" type="datetimeFigureOut">
               <a:rPr lang="fr-FR" smtClean="0"/>
-              <a:t>25/10/2026</a:t>
+              <a:t>27/10/2026</a:t>
             </a:fld>
             <a:endParaRPr lang="fr-FR"/>
           </a:p>
@@ -669,7 +670,7 @@
           <a:p>
             <a:fld id="{D7B9B2F6-DB6D-6549-8947-FBFB6C213823}" type="datetimeFigureOut">
               <a:rPr lang="fr-FR" smtClean="0"/>
-              <a:t>25/10/2026</a:t>
+              <a:t>27/10/2026</a:t>
             </a:fld>
             <a:endParaRPr lang="fr-FR"/>
           </a:p>
@@ -867,7 +868,7 @@
           <a:p>
             <a:fld id="{D7B9B2F6-DB6D-6549-8947-FBFB6C213823}" type="datetimeFigureOut">
               <a:rPr lang="fr-FR" smtClean="0"/>
-              <a:t>25/10/2026</a:t>
+              <a:t>27/10/2026</a:t>
             </a:fld>
             <a:endParaRPr lang="fr-FR"/>
           </a:p>
@@ -1142,7 +1143,7 @@
           <a:p>
             <a:fld id="{D7B9B2F6-DB6D-6549-8947-FBFB6C213823}" type="datetimeFigureOut">
               <a:rPr lang="fr-FR" smtClean="0"/>
-              <a:t>25/10/2026</a:t>
+              <a:t>27/10/2026</a:t>
             </a:fld>
             <a:endParaRPr lang="fr-FR"/>
           </a:p>
@@ -1407,7 +1408,7 @@
           <a:p>
             <a:fld id="{D7B9B2F6-DB6D-6549-8947-FBFB6C213823}" type="datetimeFigureOut">
               <a:rPr lang="fr-FR" smtClean="0"/>
-              <a:t>25/10/2026</a:t>
+              <a:t>27/10/2026</a:t>
             </a:fld>
             <a:endParaRPr lang="fr-FR"/>
           </a:p>
@@ -1819,7 +1820,7 @@
           <a:p>
             <a:fld id="{D7B9B2F6-DB6D-6549-8947-FBFB6C213823}" type="datetimeFigureOut">
               <a:rPr lang="fr-FR" smtClean="0"/>
-              <a:t>25/10/2026</a:t>
+              <a:t>27/10/2026</a:t>
             </a:fld>
             <a:endParaRPr lang="fr-FR"/>
           </a:p>
@@ -1960,7 +1961,7 @@
           <a:p>
             <a:fld id="{D7B9B2F6-DB6D-6549-8947-FBFB6C213823}" type="datetimeFigureOut">
               <a:rPr lang="fr-FR" smtClean="0"/>
-              <a:t>25/10/2026</a:t>
+              <a:t>27/10/2026</a:t>
             </a:fld>
             <a:endParaRPr lang="fr-FR"/>
           </a:p>
@@ -2073,7 +2074,7 @@
           <a:p>
             <a:fld id="{D7B9B2F6-DB6D-6549-8947-FBFB6C213823}" type="datetimeFigureOut">
               <a:rPr lang="fr-FR" smtClean="0"/>
-              <a:t>25/10/2026</a:t>
+              <a:t>27/10/2026</a:t>
             </a:fld>
             <a:endParaRPr lang="fr-FR"/>
           </a:p>
@@ -2384,7 +2385,7 @@
           <a:p>
             <a:fld id="{D7B9B2F6-DB6D-6549-8947-FBFB6C213823}" type="datetimeFigureOut">
               <a:rPr lang="fr-FR" smtClean="0"/>
-              <a:t>25/10/2026</a:t>
+              <a:t>27/10/2026</a:t>
             </a:fld>
             <a:endParaRPr lang="fr-FR"/>
           </a:p>
@@ -2672,7 +2673,7 @@
           <a:p>
             <a:fld id="{D7B9B2F6-DB6D-6549-8947-FBFB6C213823}" type="datetimeFigureOut">
               <a:rPr lang="fr-FR" smtClean="0"/>
-              <a:t>25/10/2026</a:t>
+              <a:t>27/10/2026</a:t>
             </a:fld>
             <a:endParaRPr lang="fr-FR"/>
           </a:p>
@@ -2913,7 +2914,7 @@
           <a:p>
             <a:fld id="{D7B9B2F6-DB6D-6549-8947-FBFB6C213823}" type="datetimeFigureOut">
               <a:rPr lang="fr-FR" smtClean="0"/>
-              <a:t>25/10/2026</a:t>
+              <a:t>27/10/2026</a:t>
             </a:fld>
             <a:endParaRPr lang="fr-FR"/>
           </a:p>
@@ -6765,7 +6766,7 @@
           <p:cNvPr id="4" name="Ellipse 3">
             <a:extLst>
               <a:ext uri="{FF2B5EF4-FFF2-40B4-BE49-F238E27FC236}">
-                <a16:creationId xmlns:a16="http://schemas.microsoft.com/office/drawing/2014/main" id="{D91E3C53-8C18-E4B8-2C1B-41D54828848D}"/>
+                <a16:creationId xmlns:a16="http://schemas.microsoft.com/office/drawing/2014/main" id="{22C2736B-7AC0-4546-1B59-A1350046D3B5}"/>
               </a:ext>
             </a:extLst>
           </p:cNvPr>
@@ -6774,7 +6775,7 @@
         </p:nvSpPr>
         <p:spPr>
           <a:xfrm>
-            <a:off x="3462338" y="2237007"/>
+            <a:off x="961956" y="1059946"/>
             <a:ext cx="467833" cy="467833"/>
           </a:xfrm>
           <a:prstGeom prst="ellipse">
@@ -6812,13 +6813,13 @@
           </a:fontRef>
         </p:style>
         <p:txBody>
-          <a:bodyPr rtlCol="0" anchor="ctr"/>
+          <a:bodyPr lIns="0" tIns="0" rIns="0" bIns="0" rtlCol="0" anchor="ctr"/>
           <a:lstStyle/>
           <a:p>
             <a:pPr algn="ctr"/>
             <a:r>
-              <a:rPr lang="fr-FR" sz="1000" dirty="0"/>
-              <a:t>b1</a:t>
+              <a:rPr lang="fr-FR" sz="1600" dirty="0"/>
+              <a:t>0</a:t>
             </a:r>
           </a:p>
         </p:txBody>
@@ -6828,7 +6829,7 @@
           <p:cNvPr id="5" name="Ellipse 4">
             <a:extLst>
               <a:ext uri="{FF2B5EF4-FFF2-40B4-BE49-F238E27FC236}">
-                <a16:creationId xmlns:a16="http://schemas.microsoft.com/office/drawing/2014/main" id="{EFC181F5-CC98-03A8-C9AE-41434A5B6615}"/>
+                <a16:creationId xmlns:a16="http://schemas.microsoft.com/office/drawing/2014/main" id="{1EFC3282-3071-BB23-C88E-DAF10842F4EA}"/>
               </a:ext>
             </a:extLst>
           </p:cNvPr>
@@ -6837,7 +6838,7 @@
         </p:nvSpPr>
         <p:spPr>
           <a:xfrm>
-            <a:off x="3497644" y="3037881"/>
+            <a:off x="989354" y="1853756"/>
             <a:ext cx="467833" cy="467833"/>
           </a:xfrm>
           <a:prstGeom prst="ellipse">
@@ -6875,23 +6876,454 @@
           </a:fontRef>
         </p:style>
         <p:txBody>
+          <a:bodyPr lIns="0" tIns="0" rIns="0" bIns="0" rtlCol="0" anchor="ctr"/>
+          <a:lstStyle/>
+          <a:p>
+            <a:pPr algn="ctr"/>
+            <a:r>
+              <a:rPr lang="fr-FR" sz="1600" dirty="0"/>
+              <a:t>1</a:t>
+            </a:r>
+          </a:p>
+        </p:txBody>
+      </p:sp>
+      <p:cxnSp>
+        <p:nvCxnSpPr>
+          <p:cNvPr id="6" name="Connecteur en angle 10">
+            <a:extLst>
+              <a:ext uri="{FF2B5EF4-FFF2-40B4-BE49-F238E27FC236}">
+                <a16:creationId xmlns:a16="http://schemas.microsoft.com/office/drawing/2014/main" id="{C6C4A009-05C3-D9BD-977B-F750AEA48AC6}"/>
+              </a:ext>
+            </a:extLst>
+          </p:cNvPr>
+          <p:cNvCxnSpPr>
+            <a:cxnSpLocks/>
+            <a:stCxn id="4" idx="6"/>
+            <a:endCxn id="10" idx="1"/>
+          </p:cNvCxnSpPr>
+          <p:nvPr/>
+        </p:nvCxnSpPr>
+        <p:spPr>
+          <a:xfrm>
+            <a:off x="1429789" y="1293863"/>
+            <a:ext cx="2671537" cy="184156"/>
+          </a:xfrm>
+          <a:prstGeom prst="straightConnector1">
+            <a:avLst/>
+          </a:prstGeom>
+        </p:spPr>
+        <p:style>
+          <a:lnRef idx="2">
+            <a:schemeClr val="accent1"/>
+          </a:lnRef>
+          <a:fillRef idx="0">
+            <a:schemeClr val="accent1"/>
+          </a:fillRef>
+          <a:effectRef idx="1">
+            <a:schemeClr val="accent1"/>
+          </a:effectRef>
+          <a:fontRef idx="minor">
+            <a:schemeClr val="tx1"/>
+          </a:fontRef>
+        </p:style>
+      </p:cxnSp>
+      <p:cxnSp>
+        <p:nvCxnSpPr>
+          <p:cNvPr id="7" name="Connecteur en angle 24">
+            <a:extLst>
+              <a:ext uri="{FF2B5EF4-FFF2-40B4-BE49-F238E27FC236}">
+                <a16:creationId xmlns:a16="http://schemas.microsoft.com/office/drawing/2014/main" id="{26AB70A8-7E07-3D2B-FEDA-A527C2C4C08E}"/>
+              </a:ext>
+            </a:extLst>
+          </p:cNvPr>
+          <p:cNvCxnSpPr>
+            <a:cxnSpLocks/>
+            <a:stCxn id="5" idx="6"/>
+            <a:endCxn id="10" idx="1"/>
+          </p:cNvCxnSpPr>
+          <p:nvPr/>
+        </p:nvCxnSpPr>
+        <p:spPr>
+          <a:xfrm flipV="1">
+            <a:off x="1457187" y="1478019"/>
+            <a:ext cx="2644139" cy="609654"/>
+          </a:xfrm>
+          <a:prstGeom prst="straightConnector1">
+            <a:avLst/>
+          </a:prstGeom>
+        </p:spPr>
+        <p:style>
+          <a:lnRef idx="2">
+            <a:schemeClr val="accent1"/>
+          </a:lnRef>
+          <a:fillRef idx="0">
+            <a:schemeClr val="accent1"/>
+          </a:fillRef>
+          <a:effectRef idx="1">
+            <a:schemeClr val="accent1"/>
+          </a:effectRef>
+          <a:fontRef idx="minor">
+            <a:schemeClr val="tx1"/>
+          </a:fontRef>
+        </p:style>
+      </p:cxnSp>
+      <p:sp>
+        <p:nvSpPr>
+          <p:cNvPr id="8" name="ZoneTexte 7">
+            <a:extLst>
+              <a:ext uri="{FF2B5EF4-FFF2-40B4-BE49-F238E27FC236}">
+                <a16:creationId xmlns:a16="http://schemas.microsoft.com/office/drawing/2014/main" id="{4E776ECC-BF7D-8207-456C-62171DFE4C4D}"/>
+              </a:ext>
+            </a:extLst>
+          </p:cNvPr>
+          <p:cNvSpPr txBox="1"/>
+          <p:nvPr/>
+        </p:nvSpPr>
+        <p:spPr>
+          <a:xfrm>
+            <a:off x="3031834" y="1168509"/>
+            <a:ext cx="484428" cy="307777"/>
+          </a:xfrm>
+          <a:prstGeom prst="rect">
+            <a:avLst/>
+          </a:prstGeom>
+          <a:solidFill>
+            <a:schemeClr val="bg1">
+              <a:lumMod val="95000"/>
+              <a:alpha val="70000"/>
+            </a:schemeClr>
+          </a:solidFill>
+        </p:spPr>
+        <p:txBody>
+          <a:bodyPr wrap="none" rtlCol="0">
+            <a:spAutoFit/>
+          </a:bodyPr>
+          <a:lstStyle/>
+          <a:p>
+            <a:r>
+              <a:rPr lang="fr-FR" sz="1400" dirty="0"/>
+              <a:t>w1  </a:t>
+            </a:r>
+            <a:endParaRPr lang="fr-FR" sz="2000" dirty="0"/>
+          </a:p>
+        </p:txBody>
+      </p:sp>
+      <p:sp>
+        <p:nvSpPr>
+          <p:cNvPr id="10" name="Rectangle 9">
+            <a:extLst>
+              <a:ext uri="{FF2B5EF4-FFF2-40B4-BE49-F238E27FC236}">
+                <a16:creationId xmlns:a16="http://schemas.microsoft.com/office/drawing/2014/main" id="{FC8177DB-C9B0-9851-C5E5-9598A08A41B1}"/>
+              </a:ext>
+            </a:extLst>
+          </p:cNvPr>
+          <p:cNvSpPr/>
+          <p:nvPr/>
+        </p:nvSpPr>
+        <p:spPr>
+          <a:xfrm>
+            <a:off x="4101326" y="1222837"/>
+            <a:ext cx="587269" cy="510363"/>
+          </a:xfrm>
+          <a:prstGeom prst="rect">
+            <a:avLst/>
+          </a:prstGeom>
+          <a:noFill/>
+          <a:ln>
+            <a:solidFill>
+              <a:schemeClr val="bg1">
+                <a:lumMod val="75000"/>
+              </a:schemeClr>
+            </a:solidFill>
+          </a:ln>
+        </p:spPr>
+        <p:style>
+          <a:lnRef idx="2">
+            <a:schemeClr val="accent1">
+              <a:shade val="15000"/>
+            </a:schemeClr>
+          </a:lnRef>
+          <a:fillRef idx="1">
+            <a:schemeClr val="accent1"/>
+          </a:fillRef>
+          <a:effectRef idx="0">
+            <a:schemeClr val="accent1"/>
+          </a:effectRef>
+          <a:fontRef idx="minor">
+            <a:schemeClr val="lt1"/>
+          </a:fontRef>
+        </p:style>
+        <p:txBody>
           <a:bodyPr rtlCol="0" anchor="ctr"/>
           <a:lstStyle/>
           <a:p>
             <a:pPr algn="ctr"/>
-            <a:r>
-              <a:rPr lang="fr-FR" sz="1000" dirty="0"/>
-              <a:t>b0</a:t>
-            </a:r>
-          </a:p>
-        </p:txBody>
-      </p:sp>
-      <p:sp>
-        <p:nvSpPr>
-          <p:cNvPr id="6" name="Ellipse 5">
-            <a:extLst>
-              <a:ext uri="{FF2B5EF4-FFF2-40B4-BE49-F238E27FC236}">
-                <a16:creationId xmlns:a16="http://schemas.microsoft.com/office/drawing/2014/main" id="{244181EC-568A-357B-0563-3C889EC83BA9}"/>
+            <a:endParaRPr lang="fr-FR"/>
+          </a:p>
+        </p:txBody>
+      </p:sp>
+      <p:sp>
+        <p:nvSpPr>
+          <p:cNvPr id="11" name="ZoneTexte 10">
+            <a:extLst>
+              <a:ext uri="{FF2B5EF4-FFF2-40B4-BE49-F238E27FC236}">
+                <a16:creationId xmlns:a16="http://schemas.microsoft.com/office/drawing/2014/main" id="{5C4B744E-57A2-63DD-6FFB-23C53A0E646B}"/>
+              </a:ext>
+            </a:extLst>
+          </p:cNvPr>
+          <p:cNvSpPr txBox="1"/>
+          <p:nvPr/>
+        </p:nvSpPr>
+        <p:spPr>
+          <a:xfrm>
+            <a:off x="4226055" y="1218489"/>
+            <a:ext cx="346570" cy="461665"/>
+          </a:xfrm>
+          <a:prstGeom prst="rect">
+            <a:avLst/>
+          </a:prstGeom>
+          <a:noFill/>
+        </p:spPr>
+        <p:txBody>
+          <a:bodyPr wrap="none" rtlCol="0">
+            <a:spAutoFit/>
+          </a:bodyPr>
+          <a:lstStyle/>
+          <a:p>
+            <a:r>
+              <a:rPr lang="fr-FR" sz="2400" dirty="0"/>
+              <a:t>∑</a:t>
+            </a:r>
+          </a:p>
+        </p:txBody>
+      </p:sp>
+      <p:sp>
+        <p:nvSpPr>
+          <p:cNvPr id="12" name="ZoneTexte 11">
+            <a:extLst>
+              <a:ext uri="{FF2B5EF4-FFF2-40B4-BE49-F238E27FC236}">
+                <a16:creationId xmlns:a16="http://schemas.microsoft.com/office/drawing/2014/main" id="{E69E1F0A-0725-3119-C24C-85E52181EED4}"/>
+              </a:ext>
+            </a:extLst>
+          </p:cNvPr>
+          <p:cNvSpPr txBox="1"/>
+          <p:nvPr/>
+        </p:nvSpPr>
+        <p:spPr>
+          <a:xfrm>
+            <a:off x="7305676" y="631458"/>
+            <a:ext cx="1022652" cy="369332"/>
+          </a:xfrm>
+          <a:prstGeom prst="rect">
+            <a:avLst/>
+          </a:prstGeom>
+          <a:noFill/>
+        </p:spPr>
+        <p:txBody>
+          <a:bodyPr wrap="none" rtlCol="0">
+            <a:spAutoFit/>
+          </a:bodyPr>
+          <a:lstStyle/>
+          <a:p>
+            <a:r>
+              <a:rPr lang="fr-FR" dirty="0"/>
+              <a:t>Feu vert </a:t>
+            </a:r>
+          </a:p>
+        </p:txBody>
+      </p:sp>
+      <p:sp>
+        <p:nvSpPr>
+          <p:cNvPr id="13" name="ZoneTexte 12">
+            <a:extLst>
+              <a:ext uri="{FF2B5EF4-FFF2-40B4-BE49-F238E27FC236}">
+                <a16:creationId xmlns:a16="http://schemas.microsoft.com/office/drawing/2014/main" id="{A4B2599E-2F49-AB75-FD8C-DBBC0B9B11A4}"/>
+              </a:ext>
+            </a:extLst>
+          </p:cNvPr>
+          <p:cNvSpPr txBox="1"/>
+          <p:nvPr/>
+        </p:nvSpPr>
+        <p:spPr>
+          <a:xfrm>
+            <a:off x="634121" y="613286"/>
+            <a:ext cx="1277979" cy="369332"/>
+          </a:xfrm>
+          <a:prstGeom prst="rect">
+            <a:avLst/>
+          </a:prstGeom>
+          <a:noFill/>
+        </p:spPr>
+        <p:txBody>
+          <a:bodyPr wrap="none" rtlCol="0">
+            <a:spAutoFit/>
+          </a:bodyPr>
+          <a:lstStyle/>
+          <a:p>
+            <a:r>
+              <a:rPr lang="fr-FR" dirty="0"/>
+              <a:t>Numéro: 1</a:t>
+            </a:r>
+          </a:p>
+        </p:txBody>
+      </p:sp>
+      <p:sp>
+        <p:nvSpPr>
+          <p:cNvPr id="14" name="ZoneTexte 13">
+            <a:extLst>
+              <a:ext uri="{FF2B5EF4-FFF2-40B4-BE49-F238E27FC236}">
+                <a16:creationId xmlns:a16="http://schemas.microsoft.com/office/drawing/2014/main" id="{F770EE4D-9489-C6DD-B6B1-0092FFBBF896}"/>
+              </a:ext>
+            </a:extLst>
+          </p:cNvPr>
+          <p:cNvSpPr txBox="1"/>
+          <p:nvPr/>
+        </p:nvSpPr>
+        <p:spPr>
+          <a:xfrm>
+            <a:off x="3858775" y="613286"/>
+            <a:ext cx="939681" cy="369332"/>
+          </a:xfrm>
+          <a:prstGeom prst="rect">
+            <a:avLst/>
+          </a:prstGeom>
+          <a:noFill/>
+        </p:spPr>
+        <p:txBody>
+          <a:bodyPr wrap="none" rtlCol="0">
+            <a:spAutoFit/>
+          </a:bodyPr>
+          <a:lstStyle/>
+          <a:p>
+            <a:r>
+              <a:rPr lang="fr-FR" dirty="0"/>
+              <a:t>somme</a:t>
+            </a:r>
+          </a:p>
+        </p:txBody>
+      </p:sp>
+      <p:sp>
+        <p:nvSpPr>
+          <p:cNvPr id="15" name="ZoneTexte 14">
+            <a:extLst>
+              <a:ext uri="{FF2B5EF4-FFF2-40B4-BE49-F238E27FC236}">
+                <a16:creationId xmlns:a16="http://schemas.microsoft.com/office/drawing/2014/main" id="{9374FABC-2E80-5AC3-8009-1E1076185950}"/>
+              </a:ext>
+            </a:extLst>
+          </p:cNvPr>
+          <p:cNvSpPr txBox="1"/>
+          <p:nvPr/>
+        </p:nvSpPr>
+        <p:spPr>
+          <a:xfrm>
+            <a:off x="4853251" y="613286"/>
+            <a:ext cx="785793" cy="369332"/>
+          </a:xfrm>
+          <a:prstGeom prst="rect">
+            <a:avLst/>
+          </a:prstGeom>
+          <a:noFill/>
+        </p:spPr>
+        <p:txBody>
+          <a:bodyPr wrap="none" rtlCol="0">
+            <a:spAutoFit/>
+          </a:bodyPr>
+          <a:lstStyle/>
+          <a:p>
+            <a:r>
+              <a:rPr lang="fr-FR" dirty="0"/>
+              <a:t>- seuil</a:t>
+            </a:r>
+          </a:p>
+        </p:txBody>
+      </p:sp>
+      <p:sp>
+        <p:nvSpPr>
+          <p:cNvPr id="16" name="ZoneTexte 15">
+            <a:extLst>
+              <a:ext uri="{FF2B5EF4-FFF2-40B4-BE49-F238E27FC236}">
+                <a16:creationId xmlns:a16="http://schemas.microsoft.com/office/drawing/2014/main" id="{0276C022-E67C-8B4F-F462-473922A1AF2E}"/>
+              </a:ext>
+            </a:extLst>
+          </p:cNvPr>
+          <p:cNvSpPr txBox="1"/>
+          <p:nvPr/>
+        </p:nvSpPr>
+        <p:spPr>
+          <a:xfrm>
+            <a:off x="2883637" y="613286"/>
+            <a:ext cx="912429" cy="369332"/>
+          </a:xfrm>
+          <a:prstGeom prst="rect">
+            <a:avLst/>
+          </a:prstGeom>
+          <a:noFill/>
+        </p:spPr>
+        <p:txBody>
+          <a:bodyPr wrap="none" rtlCol="0">
+            <a:spAutoFit/>
+          </a:bodyPr>
+          <a:lstStyle/>
+          <a:p>
+            <a:r>
+              <a:rPr lang="fr-FR" sz="1400" dirty="0"/>
+              <a:t>X</a:t>
+            </a:r>
+            <a:r>
+              <a:rPr lang="fr-FR" dirty="0"/>
+              <a:t> poids</a:t>
+            </a:r>
+          </a:p>
+        </p:txBody>
+      </p:sp>
+      <p:cxnSp>
+        <p:nvCxnSpPr>
+          <p:cNvPr id="17" name="Connecteur en angle 10">
+            <a:extLst>
+              <a:ext uri="{FF2B5EF4-FFF2-40B4-BE49-F238E27FC236}">
+                <a16:creationId xmlns:a16="http://schemas.microsoft.com/office/drawing/2014/main" id="{18462B41-1833-7A1A-01C8-8A0635968AA2}"/>
+              </a:ext>
+            </a:extLst>
+          </p:cNvPr>
+          <p:cNvCxnSpPr>
+            <a:cxnSpLocks/>
+            <a:stCxn id="10" idx="3"/>
+            <a:endCxn id="26" idx="1"/>
+          </p:cNvCxnSpPr>
+          <p:nvPr/>
+        </p:nvCxnSpPr>
+        <p:spPr>
+          <a:xfrm flipV="1">
+            <a:off x="4688595" y="1469573"/>
+            <a:ext cx="1407405" cy="8446"/>
+          </a:xfrm>
+          <a:prstGeom prst="bentConnector3">
+            <a:avLst>
+              <a:gd name="adj1" fmla="val 50000"/>
+            </a:avLst>
+          </a:prstGeom>
+        </p:spPr>
+        <p:style>
+          <a:lnRef idx="2">
+            <a:schemeClr val="accent1"/>
+          </a:lnRef>
+          <a:fillRef idx="0">
+            <a:schemeClr val="accent1"/>
+          </a:fillRef>
+          <a:effectRef idx="1">
+            <a:schemeClr val="accent1"/>
+          </a:effectRef>
+          <a:fontRef idx="minor">
+            <a:schemeClr val="tx1"/>
+          </a:fontRef>
+        </p:style>
+      </p:cxnSp>
+      <p:sp>
+        <p:nvSpPr>
+          <p:cNvPr id="18" name="Forme libre 17">
+            <a:extLst>
+              <a:ext uri="{FF2B5EF4-FFF2-40B4-BE49-F238E27FC236}">
+                <a16:creationId xmlns:a16="http://schemas.microsoft.com/office/drawing/2014/main" id="{96251E97-F168-96DB-AEDE-051925FF25DD}"/>
               </a:ext>
             </a:extLst>
           </p:cNvPr>
@@ -6899,8 +7331,387 @@
           <p:nvPr/>
         </p:nvSpPr>
         <p:spPr>
-          <a:xfrm>
-            <a:off x="4427040" y="5019145"/>
+          <a:xfrm rot="16557881" flipV="1">
+            <a:off x="5002989" y="1431699"/>
+            <a:ext cx="574334" cy="289722"/>
+          </a:xfrm>
+          <a:custGeom>
+            <a:avLst/>
+            <a:gdLst>
+              <a:gd name="csX0" fmla="*/ 112238 w 920336"/>
+              <a:gd name="csY0" fmla="*/ 0 h 497502"/>
+              <a:gd name="csX1" fmla="*/ 920313 w 920336"/>
+              <a:gd name="csY1" fmla="*/ 159488 h 497502"/>
+              <a:gd name="csX2" fmla="*/ 90973 w 920336"/>
+              <a:gd name="csY2" fmla="*/ 467832 h 497502"/>
+              <a:gd name="csX3" fmla="*/ 59075 w 920336"/>
+              <a:gd name="csY3" fmla="*/ 467832 h 497502"/>
+            </a:gdLst>
+            <a:ahLst/>
+            <a:cxnLst>
+              <a:cxn ang="0">
+                <a:pos x="csX0" y="csY0"/>
+              </a:cxn>
+              <a:cxn ang="0">
+                <a:pos x="csX1" y="csY1"/>
+              </a:cxn>
+              <a:cxn ang="0">
+                <a:pos x="csX2" y="csY2"/>
+              </a:cxn>
+              <a:cxn ang="0">
+                <a:pos x="csX3" y="csY3"/>
+              </a:cxn>
+            </a:cxnLst>
+            <a:rect l="l" t="t" r="r" b="b"/>
+            <a:pathLst>
+              <a:path w="920336" h="497502">
+                <a:moveTo>
+                  <a:pt x="112238" y="0"/>
+                </a:moveTo>
+                <a:cubicBezTo>
+                  <a:pt x="518047" y="40758"/>
+                  <a:pt x="923857" y="81516"/>
+                  <a:pt x="920313" y="159488"/>
+                </a:cubicBezTo>
+                <a:cubicBezTo>
+                  <a:pt x="916769" y="237460"/>
+                  <a:pt x="234513" y="416441"/>
+                  <a:pt x="90973" y="467832"/>
+                </a:cubicBezTo>
+                <a:cubicBezTo>
+                  <a:pt x="-52567" y="519223"/>
+                  <a:pt x="3254" y="493527"/>
+                  <a:pt x="59075" y="467832"/>
+                </a:cubicBezTo>
+              </a:path>
+            </a:pathLst>
+          </a:custGeom>
+          <a:solidFill>
+            <a:schemeClr val="bg2">
+              <a:lumMod val="90000"/>
+            </a:schemeClr>
+          </a:solidFill>
+        </p:spPr>
+        <p:style>
+          <a:lnRef idx="2">
+            <a:schemeClr val="accent1">
+              <a:shade val="15000"/>
+            </a:schemeClr>
+          </a:lnRef>
+          <a:fillRef idx="1">
+            <a:schemeClr val="accent1"/>
+          </a:fillRef>
+          <a:effectRef idx="0">
+            <a:schemeClr val="accent1"/>
+          </a:effectRef>
+          <a:fontRef idx="minor">
+            <a:schemeClr val="lt1"/>
+          </a:fontRef>
+        </p:style>
+        <p:txBody>
+          <a:bodyPr rtlCol="0" anchor="ctr"/>
+          <a:lstStyle/>
+          <a:p>
+            <a:pPr algn="ctr"/>
+            <a:endParaRPr lang="fr-FR" dirty="0"/>
+          </a:p>
+        </p:txBody>
+      </p:sp>
+      <p:sp>
+        <p:nvSpPr>
+          <p:cNvPr id="19" name="Rectangle 18">
+            <a:extLst>
+              <a:ext uri="{FF2B5EF4-FFF2-40B4-BE49-F238E27FC236}">
+                <a16:creationId xmlns:a16="http://schemas.microsoft.com/office/drawing/2014/main" id="{E6102F1A-EEEB-F1F4-A618-276E1A2299D6}"/>
+              </a:ext>
+            </a:extLst>
+          </p:cNvPr>
+          <p:cNvSpPr/>
+          <p:nvPr/>
+        </p:nvSpPr>
+        <p:spPr>
+          <a:xfrm>
+            <a:off x="2883638" y="1117809"/>
+            <a:ext cx="2772410" cy="816373"/>
+          </a:xfrm>
+          <a:prstGeom prst="rect">
+            <a:avLst/>
+          </a:prstGeom>
+          <a:noFill/>
+          <a:ln>
+            <a:solidFill>
+              <a:schemeClr val="bg1">
+                <a:lumMod val="65000"/>
+              </a:schemeClr>
+            </a:solidFill>
+          </a:ln>
+        </p:spPr>
+        <p:style>
+          <a:lnRef idx="2">
+            <a:schemeClr val="accent1">
+              <a:shade val="15000"/>
+            </a:schemeClr>
+          </a:lnRef>
+          <a:fillRef idx="1">
+            <a:schemeClr val="accent1"/>
+          </a:fillRef>
+          <a:effectRef idx="0">
+            <a:schemeClr val="accent1"/>
+          </a:effectRef>
+          <a:fontRef idx="minor">
+            <a:schemeClr val="lt1"/>
+          </a:fontRef>
+        </p:style>
+        <p:txBody>
+          <a:bodyPr rtlCol="0" anchor="ctr"/>
+          <a:lstStyle/>
+          <a:p>
+            <a:pPr algn="ctr"/>
+            <a:endParaRPr lang="fr-FR"/>
+          </a:p>
+        </p:txBody>
+      </p:sp>
+      <p:sp>
+        <p:nvSpPr>
+          <p:cNvPr id="20" name="ZoneTexte 19">
+            <a:extLst>
+              <a:ext uri="{FF2B5EF4-FFF2-40B4-BE49-F238E27FC236}">
+                <a16:creationId xmlns:a16="http://schemas.microsoft.com/office/drawing/2014/main" id="{E050CEBA-4B2E-6124-FA3D-BC1D89BA8C23}"/>
+              </a:ext>
+            </a:extLst>
+          </p:cNvPr>
+          <p:cNvSpPr txBox="1"/>
+          <p:nvPr/>
+        </p:nvSpPr>
+        <p:spPr>
+          <a:xfrm>
+            <a:off x="3031834" y="1513559"/>
+            <a:ext cx="447558" cy="307777"/>
+          </a:xfrm>
+          <a:prstGeom prst="rect">
+            <a:avLst/>
+          </a:prstGeom>
+          <a:solidFill>
+            <a:schemeClr val="bg1">
+              <a:lumMod val="95000"/>
+              <a:alpha val="70000"/>
+            </a:schemeClr>
+          </a:solidFill>
+        </p:spPr>
+        <p:txBody>
+          <a:bodyPr wrap="none" rtlCol="0">
+            <a:spAutoFit/>
+          </a:bodyPr>
+          <a:lstStyle/>
+          <a:p>
+            <a:r>
+              <a:rPr lang="fr-FR" sz="1400" dirty="0"/>
+              <a:t>w2 </a:t>
+            </a:r>
+            <a:endParaRPr lang="fr-FR" sz="2000" dirty="0"/>
+          </a:p>
+        </p:txBody>
+      </p:sp>
+      <p:sp>
+        <p:nvSpPr>
+          <p:cNvPr id="24" name="ZoneTexte 23">
+            <a:extLst>
+              <a:ext uri="{FF2B5EF4-FFF2-40B4-BE49-F238E27FC236}">
+                <a16:creationId xmlns:a16="http://schemas.microsoft.com/office/drawing/2014/main" id="{0699CCA4-648B-41A9-2CF7-7EFE34389318}"/>
+              </a:ext>
+            </a:extLst>
+          </p:cNvPr>
+          <p:cNvSpPr txBox="1"/>
+          <p:nvPr/>
+        </p:nvSpPr>
+        <p:spPr>
+          <a:xfrm>
+            <a:off x="5068315" y="1218218"/>
+            <a:ext cx="308098" cy="307777"/>
+          </a:xfrm>
+          <a:prstGeom prst="rect">
+            <a:avLst/>
+          </a:prstGeom>
+          <a:solidFill>
+            <a:schemeClr val="bg1">
+              <a:lumMod val="95000"/>
+              <a:alpha val="70000"/>
+            </a:schemeClr>
+          </a:solidFill>
+        </p:spPr>
+        <p:txBody>
+          <a:bodyPr wrap="none" rtlCol="0">
+            <a:spAutoFit/>
+          </a:bodyPr>
+          <a:lstStyle/>
+          <a:p>
+            <a:r>
+              <a:rPr lang="fr-FR" sz="1400" dirty="0"/>
+              <a:t>s </a:t>
+            </a:r>
+            <a:endParaRPr lang="fr-FR" sz="2000" dirty="0"/>
+          </a:p>
+        </p:txBody>
+      </p:sp>
+      <p:sp>
+        <p:nvSpPr>
+          <p:cNvPr id="26" name="Accolade ouvrante 25">
+            <a:extLst>
+              <a:ext uri="{FF2B5EF4-FFF2-40B4-BE49-F238E27FC236}">
+                <a16:creationId xmlns:a16="http://schemas.microsoft.com/office/drawing/2014/main" id="{6C3E41C7-B061-0535-5D2D-0499E84C1D4D}"/>
+              </a:ext>
+            </a:extLst>
+          </p:cNvPr>
+          <p:cNvSpPr/>
+          <p:nvPr/>
+        </p:nvSpPr>
+        <p:spPr>
+          <a:xfrm>
+            <a:off x="6096000" y="1117809"/>
+            <a:ext cx="198474" cy="703527"/>
+          </a:xfrm>
+          <a:prstGeom prst="leftBrace">
+            <a:avLst/>
+          </a:prstGeom>
+          <a:ln>
+            <a:solidFill>
+              <a:schemeClr val="accent2">
+                <a:lumMod val="75000"/>
+              </a:schemeClr>
+            </a:solidFill>
+          </a:ln>
+        </p:spPr>
+        <p:style>
+          <a:lnRef idx="2">
+            <a:schemeClr val="accent1"/>
+          </a:lnRef>
+          <a:fillRef idx="0">
+            <a:schemeClr val="accent1"/>
+          </a:fillRef>
+          <a:effectRef idx="1">
+            <a:schemeClr val="accent1"/>
+          </a:effectRef>
+          <a:fontRef idx="minor">
+            <a:schemeClr val="tx1"/>
+          </a:fontRef>
+        </p:style>
+        <p:txBody>
+          <a:bodyPr rtlCol="0" anchor="ctr"/>
+          <a:lstStyle/>
+          <a:p>
+            <a:pPr algn="ctr"/>
+            <a:endParaRPr lang="fr-FR"/>
+          </a:p>
+        </p:txBody>
+      </p:sp>
+      <p:sp>
+        <p:nvSpPr>
+          <p:cNvPr id="27" name="Accolade fermante 26">
+            <a:extLst>
+              <a:ext uri="{FF2B5EF4-FFF2-40B4-BE49-F238E27FC236}">
+                <a16:creationId xmlns:a16="http://schemas.microsoft.com/office/drawing/2014/main" id="{BF4B874E-8B9C-F2DB-2418-734BB7BA22BF}"/>
+              </a:ext>
+            </a:extLst>
+          </p:cNvPr>
+          <p:cNvSpPr/>
+          <p:nvPr/>
+        </p:nvSpPr>
+        <p:spPr>
+          <a:xfrm>
+            <a:off x="6724301" y="1059946"/>
+            <a:ext cx="197481" cy="793810"/>
+          </a:xfrm>
+          <a:prstGeom prst="rightBrace">
+            <a:avLst/>
+          </a:prstGeom>
+          <a:ln>
+            <a:solidFill>
+              <a:schemeClr val="accent2">
+                <a:lumMod val="75000"/>
+              </a:schemeClr>
+            </a:solidFill>
+          </a:ln>
+        </p:spPr>
+        <p:style>
+          <a:lnRef idx="2">
+            <a:schemeClr val="accent1"/>
+          </a:lnRef>
+          <a:fillRef idx="0">
+            <a:schemeClr val="accent1"/>
+          </a:fillRef>
+          <a:effectRef idx="1">
+            <a:schemeClr val="accent1"/>
+          </a:effectRef>
+          <a:fontRef idx="minor">
+            <a:schemeClr val="tx1"/>
+          </a:fontRef>
+        </p:style>
+        <p:txBody>
+          <a:bodyPr rtlCol="0" anchor="ctr"/>
+          <a:lstStyle/>
+          <a:p>
+            <a:pPr algn="ctr"/>
+            <a:endParaRPr lang="fr-FR"/>
+          </a:p>
+        </p:txBody>
+      </p:sp>
+      <p:cxnSp>
+        <p:nvCxnSpPr>
+          <p:cNvPr id="28" name="Connecteur droit 27">
+            <a:extLst>
+              <a:ext uri="{FF2B5EF4-FFF2-40B4-BE49-F238E27FC236}">
+                <a16:creationId xmlns:a16="http://schemas.microsoft.com/office/drawing/2014/main" id="{39F8378A-80E1-C112-2507-8E1B7564B356}"/>
+              </a:ext>
+            </a:extLst>
+          </p:cNvPr>
+          <p:cNvCxnSpPr>
+            <a:cxnSpLocks/>
+            <a:stCxn id="27" idx="1"/>
+          </p:cNvCxnSpPr>
+          <p:nvPr/>
+        </p:nvCxnSpPr>
+        <p:spPr>
+          <a:xfrm flipV="1">
+            <a:off x="6921782" y="1452016"/>
+            <a:ext cx="767789" cy="4835"/>
+          </a:xfrm>
+          <a:prstGeom prst="line">
+            <a:avLst/>
+          </a:prstGeom>
+          <a:ln>
+            <a:tailEnd type="triangle"/>
+          </a:ln>
+        </p:spPr>
+        <p:style>
+          <a:lnRef idx="2">
+            <a:schemeClr val="accent1"/>
+          </a:lnRef>
+          <a:fillRef idx="0">
+            <a:schemeClr val="accent1"/>
+          </a:fillRef>
+          <a:effectRef idx="1">
+            <a:schemeClr val="accent1"/>
+          </a:effectRef>
+          <a:fontRef idx="minor">
+            <a:schemeClr val="tx1"/>
+          </a:fontRef>
+        </p:style>
+      </p:cxnSp>
+      <p:sp>
+        <p:nvSpPr>
+          <p:cNvPr id="31" name="Ellipse 30">
+            <a:extLst>
+              <a:ext uri="{FF2B5EF4-FFF2-40B4-BE49-F238E27FC236}">
+                <a16:creationId xmlns:a16="http://schemas.microsoft.com/office/drawing/2014/main" id="{62F5F92B-CAFD-F0DE-BA84-D019D3F04431}"/>
+              </a:ext>
+            </a:extLst>
+          </p:cNvPr>
+          <p:cNvSpPr/>
+          <p:nvPr/>
+        </p:nvSpPr>
+        <p:spPr>
+          <a:xfrm>
+            <a:off x="7689571" y="1196825"/>
             <a:ext cx="467833" cy="498894"/>
           </a:xfrm>
           <a:prstGeom prst="ellipse">
@@ -6945,6 +7756,254 @@
       </p:sp>
       <p:sp>
         <p:nvSpPr>
+          <p:cNvPr id="32" name="ZoneTexte 31">
+            <a:extLst>
+              <a:ext uri="{FF2B5EF4-FFF2-40B4-BE49-F238E27FC236}">
+                <a16:creationId xmlns:a16="http://schemas.microsoft.com/office/drawing/2014/main" id="{C12B165D-2033-93E6-875E-BFADD3F755E0}"/>
+              </a:ext>
+            </a:extLst>
+          </p:cNvPr>
+          <p:cNvSpPr txBox="1"/>
+          <p:nvPr/>
+        </p:nvSpPr>
+        <p:spPr>
+          <a:xfrm>
+            <a:off x="6228452" y="1236056"/>
+            <a:ext cx="554960" cy="369332"/>
+          </a:xfrm>
+          <a:prstGeom prst="rect">
+            <a:avLst/>
+          </a:prstGeom>
+          <a:noFill/>
+        </p:spPr>
+        <p:txBody>
+          <a:bodyPr wrap="none" rtlCol="0">
+            <a:spAutoFit/>
+          </a:bodyPr>
+          <a:lstStyle/>
+          <a:p>
+            <a:r>
+              <a:rPr lang="fr-FR" dirty="0"/>
+              <a:t>&gt;=0</a:t>
+            </a:r>
+          </a:p>
+        </p:txBody>
+      </p:sp>
+    </p:spTree>
+    <p:extLst>
+      <p:ext uri="{BB962C8B-B14F-4D97-AF65-F5344CB8AC3E}">
+        <p14:creationId xmlns:p14="http://schemas.microsoft.com/office/powerpoint/2010/main" val="60668950"/>
+      </p:ext>
+    </p:extLst>
+  </p:cSld>
+  <p:clrMapOvr>
+    <a:masterClrMapping/>
+  </p:clrMapOvr>
+</p:sld>
+</file>
+
+<file path=ppt/slides/slide4.xml><?xml version="1.0" encoding="utf-8"?>
+<p:sld xmlns:a="http://schemas.openxmlformats.org/drawingml/2006/main" xmlns:r="http://schemas.openxmlformats.org/officeDocument/2006/relationships" xmlns:p="http://schemas.openxmlformats.org/presentationml/2006/main">
+  <p:cSld>
+    <p:spTree>
+      <p:nvGrpSpPr>
+        <p:cNvPr id="1" name=""/>
+        <p:cNvGrpSpPr/>
+        <p:nvPr/>
+      </p:nvGrpSpPr>
+      <p:grpSpPr>
+        <a:xfrm>
+          <a:off x="0" y="0"/>
+          <a:ext cx="0" cy="0"/>
+          <a:chOff x="0" y="0"/>
+          <a:chExt cx="0" cy="0"/>
+        </a:xfrm>
+      </p:grpSpPr>
+      <p:sp>
+        <p:nvSpPr>
+          <p:cNvPr id="4" name="Ellipse 3">
+            <a:extLst>
+              <a:ext uri="{FF2B5EF4-FFF2-40B4-BE49-F238E27FC236}">
+                <a16:creationId xmlns:a16="http://schemas.microsoft.com/office/drawing/2014/main" id="{D91E3C53-8C18-E4B8-2C1B-41D54828848D}"/>
+              </a:ext>
+            </a:extLst>
+          </p:cNvPr>
+          <p:cNvSpPr/>
+          <p:nvPr/>
+        </p:nvSpPr>
+        <p:spPr>
+          <a:xfrm>
+            <a:off x="3462338" y="2237007"/>
+            <a:ext cx="467833" cy="467833"/>
+          </a:xfrm>
+          <a:prstGeom prst="ellipse">
+            <a:avLst/>
+          </a:prstGeom>
+          <a:solidFill>
+            <a:schemeClr val="tx2">
+              <a:lumMod val="50000"/>
+              <a:lumOff val="50000"/>
+            </a:schemeClr>
+          </a:solidFill>
+          <a:ln>
+            <a:solidFill>
+              <a:schemeClr val="tx2">
+                <a:lumMod val="50000"/>
+                <a:lumOff val="50000"/>
+              </a:schemeClr>
+            </a:solidFill>
+          </a:ln>
+        </p:spPr>
+        <p:style>
+          <a:lnRef idx="2">
+            <a:schemeClr val="accent1">
+              <a:shade val="15000"/>
+            </a:schemeClr>
+          </a:lnRef>
+          <a:fillRef idx="1">
+            <a:schemeClr val="accent1"/>
+          </a:fillRef>
+          <a:effectRef idx="0">
+            <a:schemeClr val="accent1"/>
+          </a:effectRef>
+          <a:fontRef idx="minor">
+            <a:schemeClr val="lt1"/>
+          </a:fontRef>
+        </p:style>
+        <p:txBody>
+          <a:bodyPr rtlCol="0" anchor="ctr"/>
+          <a:lstStyle/>
+          <a:p>
+            <a:pPr algn="ctr"/>
+            <a:r>
+              <a:rPr lang="fr-FR" sz="1000" dirty="0"/>
+              <a:t>b1</a:t>
+            </a:r>
+          </a:p>
+        </p:txBody>
+      </p:sp>
+      <p:sp>
+        <p:nvSpPr>
+          <p:cNvPr id="5" name="Ellipse 4">
+            <a:extLst>
+              <a:ext uri="{FF2B5EF4-FFF2-40B4-BE49-F238E27FC236}">
+                <a16:creationId xmlns:a16="http://schemas.microsoft.com/office/drawing/2014/main" id="{EFC181F5-CC98-03A8-C9AE-41434A5B6615}"/>
+              </a:ext>
+            </a:extLst>
+          </p:cNvPr>
+          <p:cNvSpPr/>
+          <p:nvPr/>
+        </p:nvSpPr>
+        <p:spPr>
+          <a:xfrm>
+            <a:off x="3497644" y="3037881"/>
+            <a:ext cx="467833" cy="467833"/>
+          </a:xfrm>
+          <a:prstGeom prst="ellipse">
+            <a:avLst/>
+          </a:prstGeom>
+          <a:solidFill>
+            <a:schemeClr val="tx2">
+              <a:lumMod val="50000"/>
+              <a:lumOff val="50000"/>
+            </a:schemeClr>
+          </a:solidFill>
+          <a:ln>
+            <a:solidFill>
+              <a:schemeClr val="tx2">
+                <a:lumMod val="50000"/>
+                <a:lumOff val="50000"/>
+              </a:schemeClr>
+            </a:solidFill>
+          </a:ln>
+        </p:spPr>
+        <p:style>
+          <a:lnRef idx="2">
+            <a:schemeClr val="accent1">
+              <a:shade val="15000"/>
+            </a:schemeClr>
+          </a:lnRef>
+          <a:fillRef idx="1">
+            <a:schemeClr val="accent1"/>
+          </a:fillRef>
+          <a:effectRef idx="0">
+            <a:schemeClr val="accent1"/>
+          </a:effectRef>
+          <a:fontRef idx="minor">
+            <a:schemeClr val="lt1"/>
+          </a:fontRef>
+        </p:style>
+        <p:txBody>
+          <a:bodyPr rtlCol="0" anchor="ctr"/>
+          <a:lstStyle/>
+          <a:p>
+            <a:pPr algn="ctr"/>
+            <a:r>
+              <a:rPr lang="fr-FR" sz="1000" dirty="0"/>
+              <a:t>b0</a:t>
+            </a:r>
+          </a:p>
+        </p:txBody>
+      </p:sp>
+      <p:sp>
+        <p:nvSpPr>
+          <p:cNvPr id="6" name="Ellipse 5">
+            <a:extLst>
+              <a:ext uri="{FF2B5EF4-FFF2-40B4-BE49-F238E27FC236}">
+                <a16:creationId xmlns:a16="http://schemas.microsoft.com/office/drawing/2014/main" id="{244181EC-568A-357B-0563-3C889EC83BA9}"/>
+              </a:ext>
+            </a:extLst>
+          </p:cNvPr>
+          <p:cNvSpPr/>
+          <p:nvPr/>
+        </p:nvSpPr>
+        <p:spPr>
+          <a:xfrm>
+            <a:off x="4739380" y="5591734"/>
+            <a:ext cx="467833" cy="498894"/>
+          </a:xfrm>
+          <a:prstGeom prst="ellipse">
+            <a:avLst/>
+          </a:prstGeom>
+          <a:solidFill>
+            <a:srgbClr val="00B050"/>
+          </a:solidFill>
+          <a:ln>
+            <a:solidFill>
+              <a:schemeClr val="tx2">
+                <a:lumMod val="50000"/>
+                <a:lumOff val="50000"/>
+              </a:schemeClr>
+            </a:solidFill>
+          </a:ln>
+        </p:spPr>
+        <p:style>
+          <a:lnRef idx="2">
+            <a:schemeClr val="accent1">
+              <a:shade val="15000"/>
+            </a:schemeClr>
+          </a:lnRef>
+          <a:fillRef idx="1">
+            <a:schemeClr val="accent1"/>
+          </a:fillRef>
+          <a:effectRef idx="0">
+            <a:schemeClr val="accent1"/>
+          </a:effectRef>
+          <a:fontRef idx="minor">
+            <a:schemeClr val="lt1"/>
+          </a:fontRef>
+        </p:style>
+        <p:txBody>
+          <a:bodyPr rtlCol="0" anchor="ctr"/>
+          <a:lstStyle/>
+          <a:p>
+            <a:pPr algn="ctr"/>
+            <a:endParaRPr lang="fr-FR"/>
+          </a:p>
+        </p:txBody>
+      </p:sp>
+      <p:sp>
+        <p:nvSpPr>
           <p:cNvPr id="7" name="Ellipse 6">
             <a:extLst>
               <a:ext uri="{FF2B5EF4-FFF2-40B4-BE49-F238E27FC236}">
@@ -6957,7 +8016,7 @@
         </p:nvSpPr>
         <p:spPr>
           <a:xfrm>
-            <a:off x="5486726" y="5051603"/>
+            <a:off x="5776518" y="5559645"/>
             <a:ext cx="467833" cy="498894"/>
           </a:xfrm>
           <a:prstGeom prst="ellipse">
@@ -7014,7 +8073,7 @@
         </p:nvSpPr>
         <p:spPr>
           <a:xfrm>
-            <a:off x="6460501" y="5019145"/>
+            <a:off x="6734069" y="5557512"/>
             <a:ext cx="467833" cy="498894"/>
           </a:xfrm>
           <a:prstGeom prst="ellipse">
@@ -7181,220 +8240,6 @@
           </a:fontRef>
         </p:style>
       </p:cxnSp>
-      <p:grpSp>
-        <p:nvGrpSpPr>
-          <p:cNvPr id="61" name="Groupe 60">
-            <a:extLst>
-              <a:ext uri="{FF2B5EF4-FFF2-40B4-BE49-F238E27FC236}">
-                <a16:creationId xmlns:a16="http://schemas.microsoft.com/office/drawing/2014/main" id="{BA3CD5CB-4589-9DB8-7253-A0EEA4208ED6}"/>
-              </a:ext>
-            </a:extLst>
-          </p:cNvPr>
-          <p:cNvGrpSpPr/>
-          <p:nvPr/>
-        </p:nvGrpSpPr>
-        <p:grpSpPr>
-          <a:xfrm>
-            <a:off x="4088528" y="4568549"/>
-            <a:ext cx="4845726" cy="574334"/>
-            <a:chOff x="4073236" y="3882289"/>
-            <a:chExt cx="4845726" cy="574334"/>
-          </a:xfrm>
-        </p:grpSpPr>
-        <p:cxnSp>
-          <p:nvCxnSpPr>
-            <p:cNvPr id="41" name="Connecteur droit 40">
-              <a:extLst>
-                <a:ext uri="{FF2B5EF4-FFF2-40B4-BE49-F238E27FC236}">
-                  <a16:creationId xmlns:a16="http://schemas.microsoft.com/office/drawing/2014/main" id="{253AF414-CC8B-5FFB-18C1-6D7658DB5B0D}"/>
-                </a:ext>
-              </a:extLst>
-            </p:cNvPr>
-            <p:cNvCxnSpPr>
-              <a:cxnSpLocks/>
-            </p:cNvCxnSpPr>
-            <p:nvPr/>
-          </p:nvCxnSpPr>
-          <p:spPr>
-            <a:xfrm>
-              <a:off x="4073236" y="4156364"/>
-              <a:ext cx="3990109" cy="0"/>
-            </a:xfrm>
-            <a:prstGeom prst="line">
-              <a:avLst/>
-            </a:prstGeom>
-            <a:ln>
-              <a:solidFill>
-                <a:schemeClr val="bg1">
-                  <a:lumMod val="50000"/>
-                </a:schemeClr>
-              </a:solidFill>
-            </a:ln>
-          </p:spPr>
-          <p:style>
-            <a:lnRef idx="2">
-              <a:schemeClr val="accent1"/>
-            </a:lnRef>
-            <a:fillRef idx="0">
-              <a:schemeClr val="accent1"/>
-            </a:fillRef>
-            <a:effectRef idx="1">
-              <a:schemeClr val="accent1"/>
-            </a:effectRef>
-            <a:fontRef idx="minor">
-              <a:schemeClr val="tx1"/>
-            </a:fontRef>
-          </p:style>
-        </p:cxnSp>
-        <p:sp>
-          <p:nvSpPr>
-            <p:cNvPr id="33" name="Forme libre 32">
-              <a:extLst>
-                <a:ext uri="{FF2B5EF4-FFF2-40B4-BE49-F238E27FC236}">
-                  <a16:creationId xmlns:a16="http://schemas.microsoft.com/office/drawing/2014/main" id="{D0C5F0D0-6017-6C2F-E040-CD482B43094D}"/>
-                </a:ext>
-              </a:extLst>
-            </p:cNvPr>
-            <p:cNvSpPr/>
-            <p:nvPr/>
-          </p:nvSpPr>
-          <p:spPr>
-            <a:xfrm rot="16557881" flipV="1">
-              <a:off x="7425856" y="4024595"/>
-              <a:ext cx="574334" cy="289722"/>
-            </a:xfrm>
-            <a:custGeom>
-              <a:avLst/>
-              <a:gdLst>
-                <a:gd name="csX0" fmla="*/ 112238 w 920336"/>
-                <a:gd name="csY0" fmla="*/ 0 h 497502"/>
-                <a:gd name="csX1" fmla="*/ 920313 w 920336"/>
-                <a:gd name="csY1" fmla="*/ 159488 h 497502"/>
-                <a:gd name="csX2" fmla="*/ 90973 w 920336"/>
-                <a:gd name="csY2" fmla="*/ 467832 h 497502"/>
-                <a:gd name="csX3" fmla="*/ 59075 w 920336"/>
-                <a:gd name="csY3" fmla="*/ 467832 h 497502"/>
-              </a:gdLst>
-              <a:ahLst/>
-              <a:cxnLst>
-                <a:cxn ang="0">
-                  <a:pos x="csX0" y="csY0"/>
-                </a:cxn>
-                <a:cxn ang="0">
-                  <a:pos x="csX1" y="csY1"/>
-                </a:cxn>
-                <a:cxn ang="0">
-                  <a:pos x="csX2" y="csY2"/>
-                </a:cxn>
-                <a:cxn ang="0">
-                  <a:pos x="csX3" y="csY3"/>
-                </a:cxn>
-              </a:cxnLst>
-              <a:rect l="l" t="t" r="r" b="b"/>
-              <a:pathLst>
-                <a:path w="920336" h="497502">
-                  <a:moveTo>
-                    <a:pt x="112238" y="0"/>
-                  </a:moveTo>
-                  <a:cubicBezTo>
-                    <a:pt x="518047" y="40758"/>
-                    <a:pt x="923857" y="81516"/>
-                    <a:pt x="920313" y="159488"/>
-                  </a:cubicBezTo>
-                  <a:cubicBezTo>
-                    <a:pt x="916769" y="237460"/>
-                    <a:pt x="234513" y="416441"/>
-                    <a:pt x="90973" y="467832"/>
-                  </a:cubicBezTo>
-                  <a:cubicBezTo>
-                    <a:pt x="-52567" y="519223"/>
-                    <a:pt x="3254" y="493527"/>
-                    <a:pt x="59075" y="467832"/>
-                  </a:cubicBezTo>
-                </a:path>
-              </a:pathLst>
-            </a:custGeom>
-            <a:solidFill>
-              <a:schemeClr val="bg2">
-                <a:lumMod val="90000"/>
-              </a:schemeClr>
-            </a:solidFill>
-            <a:ln>
-              <a:solidFill>
-                <a:schemeClr val="bg1">
-                  <a:lumMod val="50000"/>
-                </a:schemeClr>
-              </a:solidFill>
-            </a:ln>
-          </p:spPr>
-          <p:style>
-            <a:lnRef idx="2">
-              <a:schemeClr val="accent1">
-                <a:shade val="15000"/>
-              </a:schemeClr>
-            </a:lnRef>
-            <a:fillRef idx="1">
-              <a:schemeClr val="accent1"/>
-            </a:fillRef>
-            <a:effectRef idx="0">
-              <a:schemeClr val="accent1"/>
-            </a:effectRef>
-            <a:fontRef idx="minor">
-              <a:schemeClr val="lt1"/>
-            </a:fontRef>
-          </p:style>
-          <p:txBody>
-            <a:bodyPr rtlCol="0" anchor="ctr"/>
-            <a:lstStyle/>
-            <a:p>
-              <a:pPr algn="ctr"/>
-              <a:endParaRPr lang="fr-FR" dirty="0"/>
-            </a:p>
-          </p:txBody>
-        </p:sp>
-        <p:sp>
-          <p:nvSpPr>
-            <p:cNvPr id="43" name="ZoneTexte 42">
-              <a:extLst>
-                <a:ext uri="{FF2B5EF4-FFF2-40B4-BE49-F238E27FC236}">
-                  <a16:creationId xmlns:a16="http://schemas.microsoft.com/office/drawing/2014/main" id="{47074316-4440-F259-9431-28CBF5F83AA1}"/>
-                </a:ext>
-              </a:extLst>
-            </p:cNvPr>
-            <p:cNvSpPr txBox="1"/>
-            <p:nvPr/>
-          </p:nvSpPr>
-          <p:spPr>
-            <a:xfrm>
-              <a:off x="8258204" y="3984790"/>
-              <a:ext cx="660758" cy="369332"/>
-            </a:xfrm>
-            <a:prstGeom prst="rect">
-              <a:avLst/>
-            </a:prstGeom>
-            <a:noFill/>
-            <a:ln>
-              <a:solidFill>
-                <a:schemeClr val="bg1">
-                  <a:lumMod val="50000"/>
-                </a:schemeClr>
-              </a:solidFill>
-            </a:ln>
-          </p:spPr>
-          <p:txBody>
-            <a:bodyPr wrap="none" rtlCol="0">
-              <a:spAutoFit/>
-            </a:bodyPr>
-            <a:lstStyle/>
-            <a:p>
-              <a:r>
-                <a:rPr lang="fr-FR" dirty="0"/>
-                <a:t>seuil</a:t>
-              </a:r>
-            </a:p>
-          </p:txBody>
-        </p:sp>
-      </p:grpSp>
       <p:grpSp>
         <p:nvGrpSpPr>
           <p:cNvPr id="47" name="Groupe 46">
@@ -8112,134 +8957,6 @@
           </a:p>
         </p:txBody>
       </p:sp>
-      <p:cxnSp>
-        <p:nvCxnSpPr>
-          <p:cNvPr id="91" name="Connecteur droit avec flèche 90">
-            <a:extLst>
-              <a:ext uri="{FF2B5EF4-FFF2-40B4-BE49-F238E27FC236}">
-                <a16:creationId xmlns:a16="http://schemas.microsoft.com/office/drawing/2014/main" id="{8954D60D-B53F-4DEC-ECF3-EC87FD125A0E}"/>
-              </a:ext>
-            </a:extLst>
-          </p:cNvPr>
-          <p:cNvCxnSpPr>
-            <a:stCxn id="52" idx="2"/>
-            <a:endCxn id="6" idx="0"/>
-          </p:cNvCxnSpPr>
-          <p:nvPr/>
-        </p:nvCxnSpPr>
-        <p:spPr>
-          <a:xfrm flipH="1">
-            <a:off x="4660957" y="4488280"/>
-            <a:ext cx="655" cy="530865"/>
-          </a:xfrm>
-          <a:prstGeom prst="straightConnector1">
-            <a:avLst/>
-          </a:prstGeom>
-          <a:ln>
-            <a:tailEnd type="triangle"/>
-          </a:ln>
-        </p:spPr>
-        <p:style>
-          <a:lnRef idx="2">
-            <a:schemeClr val="accent1"/>
-          </a:lnRef>
-          <a:fillRef idx="0">
-            <a:schemeClr val="accent1"/>
-          </a:fillRef>
-          <a:effectRef idx="1">
-            <a:schemeClr val="accent1"/>
-          </a:effectRef>
-          <a:fontRef idx="minor">
-            <a:schemeClr val="tx1"/>
-          </a:fontRef>
-        </p:style>
-      </p:cxnSp>
-      <p:cxnSp>
-        <p:nvCxnSpPr>
-          <p:cNvPr id="92" name="Connecteur droit avec flèche 91">
-            <a:extLst>
-              <a:ext uri="{FF2B5EF4-FFF2-40B4-BE49-F238E27FC236}">
-                <a16:creationId xmlns:a16="http://schemas.microsoft.com/office/drawing/2014/main" id="{435AAAD7-0271-61F0-52A2-FD59FA8F0A8A}"/>
-              </a:ext>
-            </a:extLst>
-          </p:cNvPr>
-          <p:cNvCxnSpPr>
-            <a:cxnSpLocks/>
-            <a:stCxn id="55" idx="2"/>
-            <a:endCxn id="7" idx="0"/>
-          </p:cNvCxnSpPr>
-          <p:nvPr/>
-        </p:nvCxnSpPr>
-        <p:spPr>
-          <a:xfrm flipH="1">
-            <a:off x="5720643" y="4511215"/>
-            <a:ext cx="808" cy="540388"/>
-          </a:xfrm>
-          <a:prstGeom prst="straightConnector1">
-            <a:avLst/>
-          </a:prstGeom>
-          <a:ln>
-            <a:tailEnd type="triangle"/>
-          </a:ln>
-        </p:spPr>
-        <p:style>
-          <a:lnRef idx="2">
-            <a:schemeClr val="accent1"/>
-          </a:lnRef>
-          <a:fillRef idx="0">
-            <a:schemeClr val="accent1"/>
-          </a:fillRef>
-          <a:effectRef idx="1">
-            <a:schemeClr val="accent1"/>
-          </a:effectRef>
-          <a:fontRef idx="minor">
-            <a:schemeClr val="tx1"/>
-          </a:fontRef>
-        </p:style>
-      </p:cxnSp>
-      <p:cxnSp>
-        <p:nvCxnSpPr>
-          <p:cNvPr id="98" name="Connecteur droit avec flèche 97">
-            <a:extLst>
-              <a:ext uri="{FF2B5EF4-FFF2-40B4-BE49-F238E27FC236}">
-                <a16:creationId xmlns:a16="http://schemas.microsoft.com/office/drawing/2014/main" id="{7BCB47FE-A96F-A779-8CFA-879569F7F58B}"/>
-              </a:ext>
-            </a:extLst>
-          </p:cNvPr>
-          <p:cNvCxnSpPr>
-            <a:cxnSpLocks/>
-            <a:stCxn id="48" idx="2"/>
-            <a:endCxn id="8" idx="0"/>
-          </p:cNvCxnSpPr>
-          <p:nvPr/>
-        </p:nvCxnSpPr>
-        <p:spPr>
-          <a:xfrm>
-            <a:off x="6680297" y="4518239"/>
-            <a:ext cx="14121" cy="500906"/>
-          </a:xfrm>
-          <a:prstGeom prst="straightConnector1">
-            <a:avLst/>
-          </a:prstGeom>
-          <a:ln>
-            <a:tailEnd type="triangle"/>
-          </a:ln>
-        </p:spPr>
-        <p:style>
-          <a:lnRef idx="2">
-            <a:schemeClr val="accent1"/>
-          </a:lnRef>
-          <a:fillRef idx="0">
-            <a:schemeClr val="accent1"/>
-          </a:fillRef>
-          <a:effectRef idx="1">
-            <a:schemeClr val="accent1"/>
-          </a:effectRef>
-          <a:fontRef idx="minor">
-            <a:schemeClr val="tx1"/>
-          </a:fontRef>
-        </p:style>
-      </p:cxnSp>
       <p:sp>
         <p:nvSpPr>
           <p:cNvPr id="2" name="Rectangle 1">
@@ -8254,8 +8971,8 @@
         </p:nvSpPr>
         <p:spPr>
           <a:xfrm rot="5400000">
-            <a:off x="5444907" y="3011597"/>
-            <a:ext cx="2464938" cy="749385"/>
+            <a:off x="5175889" y="3280614"/>
+            <a:ext cx="3002973" cy="749385"/>
           </a:xfrm>
           <a:prstGeom prst="rect">
             <a:avLst/>
@@ -8306,8 +9023,8 @@
         </p:nvSpPr>
         <p:spPr>
           <a:xfrm rot="5400000">
-            <a:off x="4461271" y="3028425"/>
-            <a:ext cx="2464938" cy="749385"/>
+            <a:off x="4192253" y="3297443"/>
+            <a:ext cx="3002974" cy="749385"/>
           </a:xfrm>
           <a:prstGeom prst="rect">
             <a:avLst/>
@@ -8358,8 +9075,8 @@
         </p:nvSpPr>
         <p:spPr>
           <a:xfrm rot="5400000">
-            <a:off x="3436029" y="3042275"/>
-            <a:ext cx="2464938" cy="749385"/>
+            <a:off x="3167011" y="3311293"/>
+            <a:ext cx="3002974" cy="749385"/>
           </a:xfrm>
           <a:prstGeom prst="rect">
             <a:avLst/>
@@ -8396,120 +9113,900 @@
           </a:p>
         </p:txBody>
       </p:sp>
+      <p:grpSp>
+        <p:nvGrpSpPr>
+          <p:cNvPr id="37" name="Groupe 36">
+            <a:extLst>
+              <a:ext uri="{FF2B5EF4-FFF2-40B4-BE49-F238E27FC236}">
+                <a16:creationId xmlns:a16="http://schemas.microsoft.com/office/drawing/2014/main" id="{4AB7B073-6858-14DE-BF95-FC9FA47EC3C9}"/>
+              </a:ext>
+            </a:extLst>
+          </p:cNvPr>
+          <p:cNvGrpSpPr/>
+          <p:nvPr/>
+        </p:nvGrpSpPr>
+        <p:grpSpPr>
+          <a:xfrm>
+            <a:off x="4637902" y="4544064"/>
+            <a:ext cx="335395" cy="1047670"/>
+            <a:chOff x="4637902" y="4544064"/>
+            <a:chExt cx="335395" cy="1047670"/>
+          </a:xfrm>
+        </p:grpSpPr>
+        <p:cxnSp>
+          <p:nvCxnSpPr>
+            <p:cNvPr id="91" name="Connecteur droit avec flèche 90">
+              <a:extLst>
+                <a:ext uri="{FF2B5EF4-FFF2-40B4-BE49-F238E27FC236}">
+                  <a16:creationId xmlns:a16="http://schemas.microsoft.com/office/drawing/2014/main" id="{8954D60D-B53F-4DEC-ECF3-EC87FD125A0E}"/>
+                </a:ext>
+              </a:extLst>
+            </p:cNvPr>
+            <p:cNvCxnSpPr>
+              <a:cxnSpLocks/>
+              <a:stCxn id="51" idx="2"/>
+              <a:endCxn id="13" idx="2"/>
+            </p:cNvCxnSpPr>
+            <p:nvPr/>
+          </p:nvCxnSpPr>
+          <p:spPr>
+            <a:xfrm flipH="1">
+              <a:off x="4637902" y="4544064"/>
+              <a:ext cx="18529" cy="505661"/>
+            </a:xfrm>
+            <a:prstGeom prst="straightConnector1">
+              <a:avLst/>
+            </a:prstGeom>
+            <a:ln>
+              <a:tailEnd type="triangle"/>
+            </a:ln>
+          </p:spPr>
+          <p:style>
+            <a:lnRef idx="2">
+              <a:schemeClr val="accent1"/>
+            </a:lnRef>
+            <a:fillRef idx="0">
+              <a:schemeClr val="accent1"/>
+            </a:fillRef>
+            <a:effectRef idx="1">
+              <a:schemeClr val="accent1"/>
+            </a:effectRef>
+            <a:fontRef idx="minor">
+              <a:schemeClr val="tx1"/>
+            </a:fontRef>
+          </p:style>
+        </p:cxnSp>
+        <p:sp>
+          <p:nvSpPr>
+            <p:cNvPr id="13" name="Forme libre 12">
+              <a:extLst>
+                <a:ext uri="{FF2B5EF4-FFF2-40B4-BE49-F238E27FC236}">
+                  <a16:creationId xmlns:a16="http://schemas.microsoft.com/office/drawing/2014/main" id="{A8474AC5-494B-3901-A198-3446594B583A}"/>
+                </a:ext>
+              </a:extLst>
+            </p:cNvPr>
+            <p:cNvSpPr/>
+            <p:nvPr/>
+          </p:nvSpPr>
+          <p:spPr>
+            <a:xfrm rot="16557881" flipV="1">
+              <a:off x="4558058" y="4745124"/>
+              <a:ext cx="443103" cy="281376"/>
+            </a:xfrm>
+            <a:custGeom>
+              <a:avLst/>
+              <a:gdLst>
+                <a:gd name="csX0" fmla="*/ 112238 w 920336"/>
+                <a:gd name="csY0" fmla="*/ 0 h 497502"/>
+                <a:gd name="csX1" fmla="*/ 920313 w 920336"/>
+                <a:gd name="csY1" fmla="*/ 159488 h 497502"/>
+                <a:gd name="csX2" fmla="*/ 90973 w 920336"/>
+                <a:gd name="csY2" fmla="*/ 467832 h 497502"/>
+                <a:gd name="csX3" fmla="*/ 59075 w 920336"/>
+                <a:gd name="csY3" fmla="*/ 467832 h 497502"/>
+              </a:gdLst>
+              <a:ahLst/>
+              <a:cxnLst>
+                <a:cxn ang="0">
+                  <a:pos x="csX0" y="csY0"/>
+                </a:cxn>
+                <a:cxn ang="0">
+                  <a:pos x="csX1" y="csY1"/>
+                </a:cxn>
+                <a:cxn ang="0">
+                  <a:pos x="csX2" y="csY2"/>
+                </a:cxn>
+                <a:cxn ang="0">
+                  <a:pos x="csX3" y="csY3"/>
+                </a:cxn>
+              </a:cxnLst>
+              <a:rect l="l" t="t" r="r" b="b"/>
+              <a:pathLst>
+                <a:path w="920336" h="497502">
+                  <a:moveTo>
+                    <a:pt x="112238" y="0"/>
+                  </a:moveTo>
+                  <a:cubicBezTo>
+                    <a:pt x="518047" y="40758"/>
+                    <a:pt x="923857" y="81516"/>
+                    <a:pt x="920313" y="159488"/>
+                  </a:cubicBezTo>
+                  <a:cubicBezTo>
+                    <a:pt x="916769" y="237460"/>
+                    <a:pt x="234513" y="416441"/>
+                    <a:pt x="90973" y="467832"/>
+                  </a:cubicBezTo>
+                  <a:cubicBezTo>
+                    <a:pt x="-52567" y="519223"/>
+                    <a:pt x="3254" y="493527"/>
+                    <a:pt x="59075" y="467832"/>
+                  </a:cubicBezTo>
+                </a:path>
+              </a:pathLst>
+            </a:custGeom>
+            <a:solidFill>
+              <a:schemeClr val="bg2">
+                <a:lumMod val="90000"/>
+              </a:schemeClr>
+            </a:solidFill>
+          </p:spPr>
+          <p:style>
+            <a:lnRef idx="2">
+              <a:schemeClr val="accent1">
+                <a:shade val="15000"/>
+              </a:schemeClr>
+            </a:lnRef>
+            <a:fillRef idx="1">
+              <a:schemeClr val="accent1"/>
+            </a:fillRef>
+            <a:effectRef idx="0">
+              <a:schemeClr val="accent1"/>
+            </a:effectRef>
+            <a:fontRef idx="minor">
+              <a:schemeClr val="lt1"/>
+            </a:fontRef>
+          </p:style>
+          <p:txBody>
+            <a:bodyPr rtlCol="0" anchor="ctr"/>
+            <a:lstStyle/>
+            <a:p>
+              <a:pPr algn="ctr"/>
+              <a:endParaRPr lang="fr-FR" dirty="0"/>
+            </a:p>
+          </p:txBody>
+        </p:sp>
+        <p:sp>
+          <p:nvSpPr>
+            <p:cNvPr id="27" name="Ellipse 26">
+              <a:extLst>
+                <a:ext uri="{FF2B5EF4-FFF2-40B4-BE49-F238E27FC236}">
+                  <a16:creationId xmlns:a16="http://schemas.microsoft.com/office/drawing/2014/main" id="{4FAB9963-0637-2071-CB7B-1BC8EECFCA3C}"/>
+                </a:ext>
+              </a:extLst>
+            </p:cNvPr>
+            <p:cNvSpPr/>
+            <p:nvPr/>
+          </p:nvSpPr>
+          <p:spPr>
+            <a:xfrm>
+              <a:off x="4814787" y="4735556"/>
+              <a:ext cx="148856" cy="148856"/>
+            </a:xfrm>
+            <a:prstGeom prst="ellipse">
+              <a:avLst/>
+            </a:prstGeom>
+            <a:solidFill>
+              <a:schemeClr val="bg1">
+                <a:lumMod val="50000"/>
+              </a:schemeClr>
+            </a:solidFill>
+          </p:spPr>
+          <p:style>
+            <a:lnRef idx="2">
+              <a:schemeClr val="accent1">
+                <a:shade val="15000"/>
+              </a:schemeClr>
+            </a:lnRef>
+            <a:fillRef idx="1">
+              <a:schemeClr val="accent1"/>
+            </a:fillRef>
+            <a:effectRef idx="0">
+              <a:schemeClr val="accent1"/>
+            </a:effectRef>
+            <a:fontRef idx="minor">
+              <a:schemeClr val="lt1"/>
+            </a:fontRef>
+          </p:style>
+          <p:txBody>
+            <a:bodyPr rtlCol="0" anchor="ctr"/>
+            <a:lstStyle/>
+            <a:p>
+              <a:pPr algn="ctr"/>
+              <a:endParaRPr lang="fr-FR"/>
+            </a:p>
+          </p:txBody>
+        </p:sp>
+        <p:cxnSp>
+          <p:nvCxnSpPr>
+            <p:cNvPr id="29" name="Connecteur droit avec flèche 28">
+              <a:extLst>
+                <a:ext uri="{FF2B5EF4-FFF2-40B4-BE49-F238E27FC236}">
+                  <a16:creationId xmlns:a16="http://schemas.microsoft.com/office/drawing/2014/main" id="{A36B294F-AD05-8FFC-1EA1-AFEBC04222B4}"/>
+                </a:ext>
+              </a:extLst>
+            </p:cNvPr>
+            <p:cNvCxnSpPr>
+              <a:cxnSpLocks/>
+              <a:stCxn id="27" idx="6"/>
+              <a:endCxn id="6" idx="0"/>
+            </p:cNvCxnSpPr>
+            <p:nvPr/>
+          </p:nvCxnSpPr>
+          <p:spPr>
+            <a:xfrm>
+              <a:off x="4963643" y="4809984"/>
+              <a:ext cx="9654" cy="781750"/>
+            </a:xfrm>
+            <a:prstGeom prst="straightConnector1">
+              <a:avLst/>
+            </a:prstGeom>
+            <a:ln>
+              <a:tailEnd type="triangle"/>
+            </a:ln>
+          </p:spPr>
+          <p:style>
+            <a:lnRef idx="2">
+              <a:schemeClr val="accent1"/>
+            </a:lnRef>
+            <a:fillRef idx="0">
+              <a:schemeClr val="accent1"/>
+            </a:fillRef>
+            <a:effectRef idx="1">
+              <a:schemeClr val="accent1"/>
+            </a:effectRef>
+            <a:fontRef idx="minor">
+              <a:schemeClr val="tx1"/>
+            </a:fontRef>
+          </p:style>
+        </p:cxnSp>
+      </p:grpSp>
+      <p:grpSp>
+        <p:nvGrpSpPr>
+          <p:cNvPr id="38" name="Groupe 37">
+            <a:extLst>
+              <a:ext uri="{FF2B5EF4-FFF2-40B4-BE49-F238E27FC236}">
+                <a16:creationId xmlns:a16="http://schemas.microsoft.com/office/drawing/2014/main" id="{835DC64B-CDA4-6C13-D08E-E46FD8C69BC1}"/>
+              </a:ext>
+            </a:extLst>
+          </p:cNvPr>
+          <p:cNvGrpSpPr/>
+          <p:nvPr/>
+        </p:nvGrpSpPr>
+        <p:grpSpPr>
+          <a:xfrm>
+            <a:off x="5675040" y="4525890"/>
+            <a:ext cx="335395" cy="1047670"/>
+            <a:chOff x="4637902" y="4544064"/>
+            <a:chExt cx="335395" cy="1047670"/>
+          </a:xfrm>
+        </p:grpSpPr>
+        <p:cxnSp>
+          <p:nvCxnSpPr>
+            <p:cNvPr id="39" name="Connecteur droit avec flèche 38">
+              <a:extLst>
+                <a:ext uri="{FF2B5EF4-FFF2-40B4-BE49-F238E27FC236}">
+                  <a16:creationId xmlns:a16="http://schemas.microsoft.com/office/drawing/2014/main" id="{86CDFB1F-A7D7-CE60-B656-66C3426B83BB}"/>
+                </a:ext>
+              </a:extLst>
+            </p:cNvPr>
+            <p:cNvCxnSpPr>
+              <a:cxnSpLocks/>
+              <a:endCxn id="40" idx="2"/>
+            </p:cNvCxnSpPr>
+            <p:nvPr/>
+          </p:nvCxnSpPr>
+          <p:spPr>
+            <a:xfrm flipH="1">
+              <a:off x="4637902" y="4544064"/>
+              <a:ext cx="18529" cy="505661"/>
+            </a:xfrm>
+            <a:prstGeom prst="straightConnector1">
+              <a:avLst/>
+            </a:prstGeom>
+            <a:ln>
+              <a:tailEnd type="triangle"/>
+            </a:ln>
+          </p:spPr>
+          <p:style>
+            <a:lnRef idx="2">
+              <a:schemeClr val="accent1"/>
+            </a:lnRef>
+            <a:fillRef idx="0">
+              <a:schemeClr val="accent1"/>
+            </a:fillRef>
+            <a:effectRef idx="1">
+              <a:schemeClr val="accent1"/>
+            </a:effectRef>
+            <a:fontRef idx="minor">
+              <a:schemeClr val="tx1"/>
+            </a:fontRef>
+          </p:style>
+        </p:cxnSp>
+        <p:sp>
+          <p:nvSpPr>
+            <p:cNvPr id="40" name="Forme libre 39">
+              <a:extLst>
+                <a:ext uri="{FF2B5EF4-FFF2-40B4-BE49-F238E27FC236}">
+                  <a16:creationId xmlns:a16="http://schemas.microsoft.com/office/drawing/2014/main" id="{BAA56D60-0193-E335-D67C-507A885C52C8}"/>
+                </a:ext>
+              </a:extLst>
+            </p:cNvPr>
+            <p:cNvSpPr/>
+            <p:nvPr/>
+          </p:nvSpPr>
+          <p:spPr>
+            <a:xfrm rot="16557881" flipV="1">
+              <a:off x="4558058" y="4745124"/>
+              <a:ext cx="443103" cy="281376"/>
+            </a:xfrm>
+            <a:custGeom>
+              <a:avLst/>
+              <a:gdLst>
+                <a:gd name="csX0" fmla="*/ 112238 w 920336"/>
+                <a:gd name="csY0" fmla="*/ 0 h 497502"/>
+                <a:gd name="csX1" fmla="*/ 920313 w 920336"/>
+                <a:gd name="csY1" fmla="*/ 159488 h 497502"/>
+                <a:gd name="csX2" fmla="*/ 90973 w 920336"/>
+                <a:gd name="csY2" fmla="*/ 467832 h 497502"/>
+                <a:gd name="csX3" fmla="*/ 59075 w 920336"/>
+                <a:gd name="csY3" fmla="*/ 467832 h 497502"/>
+              </a:gdLst>
+              <a:ahLst/>
+              <a:cxnLst>
+                <a:cxn ang="0">
+                  <a:pos x="csX0" y="csY0"/>
+                </a:cxn>
+                <a:cxn ang="0">
+                  <a:pos x="csX1" y="csY1"/>
+                </a:cxn>
+                <a:cxn ang="0">
+                  <a:pos x="csX2" y="csY2"/>
+                </a:cxn>
+                <a:cxn ang="0">
+                  <a:pos x="csX3" y="csY3"/>
+                </a:cxn>
+              </a:cxnLst>
+              <a:rect l="l" t="t" r="r" b="b"/>
+              <a:pathLst>
+                <a:path w="920336" h="497502">
+                  <a:moveTo>
+                    <a:pt x="112238" y="0"/>
+                  </a:moveTo>
+                  <a:cubicBezTo>
+                    <a:pt x="518047" y="40758"/>
+                    <a:pt x="923857" y="81516"/>
+                    <a:pt x="920313" y="159488"/>
+                  </a:cubicBezTo>
+                  <a:cubicBezTo>
+                    <a:pt x="916769" y="237460"/>
+                    <a:pt x="234513" y="416441"/>
+                    <a:pt x="90973" y="467832"/>
+                  </a:cubicBezTo>
+                  <a:cubicBezTo>
+                    <a:pt x="-52567" y="519223"/>
+                    <a:pt x="3254" y="493527"/>
+                    <a:pt x="59075" y="467832"/>
+                  </a:cubicBezTo>
+                </a:path>
+              </a:pathLst>
+            </a:custGeom>
+            <a:solidFill>
+              <a:schemeClr val="bg2">
+                <a:lumMod val="90000"/>
+              </a:schemeClr>
+            </a:solidFill>
+          </p:spPr>
+          <p:style>
+            <a:lnRef idx="2">
+              <a:schemeClr val="accent1">
+                <a:shade val="15000"/>
+              </a:schemeClr>
+            </a:lnRef>
+            <a:fillRef idx="1">
+              <a:schemeClr val="accent1"/>
+            </a:fillRef>
+            <a:effectRef idx="0">
+              <a:schemeClr val="accent1"/>
+            </a:effectRef>
+            <a:fontRef idx="minor">
+              <a:schemeClr val="lt1"/>
+            </a:fontRef>
+          </p:style>
+          <p:txBody>
+            <a:bodyPr rtlCol="0" anchor="ctr"/>
+            <a:lstStyle/>
+            <a:p>
+              <a:pPr algn="ctr"/>
+              <a:endParaRPr lang="fr-FR" dirty="0"/>
+            </a:p>
+          </p:txBody>
+        </p:sp>
+        <p:sp>
+          <p:nvSpPr>
+            <p:cNvPr id="42" name="Ellipse 41">
+              <a:extLst>
+                <a:ext uri="{FF2B5EF4-FFF2-40B4-BE49-F238E27FC236}">
+                  <a16:creationId xmlns:a16="http://schemas.microsoft.com/office/drawing/2014/main" id="{DE271112-6A7B-566B-197B-8ACAD589205B}"/>
+                </a:ext>
+              </a:extLst>
+            </p:cNvPr>
+            <p:cNvSpPr/>
+            <p:nvPr/>
+          </p:nvSpPr>
+          <p:spPr>
+            <a:xfrm>
+              <a:off x="4814787" y="4735556"/>
+              <a:ext cx="148856" cy="148856"/>
+            </a:xfrm>
+            <a:prstGeom prst="ellipse">
+              <a:avLst/>
+            </a:prstGeom>
+            <a:solidFill>
+              <a:schemeClr val="bg1">
+                <a:lumMod val="50000"/>
+              </a:schemeClr>
+            </a:solidFill>
+          </p:spPr>
+          <p:style>
+            <a:lnRef idx="2">
+              <a:schemeClr val="accent1">
+                <a:shade val="15000"/>
+              </a:schemeClr>
+            </a:lnRef>
+            <a:fillRef idx="1">
+              <a:schemeClr val="accent1"/>
+            </a:fillRef>
+            <a:effectRef idx="0">
+              <a:schemeClr val="accent1"/>
+            </a:effectRef>
+            <a:fontRef idx="minor">
+              <a:schemeClr val="lt1"/>
+            </a:fontRef>
+          </p:style>
+          <p:txBody>
+            <a:bodyPr rtlCol="0" anchor="ctr"/>
+            <a:lstStyle/>
+            <a:p>
+              <a:pPr algn="ctr"/>
+              <a:endParaRPr lang="fr-FR"/>
+            </a:p>
+          </p:txBody>
+        </p:sp>
+        <p:cxnSp>
+          <p:nvCxnSpPr>
+            <p:cNvPr id="44" name="Connecteur droit avec flèche 43">
+              <a:extLst>
+                <a:ext uri="{FF2B5EF4-FFF2-40B4-BE49-F238E27FC236}">
+                  <a16:creationId xmlns:a16="http://schemas.microsoft.com/office/drawing/2014/main" id="{1EFEB250-C9A5-5B5C-A3FD-2C90AB7DA3E0}"/>
+                </a:ext>
+              </a:extLst>
+            </p:cNvPr>
+            <p:cNvCxnSpPr>
+              <a:cxnSpLocks/>
+              <a:stCxn id="42" idx="6"/>
+            </p:cNvCxnSpPr>
+            <p:nvPr/>
+          </p:nvCxnSpPr>
+          <p:spPr>
+            <a:xfrm>
+              <a:off x="4963643" y="4809984"/>
+              <a:ext cx="9654" cy="781750"/>
+            </a:xfrm>
+            <a:prstGeom prst="straightConnector1">
+              <a:avLst/>
+            </a:prstGeom>
+            <a:ln>
+              <a:tailEnd type="triangle"/>
+            </a:ln>
+          </p:spPr>
+          <p:style>
+            <a:lnRef idx="2">
+              <a:schemeClr val="accent1"/>
+            </a:lnRef>
+            <a:fillRef idx="0">
+              <a:schemeClr val="accent1"/>
+            </a:fillRef>
+            <a:effectRef idx="1">
+              <a:schemeClr val="accent1"/>
+            </a:effectRef>
+            <a:fontRef idx="minor">
+              <a:schemeClr val="tx1"/>
+            </a:fontRef>
+          </p:style>
+        </p:cxnSp>
+      </p:grpSp>
+      <p:grpSp>
+        <p:nvGrpSpPr>
+          <p:cNvPr id="46" name="Groupe 45">
+            <a:extLst>
+              <a:ext uri="{FF2B5EF4-FFF2-40B4-BE49-F238E27FC236}">
+                <a16:creationId xmlns:a16="http://schemas.microsoft.com/office/drawing/2014/main" id="{78D13A88-F75C-4807-9A4E-85953CAC9073}"/>
+              </a:ext>
+            </a:extLst>
+          </p:cNvPr>
+          <p:cNvGrpSpPr/>
+          <p:nvPr/>
+        </p:nvGrpSpPr>
+        <p:grpSpPr>
+          <a:xfrm>
+            <a:off x="6653676" y="4518239"/>
+            <a:ext cx="335395" cy="1047670"/>
+            <a:chOff x="4637902" y="4544064"/>
+            <a:chExt cx="335395" cy="1047670"/>
+          </a:xfrm>
+        </p:grpSpPr>
+        <p:cxnSp>
+          <p:nvCxnSpPr>
+            <p:cNvPr id="56" name="Connecteur droit avec flèche 55">
+              <a:extLst>
+                <a:ext uri="{FF2B5EF4-FFF2-40B4-BE49-F238E27FC236}">
+                  <a16:creationId xmlns:a16="http://schemas.microsoft.com/office/drawing/2014/main" id="{9D18386D-2E2E-2F0B-4E8B-653FF52081AB}"/>
+                </a:ext>
+              </a:extLst>
+            </p:cNvPr>
+            <p:cNvCxnSpPr>
+              <a:cxnSpLocks/>
+              <a:endCxn id="57" idx="2"/>
+            </p:cNvCxnSpPr>
+            <p:nvPr/>
+          </p:nvCxnSpPr>
+          <p:spPr>
+            <a:xfrm flipH="1">
+              <a:off x="4637902" y="4544064"/>
+              <a:ext cx="18529" cy="505661"/>
+            </a:xfrm>
+            <a:prstGeom prst="straightConnector1">
+              <a:avLst/>
+            </a:prstGeom>
+            <a:ln>
+              <a:tailEnd type="triangle"/>
+            </a:ln>
+          </p:spPr>
+          <p:style>
+            <a:lnRef idx="2">
+              <a:schemeClr val="accent1"/>
+            </a:lnRef>
+            <a:fillRef idx="0">
+              <a:schemeClr val="accent1"/>
+            </a:fillRef>
+            <a:effectRef idx="1">
+              <a:schemeClr val="accent1"/>
+            </a:effectRef>
+            <a:fontRef idx="minor">
+              <a:schemeClr val="tx1"/>
+            </a:fontRef>
+          </p:style>
+        </p:cxnSp>
+        <p:sp>
+          <p:nvSpPr>
+            <p:cNvPr id="57" name="Forme libre 56">
+              <a:extLst>
+                <a:ext uri="{FF2B5EF4-FFF2-40B4-BE49-F238E27FC236}">
+                  <a16:creationId xmlns:a16="http://schemas.microsoft.com/office/drawing/2014/main" id="{63E150EE-2987-42CC-3F1E-B92726FCD950}"/>
+                </a:ext>
+              </a:extLst>
+            </p:cNvPr>
+            <p:cNvSpPr/>
+            <p:nvPr/>
+          </p:nvSpPr>
+          <p:spPr>
+            <a:xfrm rot="16557881" flipV="1">
+              <a:off x="4558058" y="4745124"/>
+              <a:ext cx="443103" cy="281376"/>
+            </a:xfrm>
+            <a:custGeom>
+              <a:avLst/>
+              <a:gdLst>
+                <a:gd name="csX0" fmla="*/ 112238 w 920336"/>
+                <a:gd name="csY0" fmla="*/ 0 h 497502"/>
+                <a:gd name="csX1" fmla="*/ 920313 w 920336"/>
+                <a:gd name="csY1" fmla="*/ 159488 h 497502"/>
+                <a:gd name="csX2" fmla="*/ 90973 w 920336"/>
+                <a:gd name="csY2" fmla="*/ 467832 h 497502"/>
+                <a:gd name="csX3" fmla="*/ 59075 w 920336"/>
+                <a:gd name="csY3" fmla="*/ 467832 h 497502"/>
+              </a:gdLst>
+              <a:ahLst/>
+              <a:cxnLst>
+                <a:cxn ang="0">
+                  <a:pos x="csX0" y="csY0"/>
+                </a:cxn>
+                <a:cxn ang="0">
+                  <a:pos x="csX1" y="csY1"/>
+                </a:cxn>
+                <a:cxn ang="0">
+                  <a:pos x="csX2" y="csY2"/>
+                </a:cxn>
+                <a:cxn ang="0">
+                  <a:pos x="csX3" y="csY3"/>
+                </a:cxn>
+              </a:cxnLst>
+              <a:rect l="l" t="t" r="r" b="b"/>
+              <a:pathLst>
+                <a:path w="920336" h="497502">
+                  <a:moveTo>
+                    <a:pt x="112238" y="0"/>
+                  </a:moveTo>
+                  <a:cubicBezTo>
+                    <a:pt x="518047" y="40758"/>
+                    <a:pt x="923857" y="81516"/>
+                    <a:pt x="920313" y="159488"/>
+                  </a:cubicBezTo>
+                  <a:cubicBezTo>
+                    <a:pt x="916769" y="237460"/>
+                    <a:pt x="234513" y="416441"/>
+                    <a:pt x="90973" y="467832"/>
+                  </a:cubicBezTo>
+                  <a:cubicBezTo>
+                    <a:pt x="-52567" y="519223"/>
+                    <a:pt x="3254" y="493527"/>
+                    <a:pt x="59075" y="467832"/>
+                  </a:cubicBezTo>
+                </a:path>
+              </a:pathLst>
+            </a:custGeom>
+            <a:solidFill>
+              <a:schemeClr val="bg2">
+                <a:lumMod val="90000"/>
+              </a:schemeClr>
+            </a:solidFill>
+          </p:spPr>
+          <p:style>
+            <a:lnRef idx="2">
+              <a:schemeClr val="accent1">
+                <a:shade val="15000"/>
+              </a:schemeClr>
+            </a:lnRef>
+            <a:fillRef idx="1">
+              <a:schemeClr val="accent1"/>
+            </a:fillRef>
+            <a:effectRef idx="0">
+              <a:schemeClr val="accent1"/>
+            </a:effectRef>
+            <a:fontRef idx="minor">
+              <a:schemeClr val="lt1"/>
+            </a:fontRef>
+          </p:style>
+          <p:txBody>
+            <a:bodyPr rtlCol="0" anchor="ctr"/>
+            <a:lstStyle/>
+            <a:p>
+              <a:pPr algn="ctr"/>
+              <a:endParaRPr lang="fr-FR" dirty="0"/>
+            </a:p>
+          </p:txBody>
+        </p:sp>
+        <p:sp>
+          <p:nvSpPr>
+            <p:cNvPr id="58" name="Ellipse 57">
+              <a:extLst>
+                <a:ext uri="{FF2B5EF4-FFF2-40B4-BE49-F238E27FC236}">
+                  <a16:creationId xmlns:a16="http://schemas.microsoft.com/office/drawing/2014/main" id="{F2ACC5CD-BA94-E920-AD61-AE287C17A807}"/>
+                </a:ext>
+              </a:extLst>
+            </p:cNvPr>
+            <p:cNvSpPr/>
+            <p:nvPr/>
+          </p:nvSpPr>
+          <p:spPr>
+            <a:xfrm>
+              <a:off x="4814787" y="4735556"/>
+              <a:ext cx="148856" cy="148856"/>
+            </a:xfrm>
+            <a:prstGeom prst="ellipse">
+              <a:avLst/>
+            </a:prstGeom>
+            <a:solidFill>
+              <a:schemeClr val="bg1">
+                <a:lumMod val="50000"/>
+              </a:schemeClr>
+            </a:solidFill>
+          </p:spPr>
+          <p:style>
+            <a:lnRef idx="2">
+              <a:schemeClr val="accent1">
+                <a:shade val="15000"/>
+              </a:schemeClr>
+            </a:lnRef>
+            <a:fillRef idx="1">
+              <a:schemeClr val="accent1"/>
+            </a:fillRef>
+            <a:effectRef idx="0">
+              <a:schemeClr val="accent1"/>
+            </a:effectRef>
+            <a:fontRef idx="minor">
+              <a:schemeClr val="lt1"/>
+            </a:fontRef>
+          </p:style>
+          <p:txBody>
+            <a:bodyPr rtlCol="0" anchor="ctr"/>
+            <a:lstStyle/>
+            <a:p>
+              <a:pPr algn="ctr"/>
+              <a:endParaRPr lang="fr-FR"/>
+            </a:p>
+          </p:txBody>
+        </p:sp>
+        <p:cxnSp>
+          <p:nvCxnSpPr>
+            <p:cNvPr id="59" name="Connecteur droit avec flèche 58">
+              <a:extLst>
+                <a:ext uri="{FF2B5EF4-FFF2-40B4-BE49-F238E27FC236}">
+                  <a16:creationId xmlns:a16="http://schemas.microsoft.com/office/drawing/2014/main" id="{B7EA82DC-662B-B502-7AA5-4C06323490E0}"/>
+                </a:ext>
+              </a:extLst>
+            </p:cNvPr>
+            <p:cNvCxnSpPr>
+              <a:cxnSpLocks/>
+              <a:stCxn id="58" idx="6"/>
+            </p:cNvCxnSpPr>
+            <p:nvPr/>
+          </p:nvCxnSpPr>
+          <p:spPr>
+            <a:xfrm>
+              <a:off x="4963643" y="4809984"/>
+              <a:ext cx="9654" cy="781750"/>
+            </a:xfrm>
+            <a:prstGeom prst="straightConnector1">
+              <a:avLst/>
+            </a:prstGeom>
+            <a:ln>
+              <a:tailEnd type="triangle"/>
+            </a:ln>
+          </p:spPr>
+          <p:style>
+            <a:lnRef idx="2">
+              <a:schemeClr val="accent1"/>
+            </a:lnRef>
+            <a:fillRef idx="0">
+              <a:schemeClr val="accent1"/>
+            </a:fillRef>
+            <a:effectRef idx="1">
+              <a:schemeClr val="accent1"/>
+            </a:effectRef>
+            <a:fontRef idx="minor">
+              <a:schemeClr val="tx1"/>
+            </a:fontRef>
+          </p:style>
+        </p:cxnSp>
+      </p:grpSp>
+      <p:sp>
+        <p:nvSpPr>
+          <p:cNvPr id="62" name="ZoneTexte 61">
+            <a:extLst>
+              <a:ext uri="{FF2B5EF4-FFF2-40B4-BE49-F238E27FC236}">
+                <a16:creationId xmlns:a16="http://schemas.microsoft.com/office/drawing/2014/main" id="{AC43A63D-0C25-DAB6-3C0E-8A16D0D3B64C}"/>
+              </a:ext>
+            </a:extLst>
+          </p:cNvPr>
+          <p:cNvSpPr txBox="1"/>
+          <p:nvPr/>
+        </p:nvSpPr>
+        <p:spPr>
+          <a:xfrm>
+            <a:off x="4358240" y="4617465"/>
+            <a:ext cx="341760" cy="276999"/>
+          </a:xfrm>
+          <a:prstGeom prst="rect">
+            <a:avLst/>
+          </a:prstGeom>
+          <a:solidFill>
+            <a:schemeClr val="bg1">
+              <a:lumMod val="95000"/>
+              <a:alpha val="69995"/>
+            </a:schemeClr>
+          </a:solidFill>
+        </p:spPr>
+        <p:txBody>
+          <a:bodyPr wrap="none" rtlCol="0">
+            <a:spAutoFit/>
+          </a:bodyPr>
+          <a:lstStyle/>
+          <a:p>
+            <a:r>
+              <a:rPr lang="fr-FR" sz="1200" dirty="0"/>
+              <a:t>s1</a:t>
+            </a:r>
+            <a:endParaRPr lang="fr-FR" dirty="0"/>
+          </a:p>
+        </p:txBody>
+      </p:sp>
+      <p:sp>
+        <p:nvSpPr>
+          <p:cNvPr id="63" name="ZoneTexte 62">
+            <a:extLst>
+              <a:ext uri="{FF2B5EF4-FFF2-40B4-BE49-F238E27FC236}">
+                <a16:creationId xmlns:a16="http://schemas.microsoft.com/office/drawing/2014/main" id="{3EFA1CC4-0790-F08E-EB84-5960585E48B1}"/>
+              </a:ext>
+            </a:extLst>
+          </p:cNvPr>
+          <p:cNvSpPr txBox="1"/>
+          <p:nvPr/>
+        </p:nvSpPr>
+        <p:spPr>
+          <a:xfrm>
+            <a:off x="5376790" y="4597056"/>
+            <a:ext cx="341760" cy="276999"/>
+          </a:xfrm>
+          <a:prstGeom prst="rect">
+            <a:avLst/>
+          </a:prstGeom>
+          <a:solidFill>
+            <a:schemeClr val="bg1">
+              <a:lumMod val="95000"/>
+              <a:alpha val="69995"/>
+            </a:schemeClr>
+          </a:solidFill>
+        </p:spPr>
+        <p:txBody>
+          <a:bodyPr wrap="none" rtlCol="0">
+            <a:spAutoFit/>
+          </a:bodyPr>
+          <a:lstStyle/>
+          <a:p>
+            <a:r>
+              <a:rPr lang="fr-FR" sz="1200" dirty="0"/>
+              <a:t>s2</a:t>
+            </a:r>
+            <a:endParaRPr lang="fr-FR" dirty="0"/>
+          </a:p>
+        </p:txBody>
+      </p:sp>
+      <p:sp>
+        <p:nvSpPr>
+          <p:cNvPr id="64" name="ZoneTexte 63">
+            <a:extLst>
+              <a:ext uri="{FF2B5EF4-FFF2-40B4-BE49-F238E27FC236}">
+                <a16:creationId xmlns:a16="http://schemas.microsoft.com/office/drawing/2014/main" id="{26437324-82E0-9DC3-7A4C-F34433641102}"/>
+              </a:ext>
+            </a:extLst>
+          </p:cNvPr>
+          <p:cNvSpPr txBox="1"/>
+          <p:nvPr/>
+        </p:nvSpPr>
+        <p:spPr>
+          <a:xfrm>
+            <a:off x="6345674" y="4597055"/>
+            <a:ext cx="341760" cy="276999"/>
+          </a:xfrm>
+          <a:prstGeom prst="rect">
+            <a:avLst/>
+          </a:prstGeom>
+          <a:solidFill>
+            <a:schemeClr val="bg1">
+              <a:lumMod val="95000"/>
+              <a:alpha val="69995"/>
+            </a:schemeClr>
+          </a:solidFill>
+        </p:spPr>
+        <p:txBody>
+          <a:bodyPr wrap="none" rtlCol="0">
+            <a:spAutoFit/>
+          </a:bodyPr>
+          <a:lstStyle/>
+          <a:p>
+            <a:r>
+              <a:rPr lang="fr-FR" sz="1200" dirty="0"/>
+              <a:t>s3</a:t>
+            </a:r>
+            <a:endParaRPr lang="fr-FR" dirty="0"/>
+          </a:p>
+        </p:txBody>
+      </p:sp>
     </p:spTree>
     <p:extLst>
       <p:ext uri="{BB962C8B-B14F-4D97-AF65-F5344CB8AC3E}">
         <p14:creationId xmlns:p14="http://schemas.microsoft.com/office/powerpoint/2010/main" val="2382523490"/>
-      </p:ext>
-    </p:extLst>
-  </p:cSld>
-  <p:clrMapOvr>
-    <a:masterClrMapping/>
-  </p:clrMapOvr>
-</p:sld>
-</file>
-
-<file path=ppt/slides/slide4.xml><?xml version="1.0" encoding="utf-8"?>
-<p:sld xmlns:a="http://schemas.openxmlformats.org/drawingml/2006/main" xmlns:r="http://schemas.openxmlformats.org/officeDocument/2006/relationships" xmlns:p="http://schemas.openxmlformats.org/presentationml/2006/main">
-  <p:cSld>
-    <p:spTree>
-      <p:nvGrpSpPr>
-        <p:cNvPr id="1" name=""/>
-        <p:cNvGrpSpPr/>
-        <p:nvPr/>
-      </p:nvGrpSpPr>
-      <p:grpSpPr>
-        <a:xfrm>
-          <a:off x="0" y="0"/>
-          <a:ext cx="0" cy="0"/>
-          <a:chOff x="0" y="0"/>
-          <a:chExt cx="0" cy="0"/>
-        </a:xfrm>
-      </p:grpSpPr>
-      <p:sp>
-        <p:nvSpPr>
-          <p:cNvPr id="2" name="Titre 1">
-            <a:extLst>
-              <a:ext uri="{FF2B5EF4-FFF2-40B4-BE49-F238E27FC236}">
-                <a16:creationId xmlns:a16="http://schemas.microsoft.com/office/drawing/2014/main" id="{F2B86EAC-284E-62EF-A1DD-75F70367B607}"/>
-              </a:ext>
-            </a:extLst>
-          </p:cNvPr>
-          <p:cNvSpPr>
-            <a:spLocks noGrp="1"/>
-          </p:cNvSpPr>
-          <p:nvPr>
-            <p:ph type="title"/>
-          </p:nvPr>
-        </p:nvSpPr>
-        <p:spPr/>
-        <p:txBody>
-          <a:bodyPr/>
-          <a:lstStyle/>
-          <a:p>
-            <a:endParaRPr lang="fr-FR"/>
-          </a:p>
-        </p:txBody>
-      </p:sp>
-      <p:sp>
-        <p:nvSpPr>
-          <p:cNvPr id="3" name="Espace réservé du contenu 2">
-            <a:extLst>
-              <a:ext uri="{FF2B5EF4-FFF2-40B4-BE49-F238E27FC236}">
-                <a16:creationId xmlns:a16="http://schemas.microsoft.com/office/drawing/2014/main" id="{FF90CE95-16DC-B6D8-3FDC-663FEA193625}"/>
-              </a:ext>
-            </a:extLst>
-          </p:cNvPr>
-          <p:cNvSpPr>
-            <a:spLocks noGrp="1"/>
-          </p:cNvSpPr>
-          <p:nvPr>
-            <p:ph idx="1"/>
-          </p:nvPr>
-        </p:nvSpPr>
-        <p:spPr/>
-        <p:txBody>
-          <a:bodyPr/>
-          <a:lstStyle/>
-          <a:p>
-            <a:endParaRPr lang="fr-FR"/>
-          </a:p>
-        </p:txBody>
-      </p:sp>
-      <p:pic>
-        <p:nvPicPr>
-          <p:cNvPr id="4" name="Image 3">
-            <a:extLst>
-              <a:ext uri="{FF2B5EF4-FFF2-40B4-BE49-F238E27FC236}">
-                <a16:creationId xmlns:a16="http://schemas.microsoft.com/office/drawing/2014/main" id="{E62E45A2-F502-7519-9DF8-B24A27A6AEDB}"/>
-              </a:ext>
-            </a:extLst>
-          </p:cNvPr>
-          <p:cNvPicPr>
-            <a:picLocks noChangeAspect="1"/>
-          </p:cNvPicPr>
-          <p:nvPr/>
-        </p:nvPicPr>
-        <p:blipFill>
-          <a:blip r:embed="rId2"/>
-          <a:stretch>
-            <a:fillRect/>
-          </a:stretch>
-        </p:blipFill>
-        <p:spPr>
-          <a:xfrm>
-            <a:off x="2609850" y="1504950"/>
-            <a:ext cx="6972300" cy="3848100"/>
-          </a:xfrm>
-          <a:prstGeom prst="rect">
-            <a:avLst/>
-          </a:prstGeom>
-        </p:spPr>
-      </p:pic>
-    </p:spTree>
-    <p:extLst>
-      <p:ext uri="{BB962C8B-B14F-4D97-AF65-F5344CB8AC3E}">
-        <p14:creationId xmlns:p14="http://schemas.microsoft.com/office/powerpoint/2010/main" val="667193975"/>
       </p:ext>
     </p:extLst>
   </p:cSld>
@@ -8541,7 +10038,7 @@
           <p:cNvPr id="2" name="Titre 1">
             <a:extLst>
               <a:ext uri="{FF2B5EF4-FFF2-40B4-BE49-F238E27FC236}">
-                <a16:creationId xmlns:a16="http://schemas.microsoft.com/office/drawing/2014/main" id="{98F86401-3D31-5798-8271-B8CBDE949B77}"/>
+                <a16:creationId xmlns:a16="http://schemas.microsoft.com/office/drawing/2014/main" id="{5821D36E-D723-6020-4C08-CF65079228BA}"/>
               </a:ext>
             </a:extLst>
           </p:cNvPr>
@@ -8557,32 +10054,10 @@
           <a:bodyPr/>
           <a:lstStyle/>
           <a:p>
-            <a:endParaRPr lang="fr-FR"/>
-          </a:p>
-        </p:txBody>
-      </p:sp>
-      <p:sp>
-        <p:nvSpPr>
-          <p:cNvPr id="3" name="Espace réservé du contenu 2">
-            <a:extLst>
-              <a:ext uri="{FF2B5EF4-FFF2-40B4-BE49-F238E27FC236}">
-                <a16:creationId xmlns:a16="http://schemas.microsoft.com/office/drawing/2014/main" id="{704FBE3E-697F-4FC8-E33A-FEEA0E9DDEF3}"/>
-              </a:ext>
-            </a:extLst>
-          </p:cNvPr>
-          <p:cNvSpPr>
-            <a:spLocks noGrp="1"/>
-          </p:cNvSpPr>
-          <p:nvPr>
-            <p:ph idx="1"/>
-          </p:nvPr>
-        </p:nvSpPr>
-        <p:spPr/>
-        <p:txBody>
-          <a:bodyPr/>
-          <a:lstStyle/>
-          <a:p>
-            <a:endParaRPr lang="fr-FR"/>
+            <a:r>
+              <a:rPr lang="fr-FR" dirty="0"/>
+              <a:t>IMG</a:t>
+            </a:r>
           </a:p>
         </p:txBody>
       </p:sp>
@@ -8591,7 +10066,7 @@
           <p:cNvPr id="4" name="Image 3">
             <a:extLst>
               <a:ext uri="{FF2B5EF4-FFF2-40B4-BE49-F238E27FC236}">
-                <a16:creationId xmlns:a16="http://schemas.microsoft.com/office/drawing/2014/main" id="{CA76F867-F921-85F4-CDF2-378D706D0434}"/>
+                <a16:creationId xmlns:a16="http://schemas.microsoft.com/office/drawing/2014/main" id="{65F5B00E-5CC0-1E6E-67AC-7AE590B137A7}"/>
               </a:ext>
             </a:extLst>
           </p:cNvPr>
@@ -8608,8 +10083,8 @@
         </p:blipFill>
         <p:spPr>
           <a:xfrm>
-            <a:off x="3777096" y="1825625"/>
-            <a:ext cx="5524500" cy="3746500"/>
+            <a:off x="3381270" y="801976"/>
+            <a:ext cx="5429460" cy="5254047"/>
           </a:xfrm>
           <a:prstGeom prst="rect">
             <a:avLst/>
@@ -8619,7 +10094,145 @@
     </p:spTree>
     <p:extLst>
       <p:ext uri="{BB962C8B-B14F-4D97-AF65-F5344CB8AC3E}">
-        <p14:creationId xmlns:p14="http://schemas.microsoft.com/office/powerpoint/2010/main" val="3465204386"/>
+        <p14:creationId xmlns:p14="http://schemas.microsoft.com/office/powerpoint/2010/main" val="4223447744"/>
+      </p:ext>
+    </p:extLst>
+  </p:cSld>
+  <p:clrMapOvr>
+    <a:masterClrMapping/>
+  </p:clrMapOvr>
+</p:sld>
+</file>
+
+<file path=ppt/slides/slide6.xml><?xml version="1.0" encoding="utf-8"?>
+<p:sld xmlns:a="http://schemas.openxmlformats.org/drawingml/2006/main" xmlns:r="http://schemas.openxmlformats.org/officeDocument/2006/relationships" xmlns:p="http://schemas.openxmlformats.org/presentationml/2006/main">
+  <p:cSld>
+    <p:spTree>
+      <p:nvGrpSpPr>
+        <p:cNvPr id="1" name=""/>
+        <p:cNvGrpSpPr/>
+        <p:nvPr/>
+      </p:nvGrpSpPr>
+      <p:grpSpPr>
+        <a:xfrm>
+          <a:off x="0" y="0"/>
+          <a:ext cx="0" cy="0"/>
+          <a:chOff x="0" y="0"/>
+          <a:chExt cx="0" cy="0"/>
+        </a:xfrm>
+      </p:grpSpPr>
+      <p:pic>
+        <p:nvPicPr>
+          <p:cNvPr id="4" name="Image 3">
+            <a:extLst>
+              <a:ext uri="{FF2B5EF4-FFF2-40B4-BE49-F238E27FC236}">
+                <a16:creationId xmlns:a16="http://schemas.microsoft.com/office/drawing/2014/main" id="{09709716-A6C0-9D4C-E60A-F1C8C940C702}"/>
+              </a:ext>
+            </a:extLst>
+          </p:cNvPr>
+          <p:cNvPicPr>
+            <a:picLocks noChangeAspect="1"/>
+          </p:cNvPicPr>
+          <p:nvPr/>
+        </p:nvPicPr>
+        <p:blipFill>
+          <a:blip r:embed="rId2"/>
+          <a:stretch>
+            <a:fillRect/>
+          </a:stretch>
+        </p:blipFill>
+        <p:spPr>
+          <a:xfrm>
+            <a:off x="915232" y="571188"/>
+            <a:ext cx="3556000" cy="3467100"/>
+          </a:xfrm>
+          <a:prstGeom prst="rect">
+            <a:avLst/>
+          </a:prstGeom>
+        </p:spPr>
+      </p:pic>
+      <p:sp>
+        <p:nvSpPr>
+          <p:cNvPr id="8" name="ZoneTexte 7">
+            <a:extLst>
+              <a:ext uri="{FF2B5EF4-FFF2-40B4-BE49-F238E27FC236}">
+                <a16:creationId xmlns:a16="http://schemas.microsoft.com/office/drawing/2014/main" id="{00F565E3-3AB9-EAC3-0864-A1AEE9B66E32}"/>
+              </a:ext>
+            </a:extLst>
+          </p:cNvPr>
+          <p:cNvSpPr txBox="1"/>
+          <p:nvPr/>
+        </p:nvSpPr>
+        <p:spPr>
+          <a:xfrm>
+            <a:off x="443518" y="4409105"/>
+            <a:ext cx="4748968" cy="369332"/>
+          </a:xfrm>
+          <a:prstGeom prst="rect">
+            <a:avLst/>
+          </a:prstGeom>
+          <a:noFill/>
+        </p:spPr>
+        <p:txBody>
+          <a:bodyPr wrap="square">
+            <a:spAutoFit/>
+          </a:bodyPr>
+          <a:lstStyle/>
+          <a:p>
+            <a:r>
+              <a:rPr lang="fr-FR" dirty="0"/>
+              <a:t>https://</a:t>
+            </a:r>
+            <a:r>
+              <a:rPr lang="fr-FR" dirty="0" err="1"/>
+              <a:t>www.youtube.com</a:t>
+            </a:r>
+            <a:r>
+              <a:rPr lang="fr-FR" dirty="0"/>
+              <a:t>/shorts/</a:t>
+            </a:r>
+            <a:r>
+              <a:rPr lang="fr-FR" dirty="0" err="1"/>
+              <a:t>HdiKxlBJLbE</a:t>
+            </a:r>
+            <a:endParaRPr lang="fr-FR" dirty="0"/>
+          </a:p>
+        </p:txBody>
+      </p:sp>
+      <p:pic>
+        <p:nvPicPr>
+          <p:cNvPr id="9" name="Image 8">
+            <a:extLst>
+              <a:ext uri="{FF2B5EF4-FFF2-40B4-BE49-F238E27FC236}">
+                <a16:creationId xmlns:a16="http://schemas.microsoft.com/office/drawing/2014/main" id="{EB0F75B3-FD40-913A-1FED-C0BF03B4DD0B}"/>
+              </a:ext>
+            </a:extLst>
+          </p:cNvPr>
+          <p:cNvPicPr>
+            <a:picLocks noChangeAspect="1"/>
+          </p:cNvPicPr>
+          <p:nvPr/>
+        </p:nvPicPr>
+        <p:blipFill>
+          <a:blip r:embed="rId3"/>
+          <a:stretch>
+            <a:fillRect/>
+          </a:stretch>
+        </p:blipFill>
+        <p:spPr>
+          <a:xfrm>
+            <a:off x="5283200" y="571188"/>
+            <a:ext cx="6908800" cy="5778500"/>
+          </a:xfrm>
+          <a:prstGeom prst="rect">
+            <a:avLst/>
+          </a:prstGeom>
+        </p:spPr>
+      </p:pic>
+    </p:spTree>
+    <p:extLst>
+      <p:ext uri="{BB962C8B-B14F-4D97-AF65-F5344CB8AC3E}">
+        <p14:creationId xmlns:p14="http://schemas.microsoft.com/office/powerpoint/2010/main" val="1130015292"/>
       </p:ext>
     </p:extLst>
   </p:cSld>

</xml_diff>